<commit_message>
Security briefing: data table covers activity history, overviews and dormant list
Co-Authored-By: Claude Fable 5.1 <noreply@anthropic.com>
</commit_message>
<xml_diff>
--- a/PQ_Report_Generator_Security_Briefing.pptx
+++ b/PQ_Report_Generator_Security_Briefing.pptx
@@ -5420,7 +5420,7 @@
                           <a:ea typeface="Calibri" pitchFamily="34" charset="-122"/>
                           <a:cs typeface="Calibri" pitchFamily="34" charset="-120"/>
                         </a:rPr>
-                        <a:t>Rolling staff &amp; device error history (24 months)</a:t>
+                        <a:t>Rolling staff, device error &amp; device activity history (24-36 months)</a:t>
                       </a:r>
                       <a:endParaRPr lang="en-US" sz="1300" dirty="0">
                         <a:latin typeface="Calibri" charset="0"/>
@@ -5814,7 +5814,7 @@
                           <a:ea typeface="Calibri" pitchFamily="34" charset="-122"/>
                           <a:cs typeface="Calibri" pitchFamily="34" charset="-120"/>
                         </a:rPr>
-                        <a:t>Generated Word reports</a:t>
+                        <a:t>Generated Word reports, site &amp; area overviews, dormant-analyser list (overviews and list are device-level: no staff names)</a:t>
                       </a:r>
                       <a:endParaRPr lang="en-US" sz="1300" dirty="0">
                         <a:latin typeface="Calibri" charset="0"/>
@@ -5879,7 +5879,7 @@
                           <a:ea typeface="Calibri" pitchFamily="34" charset="-122"/>
                           <a:cs typeface="Calibri" pitchFamily="34" charset="-120"/>
                         </a:rPr>
-                        <a:t>Reports\iSTAT\&lt;YYYY-MM Month&gt;\</a:t>
+                        <a:t>Reports\iSTAT\ and Reports\ABL\ by month</a:t>
                       </a:r>
                       <a:endParaRPr lang="en-US" sz="1300" dirty="0">
                         <a:latin typeface="Calibri" charset="0"/>

</xml_diff>

<commit_message>
PC enrolment: bundle runs only on enrolled, motherboard-bound PCs
- pq_enrolment.py at the bundle root: machine ID from system UUID, board
  serial, drive serial and hostname; enrolment password (PBKDF2 600k) guards
  an Ed25519 signing key; enrolled_pcs.json entries are signed and verified
  at every launch; 12-month term with 30-day notice; networked PCs need an
  explicit confirmation; enrolment_audit.log records every launch,
  enrolment, renewal, revocation and failed password
- portal: enrolment card, /enrol_status, /enrol, /enrolled (list + revoke)
- both engines: before_request lock page unless this PC is enrolled
- VERSION file (2026.09.27) recorded with each enrolment
- Robina (GoCo_Robina) added to per-device sites
- READMEs and both decks describe the control and its stated limits

Co-Authored-By: Claude Fable 5.1 <noreply@anthropic.com>
</commit_message>
<xml_diff>
--- a/PQ_Report_Generator_Security_Briefing.pptx
+++ b/PQ_Report_Generator_Security_Briefing.pptx
@@ -12,6 +12,7 @@
     <p:sldId id="260" r:id="rId6"/>
     <p:sldId id="261" r:id="rId7"/>
     <p:sldId id="262" r:id="rId8"/>
+    <p:sldId id="267" r:id="rId18"/>
     <p:sldId id="263" r:id="rId9"/>
     <p:sldId id="264" r:id="rId10"/>
     <p:sldId id="265" r:id="rId11"/>
@@ -2227,6 +2228,668 @@
 </file>
 
 <file path=ppt/slides/slide10.xml><?xml version="1.0" encoding="utf-8"?>
+<p:sld xmlns:a="http://schemas.openxmlformats.org/drawingml/2006/main" xmlns:r="http://schemas.openxmlformats.org/officeDocument/2006/relationships" xmlns:p="http://schemas.openxmlformats.org/presentationml/2006/main">
+  <p:cSld name="Slide 9">
+    <p:bg>
+      <p:bgPr>
+        <a:solidFill>
+          <a:srgbClr val="FFFFFF"/>
+        </a:solidFill>
+      </p:bgPr>
+    </p:bg>
+    <p:spTree>
+      <p:nvGrpSpPr>
+        <p:cNvPr id="1" name=""/>
+        <p:cNvGrpSpPr/>
+        <p:nvPr/>
+      </p:nvGrpSpPr>
+      <p:grpSpPr>
+        <a:xfrm>
+          <a:off x="0" y="0"/>
+          <a:ext cx="0" cy="0"/>
+          <a:chOff x="0" y="0"/>
+          <a:chExt cx="0" cy="0"/>
+        </a:xfrm>
+      </p:grpSpPr>
+      <p:sp>
+        <p:nvSpPr>
+          <p:cNvPr id="2" name="Text 0"/>
+          <p:cNvSpPr txBox="1"/>
+          <p:nvPr/>
+        </p:nvSpPr>
+        <p:spPr>
+          <a:xfrm>
+            <a:off x="548640" y="320040"/>
+            <a:ext cx="11064240" cy="685800"/>
+          </a:xfrm>
+          <a:prstGeom prst="rect">
+            <a:avLst/>
+          </a:prstGeom>
+          <a:noFill/>
+          <a:ln/>
+        </p:spPr>
+        <p:txBody>
+          <a:bodyPr wrap="square" lIns="0" tIns="0" rIns="0" bIns="0" rtlCol="0" anchor="ctr"/>
+          <a:lstStyle/>
+          <a:p>
+            <a:pPr algn="l" indent="0" marL="0">
+              <a:buNone/>
+            </a:pPr>
+            <a:r>
+              <a:rPr lang="en-US" sz="3000" b="1" dirty="0">
+                <a:solidFill>
+                  <a:srgbClr val="01485C"/>
+                </a:solidFill>
+                <a:latin typeface="Calibri" pitchFamily="34" charset="0"/>
+                <a:ea typeface="Calibri" pitchFamily="34" charset="-122"/>
+                <a:cs typeface="Calibri" pitchFamily="34" charset="-120"/>
+              </a:rPr>
+              <a:t>Audit &amp; accountability</a:t>
+            </a:r>
+            <a:endParaRPr lang="en-US" sz="3000" dirty="0"/>
+          </a:p>
+        </p:txBody>
+      </p:sp>
+      <p:sp>
+        <p:nvSpPr>
+          <p:cNvPr id="3" name="Shape 1"/>
+          <p:cNvSpPr/>
+          <p:nvPr/>
+        </p:nvSpPr>
+        <p:spPr>
+          <a:xfrm>
+            <a:off x="548640" y="1463040"/>
+            <a:ext cx="3611880" cy="3108960"/>
+          </a:xfrm>
+          <a:prstGeom prst="roundRect">
+            <a:avLst>
+              <a:gd name="adj" fmla="val 3529"/>
+            </a:avLst>
+          </a:prstGeom>
+          <a:solidFill>
+            <a:srgbClr val="E5F2F0"/>
+          </a:solidFill>
+          <a:ln/>
+        </p:spPr>
+      </p:sp>
+      <p:sp>
+        <p:nvSpPr>
+          <p:cNvPr id="4" name="Shape 2"/>
+          <p:cNvSpPr/>
+          <p:nvPr/>
+        </p:nvSpPr>
+        <p:spPr>
+          <a:xfrm>
+            <a:off x="822960" y="1755648"/>
+            <a:ext cx="658368" cy="658368"/>
+          </a:xfrm>
+          <a:prstGeom prst="ellipse">
+            <a:avLst/>
+          </a:prstGeom>
+          <a:solidFill>
+            <a:srgbClr val="01485C"/>
+          </a:solidFill>
+          <a:ln/>
+        </p:spPr>
+      </p:sp>
+      <p:pic>
+        <p:nvPicPr>
+          <p:cNvPr id="5" name="Image 0" descr="icon_clipboard_w.png">    </p:cNvPr>
+          <p:cNvPicPr>
+            <a:picLocks noChangeAspect="1"/>
+          </p:cNvPicPr>
+          <p:nvPr/>
+        </p:nvPicPr>
+        <p:blipFill>
+          <a:blip r:embed="rId1"/>
+          <a:stretch>
+            <a:fillRect/>
+          </a:stretch>
+        </p:blipFill>
+        <p:spPr>
+          <a:xfrm>
+            <a:off x="994136" y="1926824"/>
+            <a:ext cx="316017" cy="316017"/>
+          </a:xfrm>
+          <a:prstGeom prst="rect">
+            <a:avLst/>
+          </a:prstGeom>
+        </p:spPr>
+      </p:pic>
+      <p:sp>
+        <p:nvSpPr>
+          <p:cNvPr id="6" name="Text 3"/>
+          <p:cNvSpPr txBox="1"/>
+          <p:nvPr/>
+        </p:nvSpPr>
+        <p:spPr>
+          <a:xfrm>
+            <a:off x="822960" y="2606040"/>
+            <a:ext cx="3063240" cy="457200"/>
+          </a:xfrm>
+          <a:prstGeom prst="rect">
+            <a:avLst/>
+          </a:prstGeom>
+          <a:noFill/>
+          <a:ln/>
+        </p:spPr>
+        <p:txBody>
+          <a:bodyPr wrap="square" lIns="0" tIns="0" rIns="0" bIns="0" rtlCol="0" anchor="ctr"/>
+          <a:lstStyle/>
+          <a:p>
+            <a:pPr indent="0" marL="0">
+              <a:buNone/>
+            </a:pPr>
+            <a:r>
+              <a:rPr lang="en-US" sz="1600" b="1" dirty="0">
+                <a:solidFill>
+                  <a:srgbClr val="01485C"/>
+                </a:solidFill>
+                <a:latin typeface="Calibri" pitchFamily="34" charset="0"/>
+                <a:ea typeface="Calibri" pitchFamily="34" charset="-122"/>
+                <a:cs typeface="Calibri" pitchFamily="34" charset="-120"/>
+              </a:rPr>
+              <a:t>audit.log</a:t>
+            </a:r>
+            <a:endParaRPr lang="en-US" sz="1600" dirty="0"/>
+          </a:p>
+        </p:txBody>
+      </p:sp>
+      <p:sp>
+        <p:nvSpPr>
+          <p:cNvPr id="7" name="Text 4"/>
+          <p:cNvSpPr txBox="1"/>
+          <p:nvPr/>
+        </p:nvSpPr>
+        <p:spPr>
+          <a:xfrm>
+            <a:off x="822960" y="3108960"/>
+            <a:ext cx="3063240" cy="1371600"/>
+          </a:xfrm>
+          <a:prstGeom prst="rect">
+            <a:avLst/>
+          </a:prstGeom>
+          <a:noFill/>
+          <a:ln/>
+        </p:spPr>
+        <p:txBody>
+          <a:bodyPr wrap="square" lIns="0" tIns="0" rIns="0" bIns="0" rtlCol="0" anchor="ctr"/>
+          <a:lstStyle/>
+          <a:p>
+            <a:pPr indent="0" marL="0">
+              <a:buNone/>
+            </a:pPr>
+            <a:r>
+              <a:rPr lang="en-US" sz="1250" dirty="0">
+                <a:solidFill>
+                  <a:srgbClr val="17272E"/>
+                </a:solidFill>
+                <a:latin typeface="Calibri" pitchFamily="34" charset="0"/>
+                <a:ea typeface="Calibri" pitchFamily="34" charset="-122"/>
+                <a:cs typeface="Calibri" pitchFamily="34" charset="-120"/>
+              </a:rPr>
+              <a:t>Every report generation: timestamp, Windows username, period, scope — plus every history unlock attempt, including failures</a:t>
+            </a:r>
+            <a:endParaRPr lang="en-US" sz="1250" dirty="0"/>
+          </a:p>
+        </p:txBody>
+      </p:sp>
+      <p:sp>
+        <p:nvSpPr>
+          <p:cNvPr id="8" name="Shape 5"/>
+          <p:cNvSpPr/>
+          <p:nvPr/>
+        </p:nvSpPr>
+        <p:spPr>
+          <a:xfrm>
+            <a:off x="4370832" y="1463040"/>
+            <a:ext cx="3611880" cy="3108960"/>
+          </a:xfrm>
+          <a:prstGeom prst="roundRect">
+            <a:avLst>
+              <a:gd name="adj" fmla="val 3529"/>
+            </a:avLst>
+          </a:prstGeom>
+          <a:solidFill>
+            <a:srgbClr val="E5F2F0"/>
+          </a:solidFill>
+          <a:ln/>
+        </p:spPr>
+      </p:sp>
+      <p:sp>
+        <p:nvSpPr>
+          <p:cNvPr id="9" name="Shape 6"/>
+          <p:cNvSpPr/>
+          <p:nvPr/>
+        </p:nvSpPr>
+        <p:spPr>
+          <a:xfrm>
+            <a:off x="4645152" y="1755648"/>
+            <a:ext cx="658368" cy="658368"/>
+          </a:xfrm>
+          <a:prstGeom prst="ellipse">
+            <a:avLst/>
+          </a:prstGeom>
+          <a:solidFill>
+            <a:srgbClr val="01485C"/>
+          </a:solidFill>
+          <a:ln/>
+        </p:spPr>
+      </p:sp>
+      <p:pic>
+        <p:nvPicPr>
+          <p:cNvPr id="10" name="Image 1" descr="icon_clipboard_w.png">    </p:cNvPr>
+          <p:cNvPicPr>
+            <a:picLocks noChangeAspect="1"/>
+          </p:cNvPicPr>
+          <p:nvPr/>
+        </p:nvPicPr>
+        <p:blipFill>
+          <a:blip r:embed="rId2"/>
+          <a:stretch>
+            <a:fillRect/>
+          </a:stretch>
+        </p:blipFill>
+        <p:spPr>
+          <a:xfrm>
+            <a:off x="4816328" y="1926824"/>
+            <a:ext cx="316017" cy="316017"/>
+          </a:xfrm>
+          <a:prstGeom prst="rect">
+            <a:avLst/>
+          </a:prstGeom>
+        </p:spPr>
+      </p:pic>
+      <p:sp>
+        <p:nvSpPr>
+          <p:cNvPr id="11" name="Text 7"/>
+          <p:cNvSpPr txBox="1"/>
+          <p:nvPr/>
+        </p:nvSpPr>
+        <p:spPr>
+          <a:xfrm>
+            <a:off x="4645152" y="2606040"/>
+            <a:ext cx="3063240" cy="457200"/>
+          </a:xfrm>
+          <a:prstGeom prst="rect">
+            <a:avLst/>
+          </a:prstGeom>
+          <a:noFill/>
+          <a:ln/>
+        </p:spPr>
+        <p:txBody>
+          <a:bodyPr wrap="square" lIns="0" tIns="0" rIns="0" bIns="0" rtlCol="0" anchor="ctr"/>
+          <a:lstStyle/>
+          <a:p>
+            <a:pPr indent="0" marL="0">
+              <a:buNone/>
+            </a:pPr>
+            <a:r>
+              <a:rPr lang="en-US" sz="1600" b="1" dirty="0">
+                <a:solidFill>
+                  <a:srgbClr val="01485C"/>
+                </a:solidFill>
+                <a:latin typeface="Calibri" pitchFamily="34" charset="0"/>
+                <a:ea typeface="Calibri" pitchFamily="34" charset="-122"/>
+                <a:cs typeface="Calibri" pitchFamily="34" charset="-120"/>
+              </a:rPr>
+              <a:t>Network audit logs</a:t>
+            </a:r>
+            <a:endParaRPr lang="en-US" sz="1600" dirty="0"/>
+          </a:p>
+        </p:txBody>
+      </p:sp>
+      <p:sp>
+        <p:nvSpPr>
+          <p:cNvPr id="12" name="Text 8"/>
+          <p:cNvSpPr txBox="1"/>
+          <p:nvPr/>
+        </p:nvSpPr>
+        <p:spPr>
+          <a:xfrm>
+            <a:off x="4645152" y="3108960"/>
+            <a:ext cx="3063240" cy="1371600"/>
+          </a:xfrm>
+          <a:prstGeom prst="rect">
+            <a:avLst/>
+          </a:prstGeom>
+          <a:noFill/>
+          <a:ln/>
+        </p:spPr>
+        <p:txBody>
+          <a:bodyPr wrap="square" lIns="0" tIns="0" rIns="0" bIns="0" rtlCol="0" anchor="ctr"/>
+          <a:lstStyle/>
+          <a:p>
+            <a:pPr indent="0" marL="0">
+              <a:buNone/>
+            </a:pPr>
+            <a:r>
+              <a:rPr lang="en-US" sz="1250" dirty="0">
+                <a:solidFill>
+                  <a:srgbClr val="17272E"/>
+                </a:solidFill>
+                <a:latin typeface="Calibri" pitchFamily="34" charset="0"/>
+                <a:ea typeface="Calibri" pitchFamily="34" charset="-122"/>
+                <a:cs typeface="Calibri" pitchFamily="34" charset="-120"/>
+              </a:rPr>
+              <a:t>The guard’s record: activation lines under normal use; any outbound attempt would appear as BLOCKED with the destination</a:t>
+            </a:r>
+            <a:endParaRPr lang="en-US" sz="1250" dirty="0"/>
+          </a:p>
+        </p:txBody>
+      </p:sp>
+      <p:sp>
+        <p:nvSpPr>
+          <p:cNvPr id="13" name="Shape 9"/>
+          <p:cNvSpPr/>
+          <p:nvPr/>
+        </p:nvSpPr>
+        <p:spPr>
+          <a:xfrm>
+            <a:off x="8193024" y="1463040"/>
+            <a:ext cx="3611880" cy="3108960"/>
+          </a:xfrm>
+          <a:prstGeom prst="roundRect">
+            <a:avLst>
+              <a:gd name="adj" fmla="val 3529"/>
+            </a:avLst>
+          </a:prstGeom>
+          <a:solidFill>
+            <a:srgbClr val="E5F2F0"/>
+          </a:solidFill>
+          <a:ln/>
+        </p:spPr>
+      </p:sp>
+      <p:sp>
+        <p:nvSpPr>
+          <p:cNvPr id="14" name="Shape 10"/>
+          <p:cNvSpPr/>
+          <p:nvPr/>
+        </p:nvSpPr>
+        <p:spPr>
+          <a:xfrm>
+            <a:off x="8467344" y="1755648"/>
+            <a:ext cx="658368" cy="658368"/>
+          </a:xfrm>
+          <a:prstGeom prst="ellipse">
+            <a:avLst/>
+          </a:prstGeom>
+          <a:solidFill>
+            <a:srgbClr val="01485C"/>
+          </a:solidFill>
+          <a:ln/>
+        </p:spPr>
+      </p:sp>
+      <p:pic>
+        <p:nvPicPr>
+          <p:cNvPr id="15" name="Image 2" descr="icon_clipboard_w.png">    </p:cNvPr>
+          <p:cNvPicPr>
+            <a:picLocks noChangeAspect="1"/>
+          </p:cNvPicPr>
+          <p:nvPr/>
+        </p:nvPicPr>
+        <p:blipFill>
+          <a:blip r:embed="rId3"/>
+          <a:stretch>
+            <a:fillRect/>
+          </a:stretch>
+        </p:blipFill>
+        <p:spPr>
+          <a:xfrm>
+            <a:off x="8638520" y="1926824"/>
+            <a:ext cx="316017" cy="316017"/>
+          </a:xfrm>
+          <a:prstGeom prst="rect">
+            <a:avLst/>
+          </a:prstGeom>
+        </p:spPr>
+      </p:pic>
+      <p:sp>
+        <p:nvSpPr>
+          <p:cNvPr id="16" name="Text 11"/>
+          <p:cNvSpPr txBox="1"/>
+          <p:nvPr/>
+        </p:nvSpPr>
+        <p:spPr>
+          <a:xfrm>
+            <a:off x="8467344" y="2606040"/>
+            <a:ext cx="3063240" cy="457200"/>
+          </a:xfrm>
+          <a:prstGeom prst="rect">
+            <a:avLst/>
+          </a:prstGeom>
+          <a:noFill/>
+          <a:ln/>
+        </p:spPr>
+        <p:txBody>
+          <a:bodyPr wrap="square" lIns="0" tIns="0" rIns="0" bIns="0" rtlCol="0" anchor="ctr"/>
+          <a:lstStyle/>
+          <a:p>
+            <a:pPr indent="0" marL="0">
+              <a:buNone/>
+            </a:pPr>
+            <a:r>
+              <a:rPr lang="en-US" sz="1600" b="1" dirty="0">
+                <a:solidFill>
+                  <a:srgbClr val="01485C"/>
+                </a:solidFill>
+                <a:latin typeface="Calibri" pitchFamily="34" charset="0"/>
+                <a:ea typeface="Calibri" pitchFamily="34" charset="-122"/>
+                <a:cs typeface="Calibri" pitchFamily="34" charset="-120"/>
+              </a:rPr>
+              <a:t>Human-readable, on-device</a:t>
+            </a:r>
+            <a:endParaRPr lang="en-US" sz="1600" dirty="0"/>
+          </a:p>
+        </p:txBody>
+      </p:sp>
+      <p:sp>
+        <p:nvSpPr>
+          <p:cNvPr id="17" name="Text 12"/>
+          <p:cNvSpPr txBox="1"/>
+          <p:nvPr/>
+        </p:nvSpPr>
+        <p:spPr>
+          <a:xfrm>
+            <a:off x="8467344" y="3108960"/>
+            <a:ext cx="3063240" cy="1371600"/>
+          </a:xfrm>
+          <a:prstGeom prst="rect">
+            <a:avLst/>
+          </a:prstGeom>
+          <a:noFill/>
+          <a:ln/>
+        </p:spPr>
+        <p:txBody>
+          <a:bodyPr wrap="square" lIns="0" tIns="0" rIns="0" bIns="0" rtlCol="0" anchor="ctr"/>
+          <a:lstStyle/>
+          <a:p>
+            <a:pPr indent="0" marL="0">
+              <a:buNone/>
+            </a:pPr>
+            <a:r>
+              <a:rPr lang="en-US" sz="1250" dirty="0">
+                <a:solidFill>
+                  <a:srgbClr val="17272E"/>
+                </a:solidFill>
+                <a:latin typeface="Calibri" pitchFamily="34" charset="0"/>
+                <a:ea typeface="Calibri" pitchFamily="34" charset="-122"/>
+                <a:cs typeface="Calibri" pitchFamily="34" charset="-120"/>
+              </a:rPr>
+              <a:t>Plain text on the drive — reviewable by any auditor without tooling, tied to OS usernames</a:t>
+            </a:r>
+            <a:endParaRPr lang="en-US" sz="1250" dirty="0"/>
+          </a:p>
+        </p:txBody>
+      </p:sp>
+      <p:sp>
+        <p:nvSpPr>
+          <p:cNvPr id="18" name="Text 13"/>
+          <p:cNvSpPr txBox="1"/>
+          <p:nvPr/>
+        </p:nvSpPr>
+        <p:spPr>
+          <a:xfrm>
+            <a:off x="548640" y="5029200"/>
+            <a:ext cx="11064240" cy="457200"/>
+          </a:xfrm>
+          <a:prstGeom prst="rect">
+            <a:avLst/>
+          </a:prstGeom>
+          <a:noFill/>
+          <a:ln/>
+        </p:spPr>
+        <p:txBody>
+          <a:bodyPr wrap="square" lIns="0" tIns="0" rIns="0" bIns="0" rtlCol="0" anchor="ctr"/>
+          <a:lstStyle/>
+          <a:p>
+            <a:pPr indent="0" marL="0">
+              <a:buNone/>
+            </a:pPr>
+            <a:r>
+              <a:rPr lang="en-US" sz="1400" i="1" dirty="0">
+                <a:solidFill>
+                  <a:srgbClr val="5F7178"/>
+                </a:solidFill>
+                <a:latin typeface="Calibri" pitchFamily="34" charset="0"/>
+                <a:ea typeface="Calibri" pitchFamily="34" charset="-122"/>
+                <a:cs typeface="Calibri" pitchFamily="34" charset="-120"/>
+              </a:rPr>
+              <a:t>Failed password attempts are recorded — repeated failures on a found drive leave evidence.</a:t>
+            </a:r>
+            <a:endParaRPr lang="en-US" sz="1400" dirty="0"/>
+          </a:p>
+        </p:txBody>
+      </p:sp>
+      <p:sp>
+        <p:nvSpPr>
+          <p:cNvPr id="19" name="Shape 14"/>
+          <p:cNvSpPr/>
+          <p:nvPr/>
+        </p:nvSpPr>
+        <p:spPr>
+          <a:xfrm>
+            <a:off x="0" y="6793992"/>
+            <a:ext cx="2040636" cy="64008"/>
+          </a:xfrm>
+          <a:prstGeom prst="rect">
+            <a:avLst/>
+          </a:prstGeom>
+          <a:solidFill>
+            <a:srgbClr val="01485C"/>
+          </a:solidFill>
+          <a:ln/>
+        </p:spPr>
+      </p:sp>
+      <p:sp>
+        <p:nvSpPr>
+          <p:cNvPr id="20" name="Shape 15"/>
+          <p:cNvSpPr/>
+          <p:nvPr/>
+        </p:nvSpPr>
+        <p:spPr>
+          <a:xfrm>
+            <a:off x="2031492" y="6793992"/>
+            <a:ext cx="2040636" cy="64008"/>
+          </a:xfrm>
+          <a:prstGeom prst="rect">
+            <a:avLst/>
+          </a:prstGeom>
+          <a:solidFill>
+            <a:srgbClr val="146175"/>
+          </a:solidFill>
+          <a:ln/>
+        </p:spPr>
+      </p:sp>
+      <p:sp>
+        <p:nvSpPr>
+          <p:cNvPr id="21" name="Shape 16"/>
+          <p:cNvSpPr/>
+          <p:nvPr/>
+        </p:nvSpPr>
+        <p:spPr>
+          <a:xfrm>
+            <a:off x="4062984" y="6793992"/>
+            <a:ext cx="2040636" cy="64008"/>
+          </a:xfrm>
+          <a:prstGeom prst="rect">
+            <a:avLst/>
+          </a:prstGeom>
+          <a:solidFill>
+            <a:srgbClr val="11B5AE"/>
+          </a:solidFill>
+          <a:ln/>
+        </p:spPr>
+      </p:sp>
+      <p:sp>
+        <p:nvSpPr>
+          <p:cNvPr id="22" name="Shape 17"/>
+          <p:cNvSpPr/>
+          <p:nvPr/>
+        </p:nvSpPr>
+        <p:spPr>
+          <a:xfrm>
+            <a:off x="6094476" y="6793992"/>
+            <a:ext cx="2040636" cy="64008"/>
+          </a:xfrm>
+          <a:prstGeom prst="rect">
+            <a:avLst/>
+          </a:prstGeom>
+          <a:solidFill>
+            <a:srgbClr val="6CCAD4"/>
+          </a:solidFill>
+          <a:ln/>
+        </p:spPr>
+      </p:sp>
+      <p:sp>
+        <p:nvSpPr>
+          <p:cNvPr id="23" name="Shape 18"/>
+          <p:cNvSpPr/>
+          <p:nvPr/>
+        </p:nvSpPr>
+        <p:spPr>
+          <a:xfrm>
+            <a:off x="8125968" y="6793992"/>
+            <a:ext cx="2040636" cy="64008"/>
+          </a:xfrm>
+          <a:prstGeom prst="rect">
+            <a:avLst/>
+          </a:prstGeom>
+          <a:solidFill>
+            <a:srgbClr val="7FC04C"/>
+          </a:solidFill>
+          <a:ln/>
+        </p:spPr>
+      </p:sp>
+      <p:sp>
+        <p:nvSpPr>
+          <p:cNvPr id="24" name="Shape 19"/>
+          <p:cNvSpPr/>
+          <p:nvPr/>
+        </p:nvSpPr>
+        <p:spPr>
+          <a:xfrm>
+            <a:off x="10157460" y="6793992"/>
+            <a:ext cx="2040636" cy="64008"/>
+          </a:xfrm>
+          <a:prstGeom prst="rect">
+            <a:avLst/>
+          </a:prstGeom>
+          <a:solidFill>
+            <a:srgbClr val="E1DD57"/>
+          </a:solidFill>
+          <a:ln/>
+        </p:spPr>
+      </p:sp>
+    </p:spTree>
+  </p:cSld>
+  <p:clrMapOvr>
+    <a:masterClrMapping/>
+  </p:clrMapOvr>
+</p:sld>
+</file>
+
+<file path=ppt/slides/slide11.xml><?xml version="1.0" encoding="utf-8"?>
 <p:sld xmlns:a="http://schemas.openxmlformats.org/drawingml/2006/main" xmlns:r="http://schemas.openxmlformats.org/officeDocument/2006/relationships" xmlns:p="http://schemas.openxmlformats.org/presentationml/2006/main">
   <p:cSld name="Slide 10">
     <p:bg>
@@ -3284,7 +3947,7 @@
 </p:sld>
 </file>
 
-<file path=ppt/slides/slide11.xml><?xml version="1.0" encoding="utf-8"?>
+<file path=ppt/slides/slide12.xml><?xml version="1.0" encoding="utf-8"?>
 <p:sld xmlns:a="http://schemas.openxmlformats.org/drawingml/2006/main" xmlns:r="http://schemas.openxmlformats.org/officeDocument/2006/relationships" xmlns:p="http://schemas.openxmlformats.org/presentationml/2006/main">
   <p:cSld name="Slide 11">
     <p:bg>
@@ -3366,6 +4029,10 @@
           </a:solidFill>
           <a:ln/>
         </p:spPr>
+        <p:txBody>
+          <a:bodyPr/>
+          <a:p/>
+        </p:txBody>
       </p:sp>
       <p:sp>
         <p:nvSpPr>
@@ -3467,7 +4134,7 @@
         </p:nvSpPr>
         <p:spPr>
           <a:xfrm>
-            <a:off x="548640" y="2350008"/>
+            <a:off x="548640" y="2231136"/>
             <a:ext cx="566928" cy="566928"/>
           </a:xfrm>
           <a:prstGeom prst="ellipse">
@@ -3478,6 +4145,10 @@
           </a:solidFill>
           <a:ln/>
         </p:spPr>
+        <p:txBody>
+          <a:bodyPr/>
+          <a:p/>
+        </p:txBody>
       </p:sp>
       <p:sp>
         <p:nvSpPr>
@@ -3487,7 +4158,7 @@
         </p:nvSpPr>
         <p:spPr>
           <a:xfrm>
-            <a:off x="548640" y="2350008"/>
+            <a:off x="548640" y="2231136"/>
             <a:ext cx="566928" cy="566928"/>
           </a:xfrm>
           <a:prstGeom prst="rect">
@@ -3526,7 +4197,7 @@
         </p:nvSpPr>
         <p:spPr>
           <a:xfrm>
-            <a:off x="1325880" y="2304288"/>
+            <a:off x="1325880" y="2185416"/>
             <a:ext cx="6400800" cy="777240"/>
           </a:xfrm>
           <a:prstGeom prst="rect">
@@ -3579,7 +4250,7 @@
         </p:nvSpPr>
         <p:spPr>
           <a:xfrm>
-            <a:off x="548640" y="3282696"/>
+            <a:off x="548640" y="3044952"/>
             <a:ext cx="566928" cy="566928"/>
           </a:xfrm>
           <a:prstGeom prst="ellipse">
@@ -3590,6 +4261,10 @@
           </a:solidFill>
           <a:ln/>
         </p:spPr>
+        <p:txBody>
+          <a:bodyPr/>
+          <a:p/>
+        </p:txBody>
       </p:sp>
       <p:sp>
         <p:nvSpPr>
@@ -3599,7 +4274,7 @@
         </p:nvSpPr>
         <p:spPr>
           <a:xfrm>
-            <a:off x="548640" y="3282696"/>
+            <a:off x="548640" y="3044952"/>
             <a:ext cx="566928" cy="566928"/>
           </a:xfrm>
           <a:prstGeom prst="rect">
@@ -3638,7 +4313,7 @@
         </p:nvSpPr>
         <p:spPr>
           <a:xfrm>
-            <a:off x="1325880" y="3236976"/>
+            <a:off x="1325880" y="2999232"/>
             <a:ext cx="6400800" cy="777240"/>
           </a:xfrm>
           <a:prstGeom prst="rect">
@@ -3691,7 +4366,7 @@
         </p:nvSpPr>
         <p:spPr>
           <a:xfrm>
-            <a:off x="548640" y="4215384"/>
+            <a:off x="548640" y="3858768"/>
             <a:ext cx="566928" cy="566928"/>
           </a:xfrm>
           <a:prstGeom prst="ellipse">
@@ -3702,6 +4377,10 @@
           </a:solidFill>
           <a:ln/>
         </p:spPr>
+        <p:txBody>
+          <a:bodyPr/>
+          <a:p/>
+        </p:txBody>
       </p:sp>
       <p:sp>
         <p:nvSpPr>
@@ -3711,7 +4390,7 @@
         </p:nvSpPr>
         <p:spPr>
           <a:xfrm>
-            <a:off x="548640" y="4215384"/>
+            <a:off x="548640" y="3858768"/>
             <a:ext cx="566928" cy="566928"/>
           </a:xfrm>
           <a:prstGeom prst="rect">
@@ -3750,7 +4429,7 @@
         </p:nvSpPr>
         <p:spPr>
           <a:xfrm>
-            <a:off x="1325880" y="4169664"/>
+            <a:off x="1325880" y="3813048"/>
             <a:ext cx="6400800" cy="777240"/>
           </a:xfrm>
           <a:prstGeom prst="rect">
@@ -3821,6 +4500,10 @@
             <a:prstDash val="solid"/>
           </a:ln>
         </p:spPr>
+        <p:txBody>
+          <a:bodyPr/>
+          <a:p/>
+        </p:txBody>
       </p:sp>
       <p:sp>
         <p:nvSpPr>
@@ -3919,7 +4602,7 @@
                 <a:ea typeface="Calibri" pitchFamily="34" charset="-122"/>
                 <a:cs typeface="Calibri" pitchFamily="34" charset="-120"/>
               </a:rPr>
-              <a:t>History password is a shared team secret</a:t>
+              <a:t>History and enrolment passwords are shared team secrets</a:t>
             </a:r>
             <a:endParaRPr lang="en-US" sz="1250" dirty="0"/>
           </a:p>
@@ -3965,6 +4648,27 @@
             </a:r>
             <a:endParaRPr lang="en-US" sz="1250" dirty="0"/>
           </a:p>
+          <a:p>
+            <a:pPr marL="152400" indent="-152400">
+              <a:spcAft>
+                <a:spcPts val="1000"/>
+              </a:spcAft>
+              <a:buSzPct val="100000"/>
+              <a:buChar char="•"/>
+            </a:pPr>
+            <a:r>
+              <a:rPr lang="en-US" sz="1250" dirty="0">
+                <a:solidFill>
+                  <a:srgbClr val="6CCAD4"/>
+                </a:solidFill>
+                <a:latin typeface="Calibri" pitchFamily="34" charset="0"/>
+                <a:ea typeface="Calibri" pitchFamily="34" charset="-122"/>
+                <a:cs typeface="Calibri" pitchFamily="34" charset="-120"/>
+              </a:rPr>
+              <a:t>PC enrolment is enforced by code on the drive — evidence, not DRM</a:t>
+            </a:r>
+            <a:endParaRPr lang="en-US" sz="1250" dirty="0"/>
+          </a:p>
         </p:txBody>
       </p:sp>
       <p:sp>
@@ -3975,7 +4679,7 @@
         </p:nvSpPr>
         <p:spPr>
           <a:xfrm>
-            <a:off x="548640" y="5532120"/>
+            <a:off x="548640" y="5650992"/>
             <a:ext cx="2377440" cy="868680"/>
           </a:xfrm>
           <a:prstGeom prst="roundRect">
@@ -4171,6 +4875,122 @@
           </a:solidFill>
           <a:ln/>
         </p:spPr>
+      </p:sp>
+      <p:sp>
+        <p:nvSpPr>
+          <p:cNvPr id="12" name="Shape 10"/>
+          <p:cNvSpPr/>
+          <p:nvPr/>
+        </p:nvSpPr>
+        <p:spPr>
+          <a:xfrm>
+            <a:off x="548640" y="4672584"/>
+            <a:ext cx="566928" cy="566928"/>
+          </a:xfrm>
+          <a:prstGeom prst="ellipse">
+            <a:avLst/>
+          </a:prstGeom>
+          <a:solidFill>
+            <a:srgbClr val="7FC04C"/>
+          </a:solidFill>
+          <a:ln/>
+        </p:spPr>
+        <p:txBody>
+          <a:bodyPr/>
+          <a:p/>
+        </p:txBody>
+      </p:sp>
+      <p:sp>
+        <p:nvSpPr>
+          <p:cNvPr id="13" name="Text 11"/>
+          <p:cNvSpPr txBox="1"/>
+          <p:nvPr/>
+        </p:nvSpPr>
+        <p:spPr>
+          <a:xfrm>
+            <a:off x="548640" y="4672584"/>
+            <a:ext cx="566928" cy="566928"/>
+          </a:xfrm>
+          <a:prstGeom prst="rect">
+            <a:avLst/>
+          </a:prstGeom>
+          <a:noFill/>
+          <a:ln/>
+        </p:spPr>
+        <p:txBody>
+          <a:bodyPr wrap="square" lIns="0" tIns="0" rIns="0" bIns="0" rtlCol="0" anchor="ctr"/>
+          <a:lstStyle/>
+          <a:p>
+            <a:pPr algn="ctr" indent="0" marL="0">
+              <a:buNone/>
+            </a:pPr>
+            <a:r>
+              <a:rPr lang="en-US" sz="2000" b="1" dirty="0">
+                <a:solidFill>
+                  <a:srgbClr val="012B38"/>
+                </a:solidFill>
+                <a:latin typeface="Calibri" pitchFamily="34" charset="0"/>
+                <a:ea typeface="Calibri" pitchFamily="34" charset="-122"/>
+                <a:cs typeface="Calibri" pitchFamily="34" charset="-120"/>
+              </a:rPr>
+              <a:t>5</a:t>
+            </a:r>
+            <a:endParaRPr lang="en-US" sz="2000" dirty="0"/>
+          </a:p>
+        </p:txBody>
+      </p:sp>
+      <p:sp>
+        <p:nvSpPr>
+          <p:cNvPr id="14" name="Text 12"/>
+          <p:cNvSpPr txBox="1"/>
+          <p:nvPr/>
+        </p:nvSpPr>
+        <p:spPr>
+          <a:xfrm>
+            <a:off x="1325880" y="4626864"/>
+            <a:ext cx="6400800" cy="777240"/>
+          </a:xfrm>
+          <a:prstGeom prst="rect">
+            <a:avLst/>
+          </a:prstGeom>
+          <a:noFill/>
+          <a:ln/>
+        </p:spPr>
+        <p:txBody>
+          <a:bodyPr wrap="square" lIns="0" tIns="0" rIns="0" bIns="0" rtlCol="0" anchor="t"/>
+          <a:lstStyle/>
+          <a:p>
+            <a:pPr indent="0" marL="0">
+              <a:buNone/>
+            </a:pPr>
+            <a:r>
+              <a:rPr lang="en-US" sz="1550" b="1" dirty="0">
+                <a:solidFill>
+                  <a:srgbClr val="FFFFFF"/>
+                </a:solidFill>
+                <a:latin typeface="Calibri" pitchFamily="34" charset="0"/>
+                <a:ea typeface="Calibri" pitchFamily="34" charset="-122"/>
+                <a:cs typeface="Calibri" pitchFamily="34" charset="-120"/>
+              </a:rPr>
+              <a:t>Enrol the approved PCs   </a:t>
+            </a:r>
+            <a:pPr indent="0" marL="0">
+              <a:buNone/>
+            </a:pPr>
+            <a:r>
+              <a:rPr lang="en-US" sz="1550" dirty="0">
+                <a:solidFill>
+                  <a:srgbClr val="6CCAD4"/>
+                </a:solidFill>
+                <a:latin typeface="Calibri" pitchFamily="34" charset="0"/>
+                <a:ea typeface="Calibri" pitchFamily="34" charset="-122"/>
+                <a:cs typeface="Calibri" pitchFamily="34" charset="-120"/>
+              </a:rPr>
+              <a:t>Set the enrolment password at first launch, enrol each approved non-networked PC, review Enrolled PCs monthly</a:t>
+            </a:r>
+            <a:endParaRPr lang="en-US" sz="1550" dirty="0"/>
+          </a:p>
+        </p:txBody>
       </p:sp>
     </p:spTree>
   </p:cSld>
@@ -4301,7 +5121,7 @@
                 <a:ea typeface="Calibri" pitchFamily="34" charset="-122"/>
                 <a:cs typeface="Calibri" pitchFamily="34" charset="-120"/>
               </a:rPr>
-              <a:t>Runs on any Windows PC with no installation, no admin rights, and no system changes.</a:t>
+              <a:t>Runs only on PCs the PoC team has enrolled — no installation, no admin rights, no system changes.</a:t>
             </a:r>
             <a:endParaRPr lang="en-US" sz="1500" dirty="0"/>
           </a:p>
@@ -6764,7 +7584,7 @@
                 <a:ea typeface="Calibri" pitchFamily="34" charset="-122"/>
                 <a:cs typeface="Calibri" pitchFamily="34" charset="-120"/>
               </a:rPr>
-              <a:t>Five layers of defence</a:t>
+              <a:t>Six layers of defence</a:t>
             </a:r>
             <a:endParaRPr lang="en-US" sz="3000" dirty="0"/>
           </a:p>
@@ -6778,7 +7598,7 @@
         </p:nvSpPr>
         <p:spPr>
           <a:xfrm>
-            <a:off x="548640" y="1234440"/>
+            <a:off x="548640" y="1170432"/>
             <a:ext cx="11064240" cy="932688"/>
           </a:xfrm>
           <a:prstGeom prst="roundRect">
@@ -6805,7 +7625,7 @@
         </p:nvSpPr>
         <p:spPr>
           <a:xfrm>
-            <a:off x="749808" y="1371600"/>
+            <a:off x="749808" y="1307592"/>
             <a:ext cx="658368" cy="658368"/>
           </a:xfrm>
           <a:prstGeom prst="ellipse">
@@ -6833,7 +7653,7 @@
         </p:blipFill>
         <p:spPr>
           <a:xfrm>
-            <a:off x="920984" y="1542776"/>
+            <a:off x="920984" y="1478768"/>
             <a:ext cx="316017" cy="316017"/>
           </a:xfrm>
           <a:prstGeom prst="rect">
@@ -6849,7 +7669,7 @@
         </p:nvSpPr>
         <p:spPr>
           <a:xfrm>
-            <a:off x="1600200" y="1344168"/>
+            <a:off x="1600200" y="1280160"/>
             <a:ext cx="2743200" cy="365760"/>
           </a:xfrm>
           <a:prstGeom prst="rect">
@@ -6888,7 +7708,7 @@
         </p:nvSpPr>
         <p:spPr>
           <a:xfrm>
-            <a:off x="1600200" y="1691640"/>
+            <a:off x="1600200" y="1627632"/>
             <a:ext cx="7863840" cy="411480"/>
           </a:xfrm>
           <a:prstGeom prst="rect">
@@ -6927,7 +7747,7 @@
         </p:nvSpPr>
         <p:spPr>
           <a:xfrm>
-            <a:off x="10195560" y="1545336"/>
+            <a:off x="10195560" y="1481328"/>
             <a:ext cx="1234440" cy="310896"/>
           </a:xfrm>
           <a:prstGeom prst="roundRect">
@@ -6949,7 +7769,7 @@
         </p:nvSpPr>
         <p:spPr>
           <a:xfrm>
-            <a:off x="10195560" y="1545336"/>
+            <a:off x="10195560" y="1481328"/>
             <a:ext cx="1234440" cy="310896"/>
           </a:xfrm>
           <a:prstGeom prst="rect">
@@ -6988,7 +7808,7 @@
         </p:nvSpPr>
         <p:spPr>
           <a:xfrm>
-            <a:off x="548640" y="2276856"/>
+            <a:off x="548640" y="2029968"/>
             <a:ext cx="11064240" cy="932688"/>
           </a:xfrm>
           <a:prstGeom prst="roundRect">
@@ -7015,7 +7835,7 @@
         </p:nvSpPr>
         <p:spPr>
           <a:xfrm>
-            <a:off x="749808" y="2414016"/>
+            <a:off x="749808" y="2167128"/>
             <a:ext cx="658368" cy="658368"/>
           </a:xfrm>
           <a:prstGeom prst="ellipse">
@@ -7043,7 +7863,7 @@
         </p:blipFill>
         <p:spPr>
           <a:xfrm>
-            <a:off x="920984" y="2585192"/>
+            <a:off x="920984" y="2338304"/>
             <a:ext cx="316017" cy="316017"/>
           </a:xfrm>
           <a:prstGeom prst="rect">
@@ -7059,7 +7879,7 @@
         </p:nvSpPr>
         <p:spPr>
           <a:xfrm>
-            <a:off x="1600200" y="2386584"/>
+            <a:off x="1600200" y="2139696"/>
             <a:ext cx="2743200" cy="365760"/>
           </a:xfrm>
           <a:prstGeom prst="rect">
@@ -7098,7 +7918,7 @@
         </p:nvSpPr>
         <p:spPr>
           <a:xfrm>
-            <a:off x="1600200" y="2734056"/>
+            <a:off x="1600200" y="2487168"/>
             <a:ext cx="7863840" cy="411480"/>
           </a:xfrm>
           <a:prstGeom prst="rect">
@@ -7137,7 +7957,7 @@
         </p:nvSpPr>
         <p:spPr>
           <a:xfrm>
-            <a:off x="10195560" y="2587752"/>
+            <a:off x="10195560" y="2340864"/>
             <a:ext cx="1234440" cy="310896"/>
           </a:xfrm>
           <a:prstGeom prst="roundRect">
@@ -7159,7 +7979,7 @@
         </p:nvSpPr>
         <p:spPr>
           <a:xfrm>
-            <a:off x="10195560" y="2587752"/>
+            <a:off x="10195560" y="2340864"/>
             <a:ext cx="1234440" cy="310896"/>
           </a:xfrm>
           <a:prstGeom prst="rect">
@@ -7198,7 +8018,7 @@
         </p:nvSpPr>
         <p:spPr>
           <a:xfrm>
-            <a:off x="548640" y="3319272"/>
+            <a:off x="548640" y="2889504"/>
             <a:ext cx="11064240" cy="932688"/>
           </a:xfrm>
           <a:prstGeom prst="roundRect">
@@ -7225,7 +8045,7 @@
         </p:nvSpPr>
         <p:spPr>
           <a:xfrm>
-            <a:off x="749808" y="3456432"/>
+            <a:off x="749808" y="3026664"/>
             <a:ext cx="658368" cy="658368"/>
           </a:xfrm>
           <a:prstGeom prst="ellipse">
@@ -7253,7 +8073,7 @@
         </p:blipFill>
         <p:spPr>
           <a:xfrm>
-            <a:off x="920984" y="3627608"/>
+            <a:off x="920984" y="3197840"/>
             <a:ext cx="316017" cy="316017"/>
           </a:xfrm>
           <a:prstGeom prst="rect">
@@ -7269,7 +8089,7 @@
         </p:nvSpPr>
         <p:spPr>
           <a:xfrm>
-            <a:off x="1600200" y="3429000"/>
+            <a:off x="1600200" y="2999232"/>
             <a:ext cx="2743200" cy="365760"/>
           </a:xfrm>
           <a:prstGeom prst="rect">
@@ -7308,7 +8128,7 @@
         </p:nvSpPr>
         <p:spPr>
           <a:xfrm>
-            <a:off x="1600200" y="3776472"/>
+            <a:off x="1600200" y="3346704"/>
             <a:ext cx="7863840" cy="411480"/>
           </a:xfrm>
           <a:prstGeom prst="rect">
@@ -7347,7 +8167,7 @@
         </p:nvSpPr>
         <p:spPr>
           <a:xfrm>
-            <a:off x="10195560" y="3630168"/>
+            <a:off x="10195560" y="3200400"/>
             <a:ext cx="1234440" cy="310896"/>
           </a:xfrm>
           <a:prstGeom prst="roundRect">
@@ -7369,7 +8189,7 @@
         </p:nvSpPr>
         <p:spPr>
           <a:xfrm>
-            <a:off x="10195560" y="3630168"/>
+            <a:off x="10195560" y="3200400"/>
             <a:ext cx="1234440" cy="310896"/>
           </a:xfrm>
           <a:prstGeom prst="rect">
@@ -7408,7 +8228,7 @@
         </p:nvSpPr>
         <p:spPr>
           <a:xfrm>
-            <a:off x="548640" y="4361688"/>
+            <a:off x="548640" y="3749040"/>
             <a:ext cx="11064240" cy="932688"/>
           </a:xfrm>
           <a:prstGeom prst="roundRect">
@@ -7435,7 +8255,7 @@
         </p:nvSpPr>
         <p:spPr>
           <a:xfrm>
-            <a:off x="749808" y="4498848"/>
+            <a:off x="749808" y="3886200"/>
             <a:ext cx="658368" cy="658368"/>
           </a:xfrm>
           <a:prstGeom prst="ellipse">
@@ -7463,7 +8283,7 @@
         </p:blipFill>
         <p:spPr>
           <a:xfrm>
-            <a:off x="920984" y="4670024"/>
+            <a:off x="920984" y="4057376"/>
             <a:ext cx="316017" cy="316017"/>
           </a:xfrm>
           <a:prstGeom prst="rect">
@@ -7479,7 +8299,7 @@
         </p:nvSpPr>
         <p:spPr>
           <a:xfrm>
-            <a:off x="1600200" y="4471416"/>
+            <a:off x="1600200" y="3858768"/>
             <a:ext cx="2743200" cy="365760"/>
           </a:xfrm>
           <a:prstGeom prst="rect">
@@ -7518,7 +8338,7 @@
         </p:nvSpPr>
         <p:spPr>
           <a:xfrm>
-            <a:off x="1600200" y="4818888"/>
+            <a:off x="1600200" y="4206240"/>
             <a:ext cx="7863840" cy="411480"/>
           </a:xfrm>
           <a:prstGeom prst="rect">
@@ -7557,7 +8377,7 @@
         </p:nvSpPr>
         <p:spPr>
           <a:xfrm>
-            <a:off x="10195560" y="4672584"/>
+            <a:off x="10195560" y="4059936"/>
             <a:ext cx="1234440" cy="310896"/>
           </a:xfrm>
           <a:prstGeom prst="roundRect">
@@ -7579,7 +8399,7 @@
         </p:nvSpPr>
         <p:spPr>
           <a:xfrm>
-            <a:off x="10195560" y="4672584"/>
+            <a:off x="10195560" y="4059936"/>
             <a:ext cx="1234440" cy="310896"/>
           </a:xfrm>
           <a:prstGeom prst="rect">
@@ -7618,7 +8438,7 @@
         </p:nvSpPr>
         <p:spPr>
           <a:xfrm>
-            <a:off x="548640" y="5404104"/>
+            <a:off x="548640" y="4608576"/>
             <a:ext cx="11064240" cy="932688"/>
           </a:xfrm>
           <a:prstGeom prst="roundRect">
@@ -7645,7 +8465,7 @@
         </p:nvSpPr>
         <p:spPr>
           <a:xfrm>
-            <a:off x="749808" y="5541264"/>
+            <a:off x="749808" y="4745736"/>
             <a:ext cx="658368" cy="658368"/>
           </a:xfrm>
           <a:prstGeom prst="ellipse">
@@ -7673,7 +8493,7 @@
         </p:blipFill>
         <p:spPr>
           <a:xfrm>
-            <a:off x="920984" y="5712440"/>
+            <a:off x="920984" y="4916912"/>
             <a:ext cx="316017" cy="316017"/>
           </a:xfrm>
           <a:prstGeom prst="rect">
@@ -7689,7 +8509,7 @@
         </p:nvSpPr>
         <p:spPr>
           <a:xfrm>
-            <a:off x="1600200" y="5513832"/>
+            <a:off x="1600200" y="4718304"/>
             <a:ext cx="2743200" cy="365760"/>
           </a:xfrm>
           <a:prstGeom prst="rect">
@@ -7728,7 +8548,7 @@
         </p:nvSpPr>
         <p:spPr>
           <a:xfrm>
-            <a:off x="1600200" y="5861304"/>
+            <a:off x="1600200" y="5065776"/>
             <a:ext cx="7863840" cy="411480"/>
           </a:xfrm>
           <a:prstGeom prst="rect">
@@ -7767,7 +8587,7 @@
         </p:nvSpPr>
         <p:spPr>
           <a:xfrm>
-            <a:off x="10195560" y="5715000"/>
+            <a:off x="10195560" y="4919472"/>
             <a:ext cx="1234440" cy="310896"/>
           </a:xfrm>
           <a:prstGeom prst="roundRect">
@@ -7789,7 +8609,7 @@
         </p:nvSpPr>
         <p:spPr>
           <a:xfrm>
-            <a:off x="10195560" y="5715000"/>
+            <a:off x="10195560" y="4919472"/>
             <a:ext cx="1234440" cy="310896"/>
           </a:xfrm>
           <a:prstGeom prst="rect">
@@ -7939,6 +8759,228 @@
           </a:solidFill>
           <a:ln/>
         </p:spPr>
+      </p:sp>
+      <p:sp>
+        <p:nvSpPr>
+          <p:cNvPr id="31" name="Shape 25"/>
+          <p:cNvSpPr/>
+          <p:nvPr/>
+        </p:nvSpPr>
+        <p:spPr>
+          <a:xfrm>
+            <a:off x="548640" y="5468111"/>
+            <a:ext cx="11064240" cy="932688"/>
+          </a:xfrm>
+          <a:prstGeom prst="roundRect">
+            <a:avLst>
+              <a:gd name="adj" fmla="val 9804"/>
+            </a:avLst>
+          </a:prstGeom>
+          <a:solidFill>
+            <a:srgbClr val="FFFFFF"/>
+          </a:solidFill>
+          <a:ln w="12700">
+            <a:solidFill>
+              <a:srgbClr val="E2E8EA"/>
+            </a:solidFill>
+            <a:prstDash val="solid"/>
+          </a:ln>
+        </p:spPr>
+        <p:txBody>
+          <a:bodyPr/>
+          <a:p/>
+        </p:txBody>
+      </p:sp>
+      <p:sp>
+        <p:nvSpPr>
+          <p:cNvPr id="32" name="Shape 26"/>
+          <p:cNvSpPr/>
+          <p:nvPr/>
+        </p:nvSpPr>
+        <p:spPr>
+          <a:xfrm>
+            <a:off x="749808" y="5605271"/>
+            <a:ext cx="658368" cy="658368"/>
+          </a:xfrm>
+          <a:prstGeom prst="ellipse">
+            <a:avLst/>
+          </a:prstGeom>
+          <a:solidFill>
+            <a:srgbClr val="01485C"/>
+          </a:solidFill>
+          <a:ln/>
+        </p:spPr>
+        <p:txBody>
+          <a:bodyPr/>
+          <a:p/>
+        </p:txBody>
+      </p:sp>
+      <p:pic>
+        <p:nvPicPr>
+          <p:cNvPr id="33" name="Image 4" descr="icon_clipboard_w.png">    </p:cNvPr>
+          <p:cNvPicPr>
+            <a:picLocks noChangeAspect="1"/>
+          </p:cNvPicPr>
+          <p:nvPr/>
+        </p:nvPicPr>
+        <p:blipFill>
+          <a:blip r:embed="rId5"/>
+          <a:stretch>
+            <a:fillRect/>
+          </a:stretch>
+        </p:blipFill>
+        <p:spPr>
+          <a:xfrm>
+            <a:off x="920984" y="5776447"/>
+            <a:ext cx="316017" cy="316017"/>
+          </a:xfrm>
+          <a:prstGeom prst="rect">
+            <a:avLst/>
+          </a:prstGeom>
+        </p:spPr>
+      </p:pic>
+      <p:sp>
+        <p:nvSpPr>
+          <p:cNvPr id="34" name="Text 27"/>
+          <p:cNvSpPr txBox="1"/>
+          <p:nvPr/>
+        </p:nvSpPr>
+        <p:spPr>
+          <a:xfrm>
+            <a:off x="1600200" y="5577839"/>
+            <a:ext cx="2743200" cy="365760"/>
+          </a:xfrm>
+          <a:prstGeom prst="rect">
+            <a:avLst/>
+          </a:prstGeom>
+          <a:noFill/>
+          <a:ln/>
+        </p:spPr>
+        <p:txBody>
+          <a:bodyPr wrap="square" lIns="0" tIns="0" rIns="0" bIns="0" rtlCol="0" anchor="ctr"/>
+          <a:lstStyle/>
+          <a:p>
+            <a:pPr indent="0" marL="0">
+              <a:buNone/>
+            </a:pPr>
+            <a:r>
+              <a:rPr lang="en-US" sz="1500" b="1" dirty="0">
+                <a:solidFill>
+                  <a:srgbClr val="01485C"/>
+                </a:solidFill>
+                <a:latin typeface="Calibri" pitchFamily="34" charset="0"/>
+                <a:ea typeface="Calibri" pitchFamily="34" charset="-122"/>
+                <a:cs typeface="Calibri" pitchFamily="34" charset="-120"/>
+              </a:rPr>
+              <a:t>Where it can run</a:t>
+            </a:r>
+            <a:endParaRPr lang="en-US" sz="1500" dirty="0"/>
+          </a:p>
+        </p:txBody>
+      </p:sp>
+      <p:sp>
+        <p:nvSpPr>
+          <p:cNvPr id="35" name="Text 28"/>
+          <p:cNvSpPr txBox="1"/>
+          <p:nvPr/>
+        </p:nvSpPr>
+        <p:spPr>
+          <a:xfrm>
+            <a:off x="1600200" y="5925311"/>
+            <a:ext cx="7863840" cy="411480"/>
+          </a:xfrm>
+          <a:prstGeom prst="rect">
+            <a:avLst/>
+          </a:prstGeom>
+          <a:noFill/>
+          <a:ln/>
+        </p:spPr>
+        <p:txBody>
+          <a:bodyPr wrap="square" lIns="0" tIns="0" rIns="0" bIns="0" rtlCol="0" anchor="ctr"/>
+          <a:lstStyle/>
+          <a:p>
+            <a:pPr indent="0" marL="0">
+              <a:buNone/>
+            </a:pPr>
+            <a:r>
+              <a:rPr lang="en-US" sz="1250" dirty="0">
+                <a:solidFill>
+                  <a:srgbClr val="5F7178"/>
+                </a:solidFill>
+                <a:latin typeface="Calibri" pitchFamily="34" charset="0"/>
+                <a:ea typeface="Calibri" pitchFamily="34" charset="-122"/>
+                <a:cs typeface="Calibri" pitchFamily="34" charset="-120"/>
+              </a:rPr>
+              <a:t>PC enrolment bound to the motherboard, 12-month term, signed registry, audited</a:t>
+            </a:r>
+            <a:endParaRPr lang="en-US" sz="1250" dirty="0"/>
+          </a:p>
+        </p:txBody>
+      </p:sp>
+      <p:sp>
+        <p:nvSpPr>
+          <p:cNvPr id="36" name="Shape 29"/>
+          <p:cNvSpPr/>
+          <p:nvPr/>
+        </p:nvSpPr>
+        <p:spPr>
+          <a:xfrm>
+            <a:off x="10195560" y="5779007"/>
+            <a:ext cx="1234440" cy="310896"/>
+          </a:xfrm>
+          <a:prstGeom prst="roundRect">
+            <a:avLst>
+              <a:gd name="adj" fmla="val 50000"/>
+            </a:avLst>
+          </a:prstGeom>
+          <a:solidFill>
+            <a:srgbClr val="E5F2F0"/>
+          </a:solidFill>
+          <a:ln/>
+        </p:spPr>
+        <p:txBody>
+          <a:bodyPr/>
+          <a:p/>
+        </p:txBody>
+      </p:sp>
+      <p:sp>
+        <p:nvSpPr>
+          <p:cNvPr id="37" name="Text 30"/>
+          <p:cNvSpPr txBox="1"/>
+          <p:nvPr/>
+        </p:nvSpPr>
+        <p:spPr>
+          <a:xfrm>
+            <a:off x="10195560" y="5779007"/>
+            <a:ext cx="1234440" cy="310896"/>
+          </a:xfrm>
+          <a:prstGeom prst="rect">
+            <a:avLst/>
+          </a:prstGeom>
+          <a:noFill/>
+          <a:ln/>
+        </p:spPr>
+        <p:txBody>
+          <a:bodyPr wrap="square" lIns="0" tIns="0" rIns="0" bIns="0" rtlCol="0" anchor="ctr"/>
+          <a:lstStyle/>
+          <a:p>
+            <a:pPr algn="ctr" indent="0" marL="0">
+              <a:buNone/>
+            </a:pPr>
+            <a:r>
+              <a:rPr lang="en-US" sz="1100" b="1" dirty="0">
+                <a:solidFill>
+                  <a:srgbClr val="01485C"/>
+                </a:solidFill>
+                <a:latin typeface="Calibri" pitchFamily="34" charset="0"/>
+                <a:ea typeface="Calibri" pitchFamily="34" charset="-122"/>
+                <a:cs typeface="Calibri" pitchFamily="34" charset="-120"/>
+              </a:rPr>
+              <a:t>LIVE</a:t>
+            </a:r>
+            <a:endParaRPr lang="en-US" sz="1100" dirty="0"/>
+          </a:p>
+        </p:txBody>
       </p:sp>
     </p:spTree>
   </p:cSld>
@@ -10298,6 +11340,920 @@
 </file>
 
 <file path=ppt/slides/slide8.xml><?xml version="1.0" encoding="utf-8"?>
+<p:sld xmlns:a="http://schemas.openxmlformats.org/drawingml/2006/main" xmlns:p="http://schemas.openxmlformats.org/presentationml/2006/main" xmlns:r="http://schemas.openxmlformats.org/officeDocument/2006/relationships">
+  <p:cSld>
+    <p:spTree>
+      <p:nvGrpSpPr>
+        <p:cNvPr id="1" name=""/>
+        <p:cNvGrpSpPr/>
+        <p:nvPr/>
+      </p:nvGrpSpPr>
+      <p:grpSpPr/>
+      <p:sp>
+        <p:nvSpPr>
+          <p:cNvPr id="2" name="Text 0"/>
+          <p:cNvSpPr txBox="1"/>
+          <p:nvPr/>
+        </p:nvSpPr>
+        <p:spPr>
+          <a:xfrm>
+            <a:off x="548640" y="320040"/>
+            <a:ext cx="11064240" cy="685800"/>
+          </a:xfrm>
+          <a:prstGeom prst="rect">
+            <a:avLst/>
+          </a:prstGeom>
+          <a:noFill/>
+          <a:ln/>
+        </p:spPr>
+        <p:txBody>
+          <a:bodyPr wrap="square" lIns="0" tIns="0" rIns="0" bIns="0" rtlCol="0" anchor="ctr"/>
+          <a:lstStyle/>
+          <a:p>
+            <a:pPr algn="l" indent="0" marL="0">
+              <a:buNone/>
+            </a:pPr>
+            <a:r>
+              <a:rPr lang="en-US" sz="3000" b="1" dirty="0">
+                <a:solidFill>
+                  <a:srgbClr val="01485C"/>
+                </a:solidFill>
+                <a:latin typeface="Calibri" pitchFamily="34" charset="0"/>
+                <a:ea typeface="Calibri" pitchFamily="34" charset="-122"/>
+                <a:cs typeface="Calibri" pitchFamily="34" charset="-120"/>
+              </a:rPr>
+              <a:t>Where it can run — PC enrolment</a:t>
+            </a:r>
+            <a:endParaRPr lang="en-US" sz="3000" dirty="0"/>
+          </a:p>
+        </p:txBody>
+      </p:sp>
+      <p:sp>
+        <p:nvSpPr>
+          <p:cNvPr id="3" name="Shape 1"/>
+          <p:cNvSpPr/>
+          <p:nvPr/>
+        </p:nvSpPr>
+        <p:spPr>
+          <a:xfrm>
+            <a:off x="548640" y="1371600"/>
+            <a:ext cx="3383280" cy="1554480"/>
+          </a:xfrm>
+          <a:prstGeom prst="roundRect">
+            <a:avLst>
+              <a:gd name="adj" fmla="val 7059"/>
+            </a:avLst>
+          </a:prstGeom>
+          <a:solidFill>
+            <a:srgbClr val="E5F2F0"/>
+          </a:solidFill>
+          <a:ln/>
+        </p:spPr>
+        <p:txBody>
+          <a:bodyPr/>
+          <a:p/>
+        </p:txBody>
+      </p:sp>
+      <p:sp>
+        <p:nvSpPr>
+          <p:cNvPr id="4" name="Text 2"/>
+          <p:cNvSpPr txBox="1"/>
+          <p:nvPr/>
+        </p:nvSpPr>
+        <p:spPr>
+          <a:xfrm>
+            <a:off x="777240" y="1536192"/>
+            <a:ext cx="2926080" cy="365760"/>
+          </a:xfrm>
+          <a:prstGeom prst="rect">
+            <a:avLst/>
+          </a:prstGeom>
+          <a:noFill/>
+          <a:ln/>
+        </p:spPr>
+        <p:txBody>
+          <a:bodyPr wrap="square" lIns="0" tIns="0" rIns="0" bIns="0" rtlCol="0" anchor="ctr"/>
+          <a:lstStyle/>
+          <a:p>
+            <a:pPr indent="0" marL="0">
+              <a:buNone/>
+            </a:pPr>
+            <a:r>
+              <a:rPr lang="en-US" sz="1600" b="1" dirty="0">
+                <a:solidFill>
+                  <a:srgbClr val="01485C"/>
+                </a:solidFill>
+                <a:latin typeface="Calibri" pitchFamily="34" charset="0"/>
+                <a:ea typeface="Calibri" pitchFamily="34" charset="-122"/>
+                <a:cs typeface="Calibri" pitchFamily="34" charset="-120"/>
+              </a:rPr>
+              <a:t>Enrol once per PC</a:t>
+            </a:r>
+            <a:endParaRPr lang="en-US" sz="1600" dirty="0"/>
+          </a:p>
+        </p:txBody>
+      </p:sp>
+      <p:sp>
+        <p:nvSpPr>
+          <p:cNvPr id="5" name="Text 3"/>
+          <p:cNvSpPr txBox="1"/>
+          <p:nvPr/>
+        </p:nvSpPr>
+        <p:spPr>
+          <a:xfrm>
+            <a:off x="777240" y="1938528"/>
+            <a:ext cx="2926080" cy="914400"/>
+          </a:xfrm>
+          <a:prstGeom prst="rect">
+            <a:avLst/>
+          </a:prstGeom>
+          <a:noFill/>
+          <a:ln/>
+        </p:spPr>
+        <p:txBody>
+          <a:bodyPr wrap="square" lIns="0" tIns="0" rIns="0" bIns="0" rtlCol="0" anchor="ctr"/>
+          <a:lstStyle/>
+          <a:p>
+            <a:pPr indent="0" marL="0">
+              <a:buNone/>
+            </a:pPr>
+            <a:r>
+              <a:rPr lang="en-US" sz="1250" dirty="0">
+                <a:solidFill>
+                  <a:srgbClr val="5F7178"/>
+                </a:solidFill>
+                <a:latin typeface="Calibri" pitchFamily="34" charset="0"/>
+                <a:ea typeface="Calibri" pitchFamily="34" charset="-122"/>
+                <a:cs typeface="Calibri" pitchFamily="34" charset="-120"/>
+              </a:rPr>
+              <a:t>First launch on a PC shows its machine ID; a PoC team member enters the enrolment password</a:t>
+            </a:r>
+            <a:endParaRPr lang="en-US" sz="1250" dirty="0"/>
+          </a:p>
+        </p:txBody>
+      </p:sp>
+      <p:sp>
+        <p:nvSpPr>
+          <p:cNvPr id="6" name="Shape 4"/>
+          <p:cNvSpPr/>
+          <p:nvPr/>
+        </p:nvSpPr>
+        <p:spPr>
+          <a:xfrm>
+            <a:off x="3977640" y="2148840"/>
+            <a:ext cx="320040" cy="0"/>
+          </a:xfrm>
+          <a:prstGeom prst="line">
+            <a:avLst/>
+          </a:prstGeom>
+          <a:noFill/>
+          <a:ln w="31750">
+            <a:solidFill>
+              <a:srgbClr val="01485C"/>
+            </a:solidFill>
+            <a:prstDash val="solid"/>
+            <a:tailEnd type="triangle"/>
+          </a:ln>
+        </p:spPr>
+        <p:txBody>
+          <a:bodyPr/>
+          <a:p/>
+        </p:txBody>
+      </p:sp>
+      <p:sp>
+        <p:nvSpPr>
+          <p:cNvPr id="7" name="Shape 5"/>
+          <p:cNvSpPr/>
+          <p:nvPr/>
+        </p:nvSpPr>
+        <p:spPr>
+          <a:xfrm>
+            <a:off x="4343400" y="1371600"/>
+            <a:ext cx="3383280" cy="1554480"/>
+          </a:xfrm>
+          <a:prstGeom prst="roundRect">
+            <a:avLst>
+              <a:gd name="adj" fmla="val 7059"/>
+            </a:avLst>
+          </a:prstGeom>
+          <a:solidFill>
+            <a:srgbClr val="E5F2F0"/>
+          </a:solidFill>
+          <a:ln/>
+        </p:spPr>
+        <p:txBody>
+          <a:bodyPr/>
+          <a:p/>
+        </p:txBody>
+      </p:sp>
+      <p:sp>
+        <p:nvSpPr>
+          <p:cNvPr id="8" name="Text 6"/>
+          <p:cNvSpPr txBox="1"/>
+          <p:nvPr/>
+        </p:nvSpPr>
+        <p:spPr>
+          <a:xfrm>
+            <a:off x="4572000" y="1536192"/>
+            <a:ext cx="2926080" cy="365760"/>
+          </a:xfrm>
+          <a:prstGeom prst="rect">
+            <a:avLst/>
+          </a:prstGeom>
+          <a:noFill/>
+          <a:ln/>
+        </p:spPr>
+        <p:txBody>
+          <a:bodyPr wrap="square" lIns="0" tIns="0" rIns="0" bIns="0" rtlCol="0" anchor="ctr"/>
+          <a:lstStyle/>
+          <a:p>
+            <a:pPr indent="0" marL="0">
+              <a:buNone/>
+            </a:pPr>
+            <a:r>
+              <a:rPr lang="en-US" sz="1600" b="1" dirty="0">
+                <a:solidFill>
+                  <a:srgbClr val="01485C"/>
+                </a:solidFill>
+                <a:latin typeface="Calibri" pitchFamily="34" charset="0"/>
+                <a:ea typeface="Calibri" pitchFamily="34" charset="-122"/>
+                <a:cs typeface="Calibri" pitchFamily="34" charset="-120"/>
+              </a:rPr>
+              <a:t>Bound to the motherboard</a:t>
+            </a:r>
+            <a:endParaRPr lang="en-US" sz="1600" dirty="0"/>
+          </a:p>
+        </p:txBody>
+      </p:sp>
+      <p:sp>
+        <p:nvSpPr>
+          <p:cNvPr id="9" name="Text 7"/>
+          <p:cNvSpPr txBox="1"/>
+          <p:nvPr/>
+        </p:nvSpPr>
+        <p:spPr>
+          <a:xfrm>
+            <a:off x="4572000" y="1938528"/>
+            <a:ext cx="2926080" cy="914400"/>
+          </a:xfrm>
+          <a:prstGeom prst="rect">
+            <a:avLst/>
+          </a:prstGeom>
+          <a:noFill/>
+          <a:ln/>
+        </p:spPr>
+        <p:txBody>
+          <a:bodyPr wrap="square" lIns="0" tIns="0" rIns="0" bIns="0" rtlCol="0" anchor="ctr"/>
+          <a:lstStyle/>
+          <a:p>
+            <a:pPr indent="0" marL="0">
+              <a:buNone/>
+            </a:pPr>
+            <a:r>
+              <a:rPr lang="en-US" sz="1250" dirty="0">
+                <a:solidFill>
+                  <a:srgbClr val="5F7178"/>
+                </a:solidFill>
+                <a:latin typeface="Calibri" pitchFamily="34" charset="0"/>
+                <a:ea typeface="Calibri" pitchFamily="34" charset="-122"/>
+                <a:cs typeface="Calibri" pitchFamily="34" charset="-120"/>
+              </a:rPr>
+              <a:t>ID = hash of system UUID, board serial, drive serial and hostname — a copied drive stays locked elsewhere</a:t>
+            </a:r>
+            <a:endParaRPr lang="en-US" sz="1250" dirty="0"/>
+          </a:p>
+        </p:txBody>
+      </p:sp>
+      <p:sp>
+        <p:nvSpPr>
+          <p:cNvPr id="10" name="Shape 8"/>
+          <p:cNvSpPr/>
+          <p:nvPr/>
+        </p:nvSpPr>
+        <p:spPr>
+          <a:xfrm>
+            <a:off x="7772400" y="2148840"/>
+            <a:ext cx="320040" cy="0"/>
+          </a:xfrm>
+          <a:prstGeom prst="line">
+            <a:avLst/>
+          </a:prstGeom>
+          <a:noFill/>
+          <a:ln w="31750">
+            <a:solidFill>
+              <a:srgbClr val="01485C"/>
+            </a:solidFill>
+            <a:prstDash val="solid"/>
+            <a:tailEnd type="triangle"/>
+          </a:ln>
+        </p:spPr>
+        <p:txBody>
+          <a:bodyPr/>
+          <a:p/>
+        </p:txBody>
+      </p:sp>
+      <p:sp>
+        <p:nvSpPr>
+          <p:cNvPr id="11" name="Shape 9"/>
+          <p:cNvSpPr/>
+          <p:nvPr/>
+        </p:nvSpPr>
+        <p:spPr>
+          <a:xfrm>
+            <a:off x="8138160" y="1371600"/>
+            <a:ext cx="3383280" cy="1554480"/>
+          </a:xfrm>
+          <a:prstGeom prst="roundRect">
+            <a:avLst>
+              <a:gd name="adj" fmla="val 7059"/>
+            </a:avLst>
+          </a:prstGeom>
+          <a:solidFill>
+            <a:srgbClr val="01485C"/>
+          </a:solidFill>
+          <a:ln/>
+        </p:spPr>
+        <p:txBody>
+          <a:bodyPr/>
+          <a:p/>
+        </p:txBody>
+      </p:sp>
+      <p:sp>
+        <p:nvSpPr>
+          <p:cNvPr id="12" name="Text 10"/>
+          <p:cNvSpPr txBox="1"/>
+          <p:nvPr/>
+        </p:nvSpPr>
+        <p:spPr>
+          <a:xfrm>
+            <a:off x="8366760" y="1536192"/>
+            <a:ext cx="2926080" cy="365760"/>
+          </a:xfrm>
+          <a:prstGeom prst="rect">
+            <a:avLst/>
+          </a:prstGeom>
+          <a:noFill/>
+          <a:ln/>
+        </p:spPr>
+        <p:txBody>
+          <a:bodyPr wrap="square" lIns="0" tIns="0" rIns="0" bIns="0" rtlCol="0" anchor="ctr"/>
+          <a:lstStyle/>
+          <a:p>
+            <a:pPr indent="0" marL="0">
+              <a:buNone/>
+            </a:pPr>
+            <a:r>
+              <a:rPr lang="en-US" sz="1600" b="1" dirty="0">
+                <a:solidFill>
+                  <a:srgbClr val="FFFFFF"/>
+                </a:solidFill>
+                <a:latin typeface="Calibri" pitchFamily="34" charset="0"/>
+                <a:ea typeface="Calibri" pitchFamily="34" charset="-122"/>
+                <a:cs typeface="Calibri" pitchFamily="34" charset="-120"/>
+              </a:rPr>
+              <a:t>12-month term</a:t>
+            </a:r>
+            <a:endParaRPr lang="en-US" sz="1600" dirty="0"/>
+          </a:p>
+        </p:txBody>
+      </p:sp>
+      <p:sp>
+        <p:nvSpPr>
+          <p:cNvPr id="13" name="Text 11"/>
+          <p:cNvSpPr txBox="1"/>
+          <p:nvPr/>
+        </p:nvSpPr>
+        <p:spPr>
+          <a:xfrm>
+            <a:off x="8366760" y="1938528"/>
+            <a:ext cx="2926080" cy="914400"/>
+          </a:xfrm>
+          <a:prstGeom prst="rect">
+            <a:avLst/>
+          </a:prstGeom>
+          <a:noFill/>
+          <a:ln/>
+        </p:spPr>
+        <p:txBody>
+          <a:bodyPr wrap="square" lIns="0" tIns="0" rIns="0" bIns="0" rtlCol="0" anchor="ctr"/>
+          <a:lstStyle/>
+          <a:p>
+            <a:pPr indent="0" marL="0">
+              <a:buNone/>
+            </a:pPr>
+            <a:r>
+              <a:rPr lang="en-US" sz="1250" dirty="0">
+                <a:solidFill>
+                  <a:srgbClr val="6CCAD4"/>
+                </a:solidFill>
+                <a:latin typeface="Calibri" pitchFamily="34" charset="0"/>
+                <a:ea typeface="Calibri" pitchFamily="34" charset="-122"/>
+                <a:cs typeface="Calibri" pitchFamily="34" charset="-120"/>
+              </a:rPr>
+              <a:t>Each enrolment records the bundle version and expires; renewal brings the PC back for updates</a:t>
+            </a:r>
+            <a:endParaRPr lang="en-US" sz="1250" dirty="0"/>
+          </a:p>
+        </p:txBody>
+      </p:sp>
+      <p:sp>
+        <p:nvSpPr>
+          <p:cNvPr id="14" name="Text 12"/>
+          <p:cNvSpPr txBox="1"/>
+          <p:nvPr/>
+        </p:nvSpPr>
+        <p:spPr>
+          <a:xfrm>
+            <a:off x="548640" y="3383280"/>
+            <a:ext cx="6949440" cy="411480"/>
+          </a:xfrm>
+          <a:prstGeom prst="rect">
+            <a:avLst/>
+          </a:prstGeom>
+          <a:noFill/>
+          <a:ln/>
+        </p:spPr>
+        <p:txBody>
+          <a:bodyPr wrap="square" lIns="0" tIns="0" rIns="0" bIns="0" rtlCol="0" anchor="ctr"/>
+          <a:lstStyle/>
+          <a:p>
+            <a:pPr indent="0" marL="0">
+              <a:buNone/>
+            </a:pPr>
+            <a:r>
+              <a:rPr lang="en-US" sz="1400" b="1" dirty="0">
+                <a:solidFill>
+                  <a:srgbClr val="01485C"/>
+                </a:solidFill>
+                <a:latin typeface="Calibri" pitchFamily="34" charset="0"/>
+                <a:ea typeface="Calibri" pitchFamily="34" charset="-122"/>
+                <a:cs typeface="Calibri" pitchFamily="34" charset="-120"/>
+              </a:rPr>
+              <a:t>Registry   </a:t>
+            </a:r>
+            <a:pPr indent="0" marL="0">
+              <a:buNone/>
+            </a:pPr>
+            <a:r>
+              <a:rPr lang="en-US" sz="1400" dirty="0">
+                <a:solidFill>
+                  <a:srgbClr val="17272E"/>
+                </a:solidFill>
+                <a:latin typeface="Calibri" pitchFamily="34" charset="0"/>
+                <a:ea typeface="Calibri" pitchFamily="34" charset="-122"/>
+                <a:cs typeface="Calibri" pitchFamily="34" charset="-120"/>
+              </a:rPr>
+              <a:t>Ed25519-signed entries, verified at every launch — an edited entry stops counting</a:t>
+            </a:r>
+            <a:endParaRPr lang="en-US" sz="1400" dirty="0"/>
+          </a:p>
+        </p:txBody>
+      </p:sp>
+      <p:sp>
+        <p:nvSpPr>
+          <p:cNvPr id="15" name="Text 13"/>
+          <p:cNvSpPr txBox="1"/>
+          <p:nvPr/>
+        </p:nvSpPr>
+        <p:spPr>
+          <a:xfrm>
+            <a:off x="548640" y="3858768"/>
+            <a:ext cx="6949440" cy="411480"/>
+          </a:xfrm>
+          <a:prstGeom prst="rect">
+            <a:avLst/>
+          </a:prstGeom>
+          <a:noFill/>
+          <a:ln/>
+        </p:spPr>
+        <p:txBody>
+          <a:bodyPr wrap="square" lIns="0" tIns="0" rIns="0" bIns="0" rtlCol="0" anchor="ctr"/>
+          <a:lstStyle/>
+          <a:p>
+            <a:pPr indent="0" marL="0">
+              <a:buNone/>
+            </a:pPr>
+            <a:r>
+              <a:rPr lang="en-US" sz="1400" b="1" dirty="0">
+                <a:solidFill>
+                  <a:srgbClr val="01485C"/>
+                </a:solidFill>
+                <a:latin typeface="Calibri" pitchFamily="34" charset="0"/>
+                <a:ea typeface="Calibri" pitchFamily="34" charset="-122"/>
+                <a:cs typeface="Calibri" pitchFamily="34" charset="-120"/>
+              </a:rPr>
+              <a:t>Key custody   </a:t>
+            </a:r>
+            <a:pPr indent="0" marL="0">
+              <a:buNone/>
+            </a:pPr>
+            <a:r>
+              <a:rPr lang="en-US" sz="1400" dirty="0">
+                <a:solidFill>
+                  <a:srgbClr val="17272E"/>
+                </a:solidFill>
+                <a:latin typeface="Calibri" pitchFamily="34" charset="0"/>
+                <a:ea typeface="Calibri" pitchFamily="34" charset="-122"/>
+                <a:cs typeface="Calibri" pitchFamily="34" charset="-120"/>
+              </a:rPr>
+              <a:t>Signing key stored only encrypted with the enrolment password (PBKDF2, 600,000 rounds)</a:t>
+            </a:r>
+            <a:endParaRPr lang="en-US" sz="1400" dirty="0"/>
+          </a:p>
+        </p:txBody>
+      </p:sp>
+      <p:sp>
+        <p:nvSpPr>
+          <p:cNvPr id="16" name="Text 14"/>
+          <p:cNvSpPr txBox="1"/>
+          <p:nvPr/>
+        </p:nvSpPr>
+        <p:spPr>
+          <a:xfrm>
+            <a:off x="548640" y="4334256"/>
+            <a:ext cx="6949440" cy="411480"/>
+          </a:xfrm>
+          <a:prstGeom prst="rect">
+            <a:avLst/>
+          </a:prstGeom>
+          <a:noFill/>
+          <a:ln/>
+        </p:spPr>
+        <p:txBody>
+          <a:bodyPr wrap="square" lIns="0" tIns="0" rIns="0" bIns="0" rtlCol="0" anchor="ctr"/>
+          <a:lstStyle/>
+          <a:p>
+            <a:pPr indent="0" marL="0">
+              <a:buNone/>
+            </a:pPr>
+            <a:r>
+              <a:rPr lang="en-US" sz="1400" b="1" dirty="0">
+                <a:solidFill>
+                  <a:srgbClr val="01485C"/>
+                </a:solidFill>
+                <a:latin typeface="Calibri" pitchFamily="34" charset="0"/>
+                <a:ea typeface="Calibri" pitchFamily="34" charset="-122"/>
+                <a:cs typeface="Calibri" pitchFamily="34" charset="-120"/>
+              </a:rPr>
+              <a:t>Enforcement   </a:t>
+            </a:r>
+            <a:pPr indent="0" marL="0">
+              <a:buNone/>
+            </a:pPr>
+            <a:r>
+              <a:rPr lang="en-US" sz="1400" dirty="0">
+                <a:solidFill>
+                  <a:srgbClr val="17272E"/>
+                </a:solidFill>
+                <a:latin typeface="Calibri" pitchFamily="34" charset="0"/>
+                <a:ea typeface="Calibri" pitchFamily="34" charset="-122"/>
+                <a:cs typeface="Calibri" pitchFamily="34" charset="-120"/>
+              </a:rPr>
+              <a:t>Portal and both engines lock unless this PC is enrolled and within its term</a:t>
+            </a:r>
+            <a:endParaRPr lang="en-US" sz="1400" dirty="0"/>
+          </a:p>
+        </p:txBody>
+      </p:sp>
+      <p:sp>
+        <p:nvSpPr>
+          <p:cNvPr id="17" name="Text 15"/>
+          <p:cNvSpPr txBox="1"/>
+          <p:nvPr/>
+        </p:nvSpPr>
+        <p:spPr>
+          <a:xfrm>
+            <a:off x="548640" y="4809744"/>
+            <a:ext cx="6949440" cy="411480"/>
+          </a:xfrm>
+          <a:prstGeom prst="rect">
+            <a:avLst/>
+          </a:prstGeom>
+          <a:noFill/>
+          <a:ln/>
+        </p:spPr>
+        <p:txBody>
+          <a:bodyPr wrap="square" lIns="0" tIns="0" rIns="0" bIns="0" rtlCol="0" anchor="ctr"/>
+          <a:lstStyle/>
+          <a:p>
+            <a:pPr indent="0" marL="0">
+              <a:buNone/>
+            </a:pPr>
+            <a:r>
+              <a:rPr lang="en-US" sz="1400" b="1" dirty="0">
+                <a:solidFill>
+                  <a:srgbClr val="01485C"/>
+                </a:solidFill>
+                <a:latin typeface="Calibri" pitchFamily="34" charset="0"/>
+                <a:ea typeface="Calibri" pitchFamily="34" charset="-122"/>
+                <a:cs typeface="Calibri" pitchFamily="34" charset="-120"/>
+              </a:rPr>
+              <a:t>Audit   </a:t>
+            </a:r>
+            <a:pPr indent="0" marL="0">
+              <a:buNone/>
+            </a:pPr>
+            <a:r>
+              <a:rPr lang="en-US" sz="1400" dirty="0">
+                <a:solidFill>
+                  <a:srgbClr val="17272E"/>
+                </a:solidFill>
+                <a:latin typeface="Calibri" pitchFamily="34" charset="0"/>
+                <a:ea typeface="Calibri" pitchFamily="34" charset="-122"/>
+                <a:cs typeface="Calibri" pitchFamily="34" charset="-120"/>
+              </a:rPr>
+              <a:t>Every launch, enrolment, renewal, revocation and failed password — with PC, user, network state</a:t>
+            </a:r>
+            <a:endParaRPr lang="en-US" sz="1400" dirty="0"/>
+          </a:p>
+        </p:txBody>
+      </p:sp>
+      <p:sp>
+        <p:nvSpPr>
+          <p:cNvPr id="18" name="Shape 16"/>
+          <p:cNvSpPr/>
+          <p:nvPr/>
+        </p:nvSpPr>
+        <p:spPr>
+          <a:xfrm>
+            <a:off x="7863840" y="3383280"/>
+            <a:ext cx="3794760" cy="2103120"/>
+          </a:xfrm>
+          <a:prstGeom prst="roundRect">
+            <a:avLst>
+              <a:gd name="adj" fmla="val 5217"/>
+            </a:avLst>
+          </a:prstGeom>
+          <a:solidFill>
+            <a:srgbClr val="FDF0E4"/>
+          </a:solidFill>
+          <a:ln w="19050">
+            <a:solidFill>
+              <a:srgbClr val="B4540A"/>
+            </a:solidFill>
+            <a:prstDash val="solid"/>
+          </a:ln>
+        </p:spPr>
+        <p:txBody>
+          <a:bodyPr/>
+          <a:p/>
+        </p:txBody>
+      </p:sp>
+      <p:sp>
+        <p:nvSpPr>
+          <p:cNvPr id="19" name="Shape 17"/>
+          <p:cNvSpPr/>
+          <p:nvPr/>
+        </p:nvSpPr>
+        <p:spPr>
+          <a:xfrm>
+            <a:off x="8138160" y="3611880"/>
+            <a:ext cx="640080" cy="640080"/>
+          </a:xfrm>
+          <a:prstGeom prst="ellipse">
+            <a:avLst/>
+          </a:prstGeom>
+          <a:solidFill>
+            <a:srgbClr val="B4540A"/>
+          </a:solidFill>
+          <a:ln/>
+        </p:spPr>
+        <p:txBody>
+          <a:bodyPr/>
+          <a:p/>
+        </p:txBody>
+      </p:sp>
+      <p:pic>
+        <p:nvPicPr>
+          <p:cNvPr id="20" name="Image 0" descr="icon_warn_w.png">    </p:cNvPr>
+          <p:cNvPicPr>
+            <a:picLocks noChangeAspect="1"/>
+          </p:cNvPicPr>
+          <p:nvPr/>
+        </p:nvPicPr>
+        <p:blipFill>
+          <a:blip r:embed="rId2"/>
+          <a:stretch>
+            <a:fillRect/>
+          </a:stretch>
+        </p:blipFill>
+        <p:spPr>
+          <a:xfrm>
+            <a:off x="8304581" y="3778301"/>
+            <a:ext cx="307238" cy="307238"/>
+          </a:xfrm>
+          <a:prstGeom prst="rect">
+            <a:avLst/>
+          </a:prstGeom>
+        </p:spPr>
+      </p:pic>
+      <p:sp>
+        <p:nvSpPr>
+          <p:cNvPr id="21" name="Text 18"/>
+          <p:cNvSpPr txBox="1"/>
+          <p:nvPr/>
+        </p:nvSpPr>
+        <p:spPr>
+          <a:xfrm>
+            <a:off x="8915400" y="3703320"/>
+            <a:ext cx="2651760" cy="457200"/>
+          </a:xfrm>
+          <a:prstGeom prst="rect">
+            <a:avLst/>
+          </a:prstGeom>
+          <a:noFill/>
+          <a:ln/>
+        </p:spPr>
+        <p:txBody>
+          <a:bodyPr wrap="square" lIns="0" tIns="0" rIns="0" bIns="0" rtlCol="0" anchor="ctr"/>
+          <a:lstStyle/>
+          <a:p>
+            <a:pPr indent="0" marL="0">
+              <a:buNone/>
+            </a:pPr>
+            <a:r>
+              <a:rPr lang="en-US" sz="1500" b="1" dirty="0">
+                <a:solidFill>
+                  <a:srgbClr val="B4540A"/>
+                </a:solidFill>
+                <a:latin typeface="Calibri" pitchFamily="34" charset="0"/>
+                <a:ea typeface="Calibri" pitchFamily="34" charset="-122"/>
+                <a:cs typeface="Calibri" pitchFamily="34" charset="-120"/>
+              </a:rPr>
+              <a:t>Not DRM — by design</a:t>
+            </a:r>
+            <a:endParaRPr lang="en-US" sz="1500" dirty="0"/>
+          </a:p>
+        </p:txBody>
+      </p:sp>
+      <p:sp>
+        <p:nvSpPr>
+          <p:cNvPr id="22" name="Text 19"/>
+          <p:cNvSpPr txBox="1"/>
+          <p:nvPr/>
+        </p:nvSpPr>
+        <p:spPr>
+          <a:xfrm>
+            <a:off x="8138160" y="4343400"/>
+            <a:ext cx="3291840" cy="1005840"/>
+          </a:xfrm>
+          <a:prstGeom prst="rect">
+            <a:avLst/>
+          </a:prstGeom>
+          <a:noFill/>
+          <a:ln/>
+        </p:spPr>
+        <p:txBody>
+          <a:bodyPr wrap="square" lIns="0" tIns="0" rIns="0" bIns="0" rtlCol="0" anchor="ctr"/>
+          <a:lstStyle/>
+          <a:p>
+            <a:pPr indent="0" marL="0">
+              <a:buNone/>
+            </a:pPr>
+            <a:r>
+              <a:rPr lang="en-US" sz="1250" dirty="0">
+                <a:solidFill>
+                  <a:srgbClr val="17272E"/>
+                </a:solidFill>
+                <a:latin typeface="Calibri" pitchFamily="34" charset="0"/>
+                <a:ea typeface="Calibri" pitchFamily="34" charset="-122"/>
+                <a:cs typeface="Calibri" pitchFamily="34" charset="-120"/>
+              </a:rPr>
+              <a:t>The check lives on the drive: a BitLocker holder who edits the Python could remove it. It is an administrative control with evidence, not copy protection.</a:t>
+            </a:r>
+            <a:endParaRPr lang="en-US" sz="1250" dirty="0"/>
+          </a:p>
+        </p:txBody>
+      </p:sp>
+      <p:sp>
+        <p:nvSpPr>
+          <p:cNvPr id="23" name="Shape 20"/>
+          <p:cNvSpPr/>
+          <p:nvPr/>
+        </p:nvSpPr>
+        <p:spPr>
+          <a:xfrm>
+            <a:off x="0" y="6793992"/>
+            <a:ext cx="2040636" cy="64008"/>
+          </a:xfrm>
+          <a:prstGeom prst="rect">
+            <a:avLst/>
+          </a:prstGeom>
+          <a:solidFill>
+            <a:srgbClr val="01485C"/>
+          </a:solidFill>
+          <a:ln/>
+        </p:spPr>
+      </p:sp>
+      <p:sp>
+        <p:nvSpPr>
+          <p:cNvPr id="24" name="Shape 21"/>
+          <p:cNvSpPr/>
+          <p:nvPr/>
+        </p:nvSpPr>
+        <p:spPr>
+          <a:xfrm>
+            <a:off x="2031492" y="6793992"/>
+            <a:ext cx="2040636" cy="64008"/>
+          </a:xfrm>
+          <a:prstGeom prst="rect">
+            <a:avLst/>
+          </a:prstGeom>
+          <a:solidFill>
+            <a:srgbClr val="146175"/>
+          </a:solidFill>
+          <a:ln/>
+        </p:spPr>
+      </p:sp>
+      <p:sp>
+        <p:nvSpPr>
+          <p:cNvPr id="25" name="Shape 22"/>
+          <p:cNvSpPr/>
+          <p:nvPr/>
+        </p:nvSpPr>
+        <p:spPr>
+          <a:xfrm>
+            <a:off x="4062984" y="6793992"/>
+            <a:ext cx="2040636" cy="64008"/>
+          </a:xfrm>
+          <a:prstGeom prst="rect">
+            <a:avLst/>
+          </a:prstGeom>
+          <a:solidFill>
+            <a:srgbClr val="11B5AE"/>
+          </a:solidFill>
+          <a:ln/>
+        </p:spPr>
+      </p:sp>
+      <p:sp>
+        <p:nvSpPr>
+          <p:cNvPr id="26" name="Shape 23"/>
+          <p:cNvSpPr/>
+          <p:nvPr/>
+        </p:nvSpPr>
+        <p:spPr>
+          <a:xfrm>
+            <a:off x="6094476" y="6793992"/>
+            <a:ext cx="2040636" cy="64008"/>
+          </a:xfrm>
+          <a:prstGeom prst="rect">
+            <a:avLst/>
+          </a:prstGeom>
+          <a:solidFill>
+            <a:srgbClr val="6CCAD4"/>
+          </a:solidFill>
+          <a:ln/>
+        </p:spPr>
+      </p:sp>
+      <p:sp>
+        <p:nvSpPr>
+          <p:cNvPr id="27" name="Shape 24"/>
+          <p:cNvSpPr/>
+          <p:nvPr/>
+        </p:nvSpPr>
+        <p:spPr>
+          <a:xfrm>
+            <a:off x="8125968" y="6793992"/>
+            <a:ext cx="2040636" cy="64008"/>
+          </a:xfrm>
+          <a:prstGeom prst="rect">
+            <a:avLst/>
+          </a:prstGeom>
+          <a:solidFill>
+            <a:srgbClr val="7FC04C"/>
+          </a:solidFill>
+          <a:ln/>
+        </p:spPr>
+      </p:sp>
+      <p:sp>
+        <p:nvSpPr>
+          <p:cNvPr id="28" name="Shape 25"/>
+          <p:cNvSpPr/>
+          <p:nvPr/>
+        </p:nvSpPr>
+        <p:spPr>
+          <a:xfrm>
+            <a:off x="10157460" y="6793992"/>
+            <a:ext cx="2040636" cy="64008"/>
+          </a:xfrm>
+          <a:prstGeom prst="rect">
+            <a:avLst/>
+          </a:prstGeom>
+          <a:solidFill>
+            <a:srgbClr val="E1DD57"/>
+          </a:solidFill>
+          <a:ln/>
+        </p:spPr>
+      </p:sp>
+    </p:spTree>
+  </p:cSld>
+  <p:clrMapOvr>
+    <a:masterClrMapping/>
+  </p:clrMapOvr>
+</p:sld>
+</file>
+
+<file path=ppt/slides/slide9.xml><?xml version="1.0" encoding="utf-8"?>
 <p:sld xmlns:a="http://schemas.openxmlformats.org/drawingml/2006/main" xmlns:r="http://schemas.openxmlformats.org/officeDocument/2006/relationships" xmlns:p="http://schemas.openxmlformats.org/presentationml/2006/main">
   <p:cSld name="Slide 8">
     <p:bg>
@@ -11357,668 +13313,6 @@
       <p:sp>
         <p:nvSpPr>
           <p:cNvPr id="38" name="Shape 30"/>
-          <p:cNvSpPr/>
-          <p:nvPr/>
-        </p:nvSpPr>
-        <p:spPr>
-          <a:xfrm>
-            <a:off x="10157460" y="6793992"/>
-            <a:ext cx="2040636" cy="64008"/>
-          </a:xfrm>
-          <a:prstGeom prst="rect">
-            <a:avLst/>
-          </a:prstGeom>
-          <a:solidFill>
-            <a:srgbClr val="E1DD57"/>
-          </a:solidFill>
-          <a:ln/>
-        </p:spPr>
-      </p:sp>
-    </p:spTree>
-  </p:cSld>
-  <p:clrMapOvr>
-    <a:masterClrMapping/>
-  </p:clrMapOvr>
-</p:sld>
-</file>
-
-<file path=ppt/slides/slide9.xml><?xml version="1.0" encoding="utf-8"?>
-<p:sld xmlns:a="http://schemas.openxmlformats.org/drawingml/2006/main" xmlns:r="http://schemas.openxmlformats.org/officeDocument/2006/relationships" xmlns:p="http://schemas.openxmlformats.org/presentationml/2006/main">
-  <p:cSld name="Slide 9">
-    <p:bg>
-      <p:bgPr>
-        <a:solidFill>
-          <a:srgbClr val="FFFFFF"/>
-        </a:solidFill>
-      </p:bgPr>
-    </p:bg>
-    <p:spTree>
-      <p:nvGrpSpPr>
-        <p:cNvPr id="1" name=""/>
-        <p:cNvGrpSpPr/>
-        <p:nvPr/>
-      </p:nvGrpSpPr>
-      <p:grpSpPr>
-        <a:xfrm>
-          <a:off x="0" y="0"/>
-          <a:ext cx="0" cy="0"/>
-          <a:chOff x="0" y="0"/>
-          <a:chExt cx="0" cy="0"/>
-        </a:xfrm>
-      </p:grpSpPr>
-      <p:sp>
-        <p:nvSpPr>
-          <p:cNvPr id="2" name="Text 0"/>
-          <p:cNvSpPr txBox="1"/>
-          <p:nvPr/>
-        </p:nvSpPr>
-        <p:spPr>
-          <a:xfrm>
-            <a:off x="548640" y="320040"/>
-            <a:ext cx="11064240" cy="685800"/>
-          </a:xfrm>
-          <a:prstGeom prst="rect">
-            <a:avLst/>
-          </a:prstGeom>
-          <a:noFill/>
-          <a:ln/>
-        </p:spPr>
-        <p:txBody>
-          <a:bodyPr wrap="square" lIns="0" tIns="0" rIns="0" bIns="0" rtlCol="0" anchor="ctr"/>
-          <a:lstStyle/>
-          <a:p>
-            <a:pPr algn="l" indent="0" marL="0">
-              <a:buNone/>
-            </a:pPr>
-            <a:r>
-              <a:rPr lang="en-US" sz="3000" b="1" dirty="0">
-                <a:solidFill>
-                  <a:srgbClr val="01485C"/>
-                </a:solidFill>
-                <a:latin typeface="Calibri" pitchFamily="34" charset="0"/>
-                <a:ea typeface="Calibri" pitchFamily="34" charset="-122"/>
-                <a:cs typeface="Calibri" pitchFamily="34" charset="-120"/>
-              </a:rPr>
-              <a:t>Audit &amp; accountability</a:t>
-            </a:r>
-            <a:endParaRPr lang="en-US" sz="3000" dirty="0"/>
-          </a:p>
-        </p:txBody>
-      </p:sp>
-      <p:sp>
-        <p:nvSpPr>
-          <p:cNvPr id="3" name="Shape 1"/>
-          <p:cNvSpPr/>
-          <p:nvPr/>
-        </p:nvSpPr>
-        <p:spPr>
-          <a:xfrm>
-            <a:off x="548640" y="1463040"/>
-            <a:ext cx="3611880" cy="3108960"/>
-          </a:xfrm>
-          <a:prstGeom prst="roundRect">
-            <a:avLst>
-              <a:gd name="adj" fmla="val 3529"/>
-            </a:avLst>
-          </a:prstGeom>
-          <a:solidFill>
-            <a:srgbClr val="E5F2F0"/>
-          </a:solidFill>
-          <a:ln/>
-        </p:spPr>
-      </p:sp>
-      <p:sp>
-        <p:nvSpPr>
-          <p:cNvPr id="4" name="Shape 2"/>
-          <p:cNvSpPr/>
-          <p:nvPr/>
-        </p:nvSpPr>
-        <p:spPr>
-          <a:xfrm>
-            <a:off x="822960" y="1755648"/>
-            <a:ext cx="658368" cy="658368"/>
-          </a:xfrm>
-          <a:prstGeom prst="ellipse">
-            <a:avLst/>
-          </a:prstGeom>
-          <a:solidFill>
-            <a:srgbClr val="01485C"/>
-          </a:solidFill>
-          <a:ln/>
-        </p:spPr>
-      </p:sp>
-      <p:pic>
-        <p:nvPicPr>
-          <p:cNvPr id="5" name="Image 0" descr="icon_clipboard_w.png">    </p:cNvPr>
-          <p:cNvPicPr>
-            <a:picLocks noChangeAspect="1"/>
-          </p:cNvPicPr>
-          <p:nvPr/>
-        </p:nvPicPr>
-        <p:blipFill>
-          <a:blip r:embed="rId1"/>
-          <a:stretch>
-            <a:fillRect/>
-          </a:stretch>
-        </p:blipFill>
-        <p:spPr>
-          <a:xfrm>
-            <a:off x="994136" y="1926824"/>
-            <a:ext cx="316017" cy="316017"/>
-          </a:xfrm>
-          <a:prstGeom prst="rect">
-            <a:avLst/>
-          </a:prstGeom>
-        </p:spPr>
-      </p:pic>
-      <p:sp>
-        <p:nvSpPr>
-          <p:cNvPr id="6" name="Text 3"/>
-          <p:cNvSpPr txBox="1"/>
-          <p:nvPr/>
-        </p:nvSpPr>
-        <p:spPr>
-          <a:xfrm>
-            <a:off x="822960" y="2606040"/>
-            <a:ext cx="3063240" cy="457200"/>
-          </a:xfrm>
-          <a:prstGeom prst="rect">
-            <a:avLst/>
-          </a:prstGeom>
-          <a:noFill/>
-          <a:ln/>
-        </p:spPr>
-        <p:txBody>
-          <a:bodyPr wrap="square" lIns="0" tIns="0" rIns="0" bIns="0" rtlCol="0" anchor="ctr"/>
-          <a:lstStyle/>
-          <a:p>
-            <a:pPr indent="0" marL="0">
-              <a:buNone/>
-            </a:pPr>
-            <a:r>
-              <a:rPr lang="en-US" sz="1600" b="1" dirty="0">
-                <a:solidFill>
-                  <a:srgbClr val="01485C"/>
-                </a:solidFill>
-                <a:latin typeface="Calibri" pitchFamily="34" charset="0"/>
-                <a:ea typeface="Calibri" pitchFamily="34" charset="-122"/>
-                <a:cs typeface="Calibri" pitchFamily="34" charset="-120"/>
-              </a:rPr>
-              <a:t>audit.log</a:t>
-            </a:r>
-            <a:endParaRPr lang="en-US" sz="1600" dirty="0"/>
-          </a:p>
-        </p:txBody>
-      </p:sp>
-      <p:sp>
-        <p:nvSpPr>
-          <p:cNvPr id="7" name="Text 4"/>
-          <p:cNvSpPr txBox="1"/>
-          <p:nvPr/>
-        </p:nvSpPr>
-        <p:spPr>
-          <a:xfrm>
-            <a:off x="822960" y="3108960"/>
-            <a:ext cx="3063240" cy="1371600"/>
-          </a:xfrm>
-          <a:prstGeom prst="rect">
-            <a:avLst/>
-          </a:prstGeom>
-          <a:noFill/>
-          <a:ln/>
-        </p:spPr>
-        <p:txBody>
-          <a:bodyPr wrap="square" lIns="0" tIns="0" rIns="0" bIns="0" rtlCol="0" anchor="ctr"/>
-          <a:lstStyle/>
-          <a:p>
-            <a:pPr indent="0" marL="0">
-              <a:buNone/>
-            </a:pPr>
-            <a:r>
-              <a:rPr lang="en-US" sz="1250" dirty="0">
-                <a:solidFill>
-                  <a:srgbClr val="17272E"/>
-                </a:solidFill>
-                <a:latin typeface="Calibri" pitchFamily="34" charset="0"/>
-                <a:ea typeface="Calibri" pitchFamily="34" charset="-122"/>
-                <a:cs typeface="Calibri" pitchFamily="34" charset="-120"/>
-              </a:rPr>
-              <a:t>Every report generation: timestamp, Windows username, period, scope — plus every history unlock attempt, including failures</a:t>
-            </a:r>
-            <a:endParaRPr lang="en-US" sz="1250" dirty="0"/>
-          </a:p>
-        </p:txBody>
-      </p:sp>
-      <p:sp>
-        <p:nvSpPr>
-          <p:cNvPr id="8" name="Shape 5"/>
-          <p:cNvSpPr/>
-          <p:nvPr/>
-        </p:nvSpPr>
-        <p:spPr>
-          <a:xfrm>
-            <a:off x="4370832" y="1463040"/>
-            <a:ext cx="3611880" cy="3108960"/>
-          </a:xfrm>
-          <a:prstGeom prst="roundRect">
-            <a:avLst>
-              <a:gd name="adj" fmla="val 3529"/>
-            </a:avLst>
-          </a:prstGeom>
-          <a:solidFill>
-            <a:srgbClr val="E5F2F0"/>
-          </a:solidFill>
-          <a:ln/>
-        </p:spPr>
-      </p:sp>
-      <p:sp>
-        <p:nvSpPr>
-          <p:cNvPr id="9" name="Shape 6"/>
-          <p:cNvSpPr/>
-          <p:nvPr/>
-        </p:nvSpPr>
-        <p:spPr>
-          <a:xfrm>
-            <a:off x="4645152" y="1755648"/>
-            <a:ext cx="658368" cy="658368"/>
-          </a:xfrm>
-          <a:prstGeom prst="ellipse">
-            <a:avLst/>
-          </a:prstGeom>
-          <a:solidFill>
-            <a:srgbClr val="01485C"/>
-          </a:solidFill>
-          <a:ln/>
-        </p:spPr>
-      </p:sp>
-      <p:pic>
-        <p:nvPicPr>
-          <p:cNvPr id="10" name="Image 1" descr="icon_clipboard_w.png">    </p:cNvPr>
-          <p:cNvPicPr>
-            <a:picLocks noChangeAspect="1"/>
-          </p:cNvPicPr>
-          <p:nvPr/>
-        </p:nvPicPr>
-        <p:blipFill>
-          <a:blip r:embed="rId2"/>
-          <a:stretch>
-            <a:fillRect/>
-          </a:stretch>
-        </p:blipFill>
-        <p:spPr>
-          <a:xfrm>
-            <a:off x="4816328" y="1926824"/>
-            <a:ext cx="316017" cy="316017"/>
-          </a:xfrm>
-          <a:prstGeom prst="rect">
-            <a:avLst/>
-          </a:prstGeom>
-        </p:spPr>
-      </p:pic>
-      <p:sp>
-        <p:nvSpPr>
-          <p:cNvPr id="11" name="Text 7"/>
-          <p:cNvSpPr txBox="1"/>
-          <p:nvPr/>
-        </p:nvSpPr>
-        <p:spPr>
-          <a:xfrm>
-            <a:off x="4645152" y="2606040"/>
-            <a:ext cx="3063240" cy="457200"/>
-          </a:xfrm>
-          <a:prstGeom prst="rect">
-            <a:avLst/>
-          </a:prstGeom>
-          <a:noFill/>
-          <a:ln/>
-        </p:spPr>
-        <p:txBody>
-          <a:bodyPr wrap="square" lIns="0" tIns="0" rIns="0" bIns="0" rtlCol="0" anchor="ctr"/>
-          <a:lstStyle/>
-          <a:p>
-            <a:pPr indent="0" marL="0">
-              <a:buNone/>
-            </a:pPr>
-            <a:r>
-              <a:rPr lang="en-US" sz="1600" b="1" dirty="0">
-                <a:solidFill>
-                  <a:srgbClr val="01485C"/>
-                </a:solidFill>
-                <a:latin typeface="Calibri" pitchFamily="34" charset="0"/>
-                <a:ea typeface="Calibri" pitchFamily="34" charset="-122"/>
-                <a:cs typeface="Calibri" pitchFamily="34" charset="-120"/>
-              </a:rPr>
-              <a:t>Network audit logs</a:t>
-            </a:r>
-            <a:endParaRPr lang="en-US" sz="1600" dirty="0"/>
-          </a:p>
-        </p:txBody>
-      </p:sp>
-      <p:sp>
-        <p:nvSpPr>
-          <p:cNvPr id="12" name="Text 8"/>
-          <p:cNvSpPr txBox="1"/>
-          <p:nvPr/>
-        </p:nvSpPr>
-        <p:spPr>
-          <a:xfrm>
-            <a:off x="4645152" y="3108960"/>
-            <a:ext cx="3063240" cy="1371600"/>
-          </a:xfrm>
-          <a:prstGeom prst="rect">
-            <a:avLst/>
-          </a:prstGeom>
-          <a:noFill/>
-          <a:ln/>
-        </p:spPr>
-        <p:txBody>
-          <a:bodyPr wrap="square" lIns="0" tIns="0" rIns="0" bIns="0" rtlCol="0" anchor="ctr"/>
-          <a:lstStyle/>
-          <a:p>
-            <a:pPr indent="0" marL="0">
-              <a:buNone/>
-            </a:pPr>
-            <a:r>
-              <a:rPr lang="en-US" sz="1250" dirty="0">
-                <a:solidFill>
-                  <a:srgbClr val="17272E"/>
-                </a:solidFill>
-                <a:latin typeface="Calibri" pitchFamily="34" charset="0"/>
-                <a:ea typeface="Calibri" pitchFamily="34" charset="-122"/>
-                <a:cs typeface="Calibri" pitchFamily="34" charset="-120"/>
-              </a:rPr>
-              <a:t>The guard’s record: activation lines under normal use; any outbound attempt would appear as BLOCKED with the destination</a:t>
-            </a:r>
-            <a:endParaRPr lang="en-US" sz="1250" dirty="0"/>
-          </a:p>
-        </p:txBody>
-      </p:sp>
-      <p:sp>
-        <p:nvSpPr>
-          <p:cNvPr id="13" name="Shape 9"/>
-          <p:cNvSpPr/>
-          <p:nvPr/>
-        </p:nvSpPr>
-        <p:spPr>
-          <a:xfrm>
-            <a:off x="8193024" y="1463040"/>
-            <a:ext cx="3611880" cy="3108960"/>
-          </a:xfrm>
-          <a:prstGeom prst="roundRect">
-            <a:avLst>
-              <a:gd name="adj" fmla="val 3529"/>
-            </a:avLst>
-          </a:prstGeom>
-          <a:solidFill>
-            <a:srgbClr val="E5F2F0"/>
-          </a:solidFill>
-          <a:ln/>
-        </p:spPr>
-      </p:sp>
-      <p:sp>
-        <p:nvSpPr>
-          <p:cNvPr id="14" name="Shape 10"/>
-          <p:cNvSpPr/>
-          <p:nvPr/>
-        </p:nvSpPr>
-        <p:spPr>
-          <a:xfrm>
-            <a:off x="8467344" y="1755648"/>
-            <a:ext cx="658368" cy="658368"/>
-          </a:xfrm>
-          <a:prstGeom prst="ellipse">
-            <a:avLst/>
-          </a:prstGeom>
-          <a:solidFill>
-            <a:srgbClr val="01485C"/>
-          </a:solidFill>
-          <a:ln/>
-        </p:spPr>
-      </p:sp>
-      <p:pic>
-        <p:nvPicPr>
-          <p:cNvPr id="15" name="Image 2" descr="icon_clipboard_w.png">    </p:cNvPr>
-          <p:cNvPicPr>
-            <a:picLocks noChangeAspect="1"/>
-          </p:cNvPicPr>
-          <p:nvPr/>
-        </p:nvPicPr>
-        <p:blipFill>
-          <a:blip r:embed="rId3"/>
-          <a:stretch>
-            <a:fillRect/>
-          </a:stretch>
-        </p:blipFill>
-        <p:spPr>
-          <a:xfrm>
-            <a:off x="8638520" y="1926824"/>
-            <a:ext cx="316017" cy="316017"/>
-          </a:xfrm>
-          <a:prstGeom prst="rect">
-            <a:avLst/>
-          </a:prstGeom>
-        </p:spPr>
-      </p:pic>
-      <p:sp>
-        <p:nvSpPr>
-          <p:cNvPr id="16" name="Text 11"/>
-          <p:cNvSpPr txBox="1"/>
-          <p:nvPr/>
-        </p:nvSpPr>
-        <p:spPr>
-          <a:xfrm>
-            <a:off x="8467344" y="2606040"/>
-            <a:ext cx="3063240" cy="457200"/>
-          </a:xfrm>
-          <a:prstGeom prst="rect">
-            <a:avLst/>
-          </a:prstGeom>
-          <a:noFill/>
-          <a:ln/>
-        </p:spPr>
-        <p:txBody>
-          <a:bodyPr wrap="square" lIns="0" tIns="0" rIns="0" bIns="0" rtlCol="0" anchor="ctr"/>
-          <a:lstStyle/>
-          <a:p>
-            <a:pPr indent="0" marL="0">
-              <a:buNone/>
-            </a:pPr>
-            <a:r>
-              <a:rPr lang="en-US" sz="1600" b="1" dirty="0">
-                <a:solidFill>
-                  <a:srgbClr val="01485C"/>
-                </a:solidFill>
-                <a:latin typeface="Calibri" pitchFamily="34" charset="0"/>
-                <a:ea typeface="Calibri" pitchFamily="34" charset="-122"/>
-                <a:cs typeface="Calibri" pitchFamily="34" charset="-120"/>
-              </a:rPr>
-              <a:t>Human-readable, on-device</a:t>
-            </a:r>
-            <a:endParaRPr lang="en-US" sz="1600" dirty="0"/>
-          </a:p>
-        </p:txBody>
-      </p:sp>
-      <p:sp>
-        <p:nvSpPr>
-          <p:cNvPr id="17" name="Text 12"/>
-          <p:cNvSpPr txBox="1"/>
-          <p:nvPr/>
-        </p:nvSpPr>
-        <p:spPr>
-          <a:xfrm>
-            <a:off x="8467344" y="3108960"/>
-            <a:ext cx="3063240" cy="1371600"/>
-          </a:xfrm>
-          <a:prstGeom prst="rect">
-            <a:avLst/>
-          </a:prstGeom>
-          <a:noFill/>
-          <a:ln/>
-        </p:spPr>
-        <p:txBody>
-          <a:bodyPr wrap="square" lIns="0" tIns="0" rIns="0" bIns="0" rtlCol="0" anchor="ctr"/>
-          <a:lstStyle/>
-          <a:p>
-            <a:pPr indent="0" marL="0">
-              <a:buNone/>
-            </a:pPr>
-            <a:r>
-              <a:rPr lang="en-US" sz="1250" dirty="0">
-                <a:solidFill>
-                  <a:srgbClr val="17272E"/>
-                </a:solidFill>
-                <a:latin typeface="Calibri" pitchFamily="34" charset="0"/>
-                <a:ea typeface="Calibri" pitchFamily="34" charset="-122"/>
-                <a:cs typeface="Calibri" pitchFamily="34" charset="-120"/>
-              </a:rPr>
-              <a:t>Plain text on the drive — reviewable by any auditor without tooling, tied to OS usernames</a:t>
-            </a:r>
-            <a:endParaRPr lang="en-US" sz="1250" dirty="0"/>
-          </a:p>
-        </p:txBody>
-      </p:sp>
-      <p:sp>
-        <p:nvSpPr>
-          <p:cNvPr id="18" name="Text 13"/>
-          <p:cNvSpPr txBox="1"/>
-          <p:nvPr/>
-        </p:nvSpPr>
-        <p:spPr>
-          <a:xfrm>
-            <a:off x="548640" y="5029200"/>
-            <a:ext cx="11064240" cy="457200"/>
-          </a:xfrm>
-          <a:prstGeom prst="rect">
-            <a:avLst/>
-          </a:prstGeom>
-          <a:noFill/>
-          <a:ln/>
-        </p:spPr>
-        <p:txBody>
-          <a:bodyPr wrap="square" lIns="0" tIns="0" rIns="0" bIns="0" rtlCol="0" anchor="ctr"/>
-          <a:lstStyle/>
-          <a:p>
-            <a:pPr indent="0" marL="0">
-              <a:buNone/>
-            </a:pPr>
-            <a:r>
-              <a:rPr lang="en-US" sz="1400" i="1" dirty="0">
-                <a:solidFill>
-                  <a:srgbClr val="5F7178"/>
-                </a:solidFill>
-                <a:latin typeface="Calibri" pitchFamily="34" charset="0"/>
-                <a:ea typeface="Calibri" pitchFamily="34" charset="-122"/>
-                <a:cs typeface="Calibri" pitchFamily="34" charset="-120"/>
-              </a:rPr>
-              <a:t>Failed password attempts are recorded — repeated failures on a found drive leave evidence.</a:t>
-            </a:r>
-            <a:endParaRPr lang="en-US" sz="1400" dirty="0"/>
-          </a:p>
-        </p:txBody>
-      </p:sp>
-      <p:sp>
-        <p:nvSpPr>
-          <p:cNvPr id="19" name="Shape 14"/>
-          <p:cNvSpPr/>
-          <p:nvPr/>
-        </p:nvSpPr>
-        <p:spPr>
-          <a:xfrm>
-            <a:off x="0" y="6793992"/>
-            <a:ext cx="2040636" cy="64008"/>
-          </a:xfrm>
-          <a:prstGeom prst="rect">
-            <a:avLst/>
-          </a:prstGeom>
-          <a:solidFill>
-            <a:srgbClr val="01485C"/>
-          </a:solidFill>
-          <a:ln/>
-        </p:spPr>
-      </p:sp>
-      <p:sp>
-        <p:nvSpPr>
-          <p:cNvPr id="20" name="Shape 15"/>
-          <p:cNvSpPr/>
-          <p:nvPr/>
-        </p:nvSpPr>
-        <p:spPr>
-          <a:xfrm>
-            <a:off x="2031492" y="6793992"/>
-            <a:ext cx="2040636" cy="64008"/>
-          </a:xfrm>
-          <a:prstGeom prst="rect">
-            <a:avLst/>
-          </a:prstGeom>
-          <a:solidFill>
-            <a:srgbClr val="146175"/>
-          </a:solidFill>
-          <a:ln/>
-        </p:spPr>
-      </p:sp>
-      <p:sp>
-        <p:nvSpPr>
-          <p:cNvPr id="21" name="Shape 16"/>
-          <p:cNvSpPr/>
-          <p:nvPr/>
-        </p:nvSpPr>
-        <p:spPr>
-          <a:xfrm>
-            <a:off x="4062984" y="6793992"/>
-            <a:ext cx="2040636" cy="64008"/>
-          </a:xfrm>
-          <a:prstGeom prst="rect">
-            <a:avLst/>
-          </a:prstGeom>
-          <a:solidFill>
-            <a:srgbClr val="11B5AE"/>
-          </a:solidFill>
-          <a:ln/>
-        </p:spPr>
-      </p:sp>
-      <p:sp>
-        <p:nvSpPr>
-          <p:cNvPr id="22" name="Shape 17"/>
-          <p:cNvSpPr/>
-          <p:nvPr/>
-        </p:nvSpPr>
-        <p:spPr>
-          <a:xfrm>
-            <a:off x="6094476" y="6793992"/>
-            <a:ext cx="2040636" cy="64008"/>
-          </a:xfrm>
-          <a:prstGeom prst="rect">
-            <a:avLst/>
-          </a:prstGeom>
-          <a:solidFill>
-            <a:srgbClr val="6CCAD4"/>
-          </a:solidFill>
-          <a:ln/>
-        </p:spPr>
-      </p:sp>
-      <p:sp>
-        <p:nvSpPr>
-          <p:cNvPr id="23" name="Shape 18"/>
-          <p:cNvSpPr/>
-          <p:nvPr/>
-        </p:nvSpPr>
-        <p:spPr>
-          <a:xfrm>
-            <a:off x="8125968" y="6793992"/>
-            <a:ext cx="2040636" cy="64008"/>
-          </a:xfrm>
-          <a:prstGeom prst="rect">
-            <a:avLst/>
-          </a:prstGeom>
-          <a:solidFill>
-            <a:srgbClr val="7FC04C"/>
-          </a:solidFill>
-          <a:ln/>
-        </p:spPr>
-      </p:sp>
-      <p:sp>
-        <p:nvSpPr>
-          <p:cNvPr id="24" name="Shape 19"/>
           <p:cNvSpPr/>
           <p:nvPr/>
         </p:nvSpPr>

</xml_diff>

<commit_message>
Central licensing replaces drive-side enrolment
- pq_licence.py: the bundle runs only under a *.lic file signed by the PoC
  lead's offline keygen; the drive holds just the Ed25519 public key.
  Licence = site, machine IDs (seat cap), issued/expires (12-month QIS
  cycle), max bundle version. States LICENSED / EXPIRING / GRACE / EXPIRED,
  VERSION gate, clock-rollback lock, licence_audit.log
- PQ_Licensing/pq_keygen.py (private key, issued files and ledger are
  gitignored): init / id / issue / show / list
- portal: lock card with machine ID and Install licence file, /licence_status,
  /licence_install, /licences page; engines: before_request lock page
- READMEs and both decks updated for the licence model

Co-Authored-By: Claude Fable 5.1 <noreply@anthropic.com>
</commit_message>
<xml_diff>
--- a/PQ_Report_Generator_Security_Briefing.pptx
+++ b/PQ_Report_Generator_Security_Briefing.pptx
@@ -2228,668 +2228,6 @@
 </file>
 
 <file path=ppt/slides/slide10.xml><?xml version="1.0" encoding="utf-8"?>
-<p:sld xmlns:a="http://schemas.openxmlformats.org/drawingml/2006/main" xmlns:r="http://schemas.openxmlformats.org/officeDocument/2006/relationships" xmlns:p="http://schemas.openxmlformats.org/presentationml/2006/main">
-  <p:cSld name="Slide 9">
-    <p:bg>
-      <p:bgPr>
-        <a:solidFill>
-          <a:srgbClr val="FFFFFF"/>
-        </a:solidFill>
-      </p:bgPr>
-    </p:bg>
-    <p:spTree>
-      <p:nvGrpSpPr>
-        <p:cNvPr id="1" name=""/>
-        <p:cNvGrpSpPr/>
-        <p:nvPr/>
-      </p:nvGrpSpPr>
-      <p:grpSpPr>
-        <a:xfrm>
-          <a:off x="0" y="0"/>
-          <a:ext cx="0" cy="0"/>
-          <a:chOff x="0" y="0"/>
-          <a:chExt cx="0" cy="0"/>
-        </a:xfrm>
-      </p:grpSpPr>
-      <p:sp>
-        <p:nvSpPr>
-          <p:cNvPr id="2" name="Text 0"/>
-          <p:cNvSpPr txBox="1"/>
-          <p:nvPr/>
-        </p:nvSpPr>
-        <p:spPr>
-          <a:xfrm>
-            <a:off x="548640" y="320040"/>
-            <a:ext cx="11064240" cy="685800"/>
-          </a:xfrm>
-          <a:prstGeom prst="rect">
-            <a:avLst/>
-          </a:prstGeom>
-          <a:noFill/>
-          <a:ln/>
-        </p:spPr>
-        <p:txBody>
-          <a:bodyPr wrap="square" lIns="0" tIns="0" rIns="0" bIns="0" rtlCol="0" anchor="ctr"/>
-          <a:lstStyle/>
-          <a:p>
-            <a:pPr algn="l" indent="0" marL="0">
-              <a:buNone/>
-            </a:pPr>
-            <a:r>
-              <a:rPr lang="en-US" sz="3000" b="1" dirty="0">
-                <a:solidFill>
-                  <a:srgbClr val="01485C"/>
-                </a:solidFill>
-                <a:latin typeface="Calibri" pitchFamily="34" charset="0"/>
-                <a:ea typeface="Calibri" pitchFamily="34" charset="-122"/>
-                <a:cs typeface="Calibri" pitchFamily="34" charset="-120"/>
-              </a:rPr>
-              <a:t>Audit &amp; accountability</a:t>
-            </a:r>
-            <a:endParaRPr lang="en-US" sz="3000" dirty="0"/>
-          </a:p>
-        </p:txBody>
-      </p:sp>
-      <p:sp>
-        <p:nvSpPr>
-          <p:cNvPr id="3" name="Shape 1"/>
-          <p:cNvSpPr/>
-          <p:nvPr/>
-        </p:nvSpPr>
-        <p:spPr>
-          <a:xfrm>
-            <a:off x="548640" y="1463040"/>
-            <a:ext cx="3611880" cy="3108960"/>
-          </a:xfrm>
-          <a:prstGeom prst="roundRect">
-            <a:avLst>
-              <a:gd name="adj" fmla="val 3529"/>
-            </a:avLst>
-          </a:prstGeom>
-          <a:solidFill>
-            <a:srgbClr val="E5F2F0"/>
-          </a:solidFill>
-          <a:ln/>
-        </p:spPr>
-      </p:sp>
-      <p:sp>
-        <p:nvSpPr>
-          <p:cNvPr id="4" name="Shape 2"/>
-          <p:cNvSpPr/>
-          <p:nvPr/>
-        </p:nvSpPr>
-        <p:spPr>
-          <a:xfrm>
-            <a:off x="822960" y="1755648"/>
-            <a:ext cx="658368" cy="658368"/>
-          </a:xfrm>
-          <a:prstGeom prst="ellipse">
-            <a:avLst/>
-          </a:prstGeom>
-          <a:solidFill>
-            <a:srgbClr val="01485C"/>
-          </a:solidFill>
-          <a:ln/>
-        </p:spPr>
-      </p:sp>
-      <p:pic>
-        <p:nvPicPr>
-          <p:cNvPr id="5" name="Image 0" descr="icon_clipboard_w.png">    </p:cNvPr>
-          <p:cNvPicPr>
-            <a:picLocks noChangeAspect="1"/>
-          </p:cNvPicPr>
-          <p:nvPr/>
-        </p:nvPicPr>
-        <p:blipFill>
-          <a:blip r:embed="rId1"/>
-          <a:stretch>
-            <a:fillRect/>
-          </a:stretch>
-        </p:blipFill>
-        <p:spPr>
-          <a:xfrm>
-            <a:off x="994136" y="1926824"/>
-            <a:ext cx="316017" cy="316017"/>
-          </a:xfrm>
-          <a:prstGeom prst="rect">
-            <a:avLst/>
-          </a:prstGeom>
-        </p:spPr>
-      </p:pic>
-      <p:sp>
-        <p:nvSpPr>
-          <p:cNvPr id="6" name="Text 3"/>
-          <p:cNvSpPr txBox="1"/>
-          <p:nvPr/>
-        </p:nvSpPr>
-        <p:spPr>
-          <a:xfrm>
-            <a:off x="822960" y="2606040"/>
-            <a:ext cx="3063240" cy="457200"/>
-          </a:xfrm>
-          <a:prstGeom prst="rect">
-            <a:avLst/>
-          </a:prstGeom>
-          <a:noFill/>
-          <a:ln/>
-        </p:spPr>
-        <p:txBody>
-          <a:bodyPr wrap="square" lIns="0" tIns="0" rIns="0" bIns="0" rtlCol="0" anchor="ctr"/>
-          <a:lstStyle/>
-          <a:p>
-            <a:pPr indent="0" marL="0">
-              <a:buNone/>
-            </a:pPr>
-            <a:r>
-              <a:rPr lang="en-US" sz="1600" b="1" dirty="0">
-                <a:solidFill>
-                  <a:srgbClr val="01485C"/>
-                </a:solidFill>
-                <a:latin typeface="Calibri" pitchFamily="34" charset="0"/>
-                <a:ea typeface="Calibri" pitchFamily="34" charset="-122"/>
-                <a:cs typeface="Calibri" pitchFamily="34" charset="-120"/>
-              </a:rPr>
-              <a:t>audit.log</a:t>
-            </a:r>
-            <a:endParaRPr lang="en-US" sz="1600" dirty="0"/>
-          </a:p>
-        </p:txBody>
-      </p:sp>
-      <p:sp>
-        <p:nvSpPr>
-          <p:cNvPr id="7" name="Text 4"/>
-          <p:cNvSpPr txBox="1"/>
-          <p:nvPr/>
-        </p:nvSpPr>
-        <p:spPr>
-          <a:xfrm>
-            <a:off x="822960" y="3108960"/>
-            <a:ext cx="3063240" cy="1371600"/>
-          </a:xfrm>
-          <a:prstGeom prst="rect">
-            <a:avLst/>
-          </a:prstGeom>
-          <a:noFill/>
-          <a:ln/>
-        </p:spPr>
-        <p:txBody>
-          <a:bodyPr wrap="square" lIns="0" tIns="0" rIns="0" bIns="0" rtlCol="0" anchor="ctr"/>
-          <a:lstStyle/>
-          <a:p>
-            <a:pPr indent="0" marL="0">
-              <a:buNone/>
-            </a:pPr>
-            <a:r>
-              <a:rPr lang="en-US" sz="1250" dirty="0">
-                <a:solidFill>
-                  <a:srgbClr val="17272E"/>
-                </a:solidFill>
-                <a:latin typeface="Calibri" pitchFamily="34" charset="0"/>
-                <a:ea typeface="Calibri" pitchFamily="34" charset="-122"/>
-                <a:cs typeface="Calibri" pitchFamily="34" charset="-120"/>
-              </a:rPr>
-              <a:t>Every report generation: timestamp, Windows username, period, scope — plus every history unlock attempt, including failures</a:t>
-            </a:r>
-            <a:endParaRPr lang="en-US" sz="1250" dirty="0"/>
-          </a:p>
-        </p:txBody>
-      </p:sp>
-      <p:sp>
-        <p:nvSpPr>
-          <p:cNvPr id="8" name="Shape 5"/>
-          <p:cNvSpPr/>
-          <p:nvPr/>
-        </p:nvSpPr>
-        <p:spPr>
-          <a:xfrm>
-            <a:off x="4370832" y="1463040"/>
-            <a:ext cx="3611880" cy="3108960"/>
-          </a:xfrm>
-          <a:prstGeom prst="roundRect">
-            <a:avLst>
-              <a:gd name="adj" fmla="val 3529"/>
-            </a:avLst>
-          </a:prstGeom>
-          <a:solidFill>
-            <a:srgbClr val="E5F2F0"/>
-          </a:solidFill>
-          <a:ln/>
-        </p:spPr>
-      </p:sp>
-      <p:sp>
-        <p:nvSpPr>
-          <p:cNvPr id="9" name="Shape 6"/>
-          <p:cNvSpPr/>
-          <p:nvPr/>
-        </p:nvSpPr>
-        <p:spPr>
-          <a:xfrm>
-            <a:off x="4645152" y="1755648"/>
-            <a:ext cx="658368" cy="658368"/>
-          </a:xfrm>
-          <a:prstGeom prst="ellipse">
-            <a:avLst/>
-          </a:prstGeom>
-          <a:solidFill>
-            <a:srgbClr val="01485C"/>
-          </a:solidFill>
-          <a:ln/>
-        </p:spPr>
-      </p:sp>
-      <p:pic>
-        <p:nvPicPr>
-          <p:cNvPr id="10" name="Image 1" descr="icon_clipboard_w.png">    </p:cNvPr>
-          <p:cNvPicPr>
-            <a:picLocks noChangeAspect="1"/>
-          </p:cNvPicPr>
-          <p:nvPr/>
-        </p:nvPicPr>
-        <p:blipFill>
-          <a:blip r:embed="rId2"/>
-          <a:stretch>
-            <a:fillRect/>
-          </a:stretch>
-        </p:blipFill>
-        <p:spPr>
-          <a:xfrm>
-            <a:off x="4816328" y="1926824"/>
-            <a:ext cx="316017" cy="316017"/>
-          </a:xfrm>
-          <a:prstGeom prst="rect">
-            <a:avLst/>
-          </a:prstGeom>
-        </p:spPr>
-      </p:pic>
-      <p:sp>
-        <p:nvSpPr>
-          <p:cNvPr id="11" name="Text 7"/>
-          <p:cNvSpPr txBox="1"/>
-          <p:nvPr/>
-        </p:nvSpPr>
-        <p:spPr>
-          <a:xfrm>
-            <a:off x="4645152" y="2606040"/>
-            <a:ext cx="3063240" cy="457200"/>
-          </a:xfrm>
-          <a:prstGeom prst="rect">
-            <a:avLst/>
-          </a:prstGeom>
-          <a:noFill/>
-          <a:ln/>
-        </p:spPr>
-        <p:txBody>
-          <a:bodyPr wrap="square" lIns="0" tIns="0" rIns="0" bIns="0" rtlCol="0" anchor="ctr"/>
-          <a:lstStyle/>
-          <a:p>
-            <a:pPr indent="0" marL="0">
-              <a:buNone/>
-            </a:pPr>
-            <a:r>
-              <a:rPr lang="en-US" sz="1600" b="1" dirty="0">
-                <a:solidFill>
-                  <a:srgbClr val="01485C"/>
-                </a:solidFill>
-                <a:latin typeface="Calibri" pitchFamily="34" charset="0"/>
-                <a:ea typeface="Calibri" pitchFamily="34" charset="-122"/>
-                <a:cs typeface="Calibri" pitchFamily="34" charset="-120"/>
-              </a:rPr>
-              <a:t>Network audit logs</a:t>
-            </a:r>
-            <a:endParaRPr lang="en-US" sz="1600" dirty="0"/>
-          </a:p>
-        </p:txBody>
-      </p:sp>
-      <p:sp>
-        <p:nvSpPr>
-          <p:cNvPr id="12" name="Text 8"/>
-          <p:cNvSpPr txBox="1"/>
-          <p:nvPr/>
-        </p:nvSpPr>
-        <p:spPr>
-          <a:xfrm>
-            <a:off x="4645152" y="3108960"/>
-            <a:ext cx="3063240" cy="1371600"/>
-          </a:xfrm>
-          <a:prstGeom prst="rect">
-            <a:avLst/>
-          </a:prstGeom>
-          <a:noFill/>
-          <a:ln/>
-        </p:spPr>
-        <p:txBody>
-          <a:bodyPr wrap="square" lIns="0" tIns="0" rIns="0" bIns="0" rtlCol="0" anchor="ctr"/>
-          <a:lstStyle/>
-          <a:p>
-            <a:pPr indent="0" marL="0">
-              <a:buNone/>
-            </a:pPr>
-            <a:r>
-              <a:rPr lang="en-US" sz="1250" dirty="0">
-                <a:solidFill>
-                  <a:srgbClr val="17272E"/>
-                </a:solidFill>
-                <a:latin typeface="Calibri" pitchFamily="34" charset="0"/>
-                <a:ea typeface="Calibri" pitchFamily="34" charset="-122"/>
-                <a:cs typeface="Calibri" pitchFamily="34" charset="-120"/>
-              </a:rPr>
-              <a:t>The guard’s record: activation lines under normal use; any outbound attempt would appear as BLOCKED with the destination</a:t>
-            </a:r>
-            <a:endParaRPr lang="en-US" sz="1250" dirty="0"/>
-          </a:p>
-        </p:txBody>
-      </p:sp>
-      <p:sp>
-        <p:nvSpPr>
-          <p:cNvPr id="13" name="Shape 9"/>
-          <p:cNvSpPr/>
-          <p:nvPr/>
-        </p:nvSpPr>
-        <p:spPr>
-          <a:xfrm>
-            <a:off x="8193024" y="1463040"/>
-            <a:ext cx="3611880" cy="3108960"/>
-          </a:xfrm>
-          <a:prstGeom prst="roundRect">
-            <a:avLst>
-              <a:gd name="adj" fmla="val 3529"/>
-            </a:avLst>
-          </a:prstGeom>
-          <a:solidFill>
-            <a:srgbClr val="E5F2F0"/>
-          </a:solidFill>
-          <a:ln/>
-        </p:spPr>
-      </p:sp>
-      <p:sp>
-        <p:nvSpPr>
-          <p:cNvPr id="14" name="Shape 10"/>
-          <p:cNvSpPr/>
-          <p:nvPr/>
-        </p:nvSpPr>
-        <p:spPr>
-          <a:xfrm>
-            <a:off x="8467344" y="1755648"/>
-            <a:ext cx="658368" cy="658368"/>
-          </a:xfrm>
-          <a:prstGeom prst="ellipse">
-            <a:avLst/>
-          </a:prstGeom>
-          <a:solidFill>
-            <a:srgbClr val="01485C"/>
-          </a:solidFill>
-          <a:ln/>
-        </p:spPr>
-      </p:sp>
-      <p:pic>
-        <p:nvPicPr>
-          <p:cNvPr id="15" name="Image 2" descr="icon_clipboard_w.png">    </p:cNvPr>
-          <p:cNvPicPr>
-            <a:picLocks noChangeAspect="1"/>
-          </p:cNvPicPr>
-          <p:nvPr/>
-        </p:nvPicPr>
-        <p:blipFill>
-          <a:blip r:embed="rId3"/>
-          <a:stretch>
-            <a:fillRect/>
-          </a:stretch>
-        </p:blipFill>
-        <p:spPr>
-          <a:xfrm>
-            <a:off x="8638520" y="1926824"/>
-            <a:ext cx="316017" cy="316017"/>
-          </a:xfrm>
-          <a:prstGeom prst="rect">
-            <a:avLst/>
-          </a:prstGeom>
-        </p:spPr>
-      </p:pic>
-      <p:sp>
-        <p:nvSpPr>
-          <p:cNvPr id="16" name="Text 11"/>
-          <p:cNvSpPr txBox="1"/>
-          <p:nvPr/>
-        </p:nvSpPr>
-        <p:spPr>
-          <a:xfrm>
-            <a:off x="8467344" y="2606040"/>
-            <a:ext cx="3063240" cy="457200"/>
-          </a:xfrm>
-          <a:prstGeom prst="rect">
-            <a:avLst/>
-          </a:prstGeom>
-          <a:noFill/>
-          <a:ln/>
-        </p:spPr>
-        <p:txBody>
-          <a:bodyPr wrap="square" lIns="0" tIns="0" rIns="0" bIns="0" rtlCol="0" anchor="ctr"/>
-          <a:lstStyle/>
-          <a:p>
-            <a:pPr indent="0" marL="0">
-              <a:buNone/>
-            </a:pPr>
-            <a:r>
-              <a:rPr lang="en-US" sz="1600" b="1" dirty="0">
-                <a:solidFill>
-                  <a:srgbClr val="01485C"/>
-                </a:solidFill>
-                <a:latin typeface="Calibri" pitchFamily="34" charset="0"/>
-                <a:ea typeface="Calibri" pitchFamily="34" charset="-122"/>
-                <a:cs typeface="Calibri" pitchFamily="34" charset="-120"/>
-              </a:rPr>
-              <a:t>Human-readable, on-device</a:t>
-            </a:r>
-            <a:endParaRPr lang="en-US" sz="1600" dirty="0"/>
-          </a:p>
-        </p:txBody>
-      </p:sp>
-      <p:sp>
-        <p:nvSpPr>
-          <p:cNvPr id="17" name="Text 12"/>
-          <p:cNvSpPr txBox="1"/>
-          <p:nvPr/>
-        </p:nvSpPr>
-        <p:spPr>
-          <a:xfrm>
-            <a:off x="8467344" y="3108960"/>
-            <a:ext cx="3063240" cy="1371600"/>
-          </a:xfrm>
-          <a:prstGeom prst="rect">
-            <a:avLst/>
-          </a:prstGeom>
-          <a:noFill/>
-          <a:ln/>
-        </p:spPr>
-        <p:txBody>
-          <a:bodyPr wrap="square" lIns="0" tIns="0" rIns="0" bIns="0" rtlCol="0" anchor="ctr"/>
-          <a:lstStyle/>
-          <a:p>
-            <a:pPr indent="0" marL="0">
-              <a:buNone/>
-            </a:pPr>
-            <a:r>
-              <a:rPr lang="en-US" sz="1250" dirty="0">
-                <a:solidFill>
-                  <a:srgbClr val="17272E"/>
-                </a:solidFill>
-                <a:latin typeface="Calibri" pitchFamily="34" charset="0"/>
-                <a:ea typeface="Calibri" pitchFamily="34" charset="-122"/>
-                <a:cs typeface="Calibri" pitchFamily="34" charset="-120"/>
-              </a:rPr>
-              <a:t>Plain text on the drive — reviewable by any auditor without tooling, tied to OS usernames</a:t>
-            </a:r>
-            <a:endParaRPr lang="en-US" sz="1250" dirty="0"/>
-          </a:p>
-        </p:txBody>
-      </p:sp>
-      <p:sp>
-        <p:nvSpPr>
-          <p:cNvPr id="18" name="Text 13"/>
-          <p:cNvSpPr txBox="1"/>
-          <p:nvPr/>
-        </p:nvSpPr>
-        <p:spPr>
-          <a:xfrm>
-            <a:off x="548640" y="5029200"/>
-            <a:ext cx="11064240" cy="457200"/>
-          </a:xfrm>
-          <a:prstGeom prst="rect">
-            <a:avLst/>
-          </a:prstGeom>
-          <a:noFill/>
-          <a:ln/>
-        </p:spPr>
-        <p:txBody>
-          <a:bodyPr wrap="square" lIns="0" tIns="0" rIns="0" bIns="0" rtlCol="0" anchor="ctr"/>
-          <a:lstStyle/>
-          <a:p>
-            <a:pPr indent="0" marL="0">
-              <a:buNone/>
-            </a:pPr>
-            <a:r>
-              <a:rPr lang="en-US" sz="1400" i="1" dirty="0">
-                <a:solidFill>
-                  <a:srgbClr val="5F7178"/>
-                </a:solidFill>
-                <a:latin typeface="Calibri" pitchFamily="34" charset="0"/>
-                <a:ea typeface="Calibri" pitchFamily="34" charset="-122"/>
-                <a:cs typeface="Calibri" pitchFamily="34" charset="-120"/>
-              </a:rPr>
-              <a:t>Failed password attempts are recorded — repeated failures on a found drive leave evidence.</a:t>
-            </a:r>
-            <a:endParaRPr lang="en-US" sz="1400" dirty="0"/>
-          </a:p>
-        </p:txBody>
-      </p:sp>
-      <p:sp>
-        <p:nvSpPr>
-          <p:cNvPr id="19" name="Shape 14"/>
-          <p:cNvSpPr/>
-          <p:nvPr/>
-        </p:nvSpPr>
-        <p:spPr>
-          <a:xfrm>
-            <a:off x="0" y="6793992"/>
-            <a:ext cx="2040636" cy="64008"/>
-          </a:xfrm>
-          <a:prstGeom prst="rect">
-            <a:avLst/>
-          </a:prstGeom>
-          <a:solidFill>
-            <a:srgbClr val="01485C"/>
-          </a:solidFill>
-          <a:ln/>
-        </p:spPr>
-      </p:sp>
-      <p:sp>
-        <p:nvSpPr>
-          <p:cNvPr id="20" name="Shape 15"/>
-          <p:cNvSpPr/>
-          <p:nvPr/>
-        </p:nvSpPr>
-        <p:spPr>
-          <a:xfrm>
-            <a:off x="2031492" y="6793992"/>
-            <a:ext cx="2040636" cy="64008"/>
-          </a:xfrm>
-          <a:prstGeom prst="rect">
-            <a:avLst/>
-          </a:prstGeom>
-          <a:solidFill>
-            <a:srgbClr val="146175"/>
-          </a:solidFill>
-          <a:ln/>
-        </p:spPr>
-      </p:sp>
-      <p:sp>
-        <p:nvSpPr>
-          <p:cNvPr id="21" name="Shape 16"/>
-          <p:cNvSpPr/>
-          <p:nvPr/>
-        </p:nvSpPr>
-        <p:spPr>
-          <a:xfrm>
-            <a:off x="4062984" y="6793992"/>
-            <a:ext cx="2040636" cy="64008"/>
-          </a:xfrm>
-          <a:prstGeom prst="rect">
-            <a:avLst/>
-          </a:prstGeom>
-          <a:solidFill>
-            <a:srgbClr val="11B5AE"/>
-          </a:solidFill>
-          <a:ln/>
-        </p:spPr>
-      </p:sp>
-      <p:sp>
-        <p:nvSpPr>
-          <p:cNvPr id="22" name="Shape 17"/>
-          <p:cNvSpPr/>
-          <p:nvPr/>
-        </p:nvSpPr>
-        <p:spPr>
-          <a:xfrm>
-            <a:off x="6094476" y="6793992"/>
-            <a:ext cx="2040636" cy="64008"/>
-          </a:xfrm>
-          <a:prstGeom prst="rect">
-            <a:avLst/>
-          </a:prstGeom>
-          <a:solidFill>
-            <a:srgbClr val="6CCAD4"/>
-          </a:solidFill>
-          <a:ln/>
-        </p:spPr>
-      </p:sp>
-      <p:sp>
-        <p:nvSpPr>
-          <p:cNvPr id="23" name="Shape 18"/>
-          <p:cNvSpPr/>
-          <p:nvPr/>
-        </p:nvSpPr>
-        <p:spPr>
-          <a:xfrm>
-            <a:off x="8125968" y="6793992"/>
-            <a:ext cx="2040636" cy="64008"/>
-          </a:xfrm>
-          <a:prstGeom prst="rect">
-            <a:avLst/>
-          </a:prstGeom>
-          <a:solidFill>
-            <a:srgbClr val="7FC04C"/>
-          </a:solidFill>
-          <a:ln/>
-        </p:spPr>
-      </p:sp>
-      <p:sp>
-        <p:nvSpPr>
-          <p:cNvPr id="24" name="Shape 19"/>
-          <p:cNvSpPr/>
-          <p:nvPr/>
-        </p:nvSpPr>
-        <p:spPr>
-          <a:xfrm>
-            <a:off x="10157460" y="6793992"/>
-            <a:ext cx="2040636" cy="64008"/>
-          </a:xfrm>
-          <a:prstGeom prst="rect">
-            <a:avLst/>
-          </a:prstGeom>
-          <a:solidFill>
-            <a:srgbClr val="E1DD57"/>
-          </a:solidFill>
-          <a:ln/>
-        </p:spPr>
-      </p:sp>
-    </p:spTree>
-  </p:cSld>
-  <p:clrMapOvr>
-    <a:masterClrMapping/>
-  </p:clrMapOvr>
-</p:sld>
-</file>
-
-<file path=ppt/slides/slide11.xml><?xml version="1.0" encoding="utf-8"?>
 <p:sld xmlns:a="http://schemas.openxmlformats.org/drawingml/2006/main" xmlns:r="http://schemas.openxmlformats.org/officeDocument/2006/relationships" xmlns:p="http://schemas.openxmlformats.org/presentationml/2006/main">
   <p:cSld name="Slide 10">
     <p:bg>
@@ -3947,7 +3285,7 @@
 </p:sld>
 </file>
 
-<file path=ppt/slides/slide12.xml><?xml version="1.0" encoding="utf-8"?>
+<file path=ppt/slides/slide11.xml><?xml version="1.0" encoding="utf-8"?>
 <p:sld xmlns:a="http://schemas.openxmlformats.org/drawingml/2006/main" xmlns:r="http://schemas.openxmlformats.org/officeDocument/2006/relationships" xmlns:p="http://schemas.openxmlformats.org/presentationml/2006/main">
   <p:cSld name="Slide 11">
     <p:bg>
@@ -4602,7 +3940,7 @@
                 <a:ea typeface="Calibri" pitchFamily="34" charset="-122"/>
                 <a:cs typeface="Calibri" pitchFamily="34" charset="-120"/>
               </a:rPr>
-              <a:t>History and enrolment passwords are shared team secrets</a:t>
+              <a:t>History and BitLocker passwords are shared team secrets; the licence key is the PoC lead’s alone</a:t>
             </a:r>
             <a:endParaRPr lang="en-US" sz="1250" dirty="0"/>
           </a:p>
@@ -4665,7 +4003,7 @@
                 <a:ea typeface="Calibri" pitchFamily="34" charset="-122"/>
                 <a:cs typeface="Calibri" pitchFamily="34" charset="-120"/>
               </a:rPr>
-              <a:t>PC enrolment is enforced by code on the drive — evidence, not DRM</a:t>
+              <a:t>Licence enforcement is code on the drive — evidence, not DRM</a:t>
             </a:r>
             <a:endParaRPr lang="en-US" sz="1250" dirty="0"/>
           </a:p>
@@ -4679,7 +4017,7 @@
         </p:nvSpPr>
         <p:spPr>
           <a:xfrm>
-            <a:off x="548640" y="5650992"/>
+            <a:off x="548640" y="5532120"/>
             <a:ext cx="2377440" cy="868680"/>
           </a:xfrm>
           <a:prstGeom prst="roundRect">
@@ -4972,7 +4310,7 @@
                 <a:ea typeface="Calibri" pitchFamily="34" charset="-122"/>
                 <a:cs typeface="Calibri" pitchFamily="34" charset="-120"/>
               </a:rPr>
-              <a:t>Enrol the approved PCs   </a:t>
+              <a:t>Licence the approved PCs   </a:t>
             </a:r>
             <a:pPr indent="0" marL="0">
               <a:buNone/>
@@ -4986,11 +4324,925 @@
                 <a:ea typeface="Calibri" pitchFamily="34" charset="-122"/>
                 <a:cs typeface="Calibri" pitchFamily="34" charset="-120"/>
               </a:rPr>
-              <a:t>Set the enrolment password at first launch, enrol each approved non-networked PC, review Enrolled PCs monthly</a:t>
+              <a:t>Issue a 12-month licence per PC with the keygen; re-issue at each QIS review with the new version</a:t>
             </a:r>
             <a:endParaRPr lang="en-US" sz="1550" dirty="0"/>
           </a:p>
         </p:txBody>
+      </p:sp>
+    </p:spTree>
+  </p:cSld>
+  <p:clrMapOvr>
+    <a:masterClrMapping/>
+  </p:clrMapOvr>
+</p:sld>
+</file>
+
+<file path=ppt/slides/slide12.xml><?xml version="1.0" encoding="utf-8"?>
+<p:sld xmlns:a="http://schemas.openxmlformats.org/drawingml/2006/main" xmlns:p="http://schemas.openxmlformats.org/presentationml/2006/main" xmlns:r="http://schemas.openxmlformats.org/officeDocument/2006/relationships">
+  <p:cSld>
+    <p:spTree>
+      <p:nvGrpSpPr>
+        <p:cNvPr id="1" name=""/>
+        <p:cNvGrpSpPr/>
+        <p:nvPr/>
+      </p:nvGrpSpPr>
+      <p:grpSpPr/>
+      <p:sp>
+        <p:nvSpPr>
+          <p:cNvPr id="2" name="Text 0"/>
+          <p:cNvSpPr txBox="1"/>
+          <p:nvPr/>
+        </p:nvSpPr>
+        <p:spPr>
+          <a:xfrm>
+            <a:off x="548640" y="320040"/>
+            <a:ext cx="11064240" cy="685800"/>
+          </a:xfrm>
+          <a:prstGeom prst="rect">
+            <a:avLst/>
+          </a:prstGeom>
+          <a:noFill/>
+          <a:ln/>
+        </p:spPr>
+        <p:txBody>
+          <a:bodyPr wrap="square" lIns="0" tIns="0" rIns="0" bIns="0" rtlCol="0" anchor="ctr"/>
+          <a:lstStyle/>
+          <a:p>
+            <a:pPr algn="l" indent="0" marL="0">
+              <a:buNone/>
+            </a:pPr>
+            <a:r>
+              <a:rPr lang="en-US" sz="3000" b="1" dirty="0">
+                <a:solidFill>
+                  <a:srgbClr val="01485C"/>
+                </a:solidFill>
+                <a:latin typeface="Calibri" pitchFamily="34" charset="0"/>
+                <a:ea typeface="Calibri" pitchFamily="34" charset="-122"/>
+                <a:cs typeface="Calibri" pitchFamily="34" charset="-120"/>
+              </a:rPr>
+              <a:t>Where it can run — central licensing</a:t>
+            </a:r>
+            <a:endParaRPr lang="en-US" sz="3000" dirty="0"/>
+          </a:p>
+        </p:txBody>
+      </p:sp>
+      <p:sp>
+        <p:nvSpPr>
+          <p:cNvPr id="3" name="Shape 1"/>
+          <p:cNvSpPr/>
+          <p:nvPr/>
+        </p:nvSpPr>
+        <p:spPr>
+          <a:xfrm>
+            <a:off x="548640" y="1371600"/>
+            <a:ext cx="3383280" cy="1554480"/>
+          </a:xfrm>
+          <a:prstGeom prst="roundRect">
+            <a:avLst>
+              <a:gd name="adj" fmla="val 7059"/>
+            </a:avLst>
+          </a:prstGeom>
+          <a:solidFill>
+            <a:srgbClr val="E5F2F0"/>
+          </a:solidFill>
+          <a:ln/>
+        </p:spPr>
+        <p:txBody>
+          <a:bodyPr/>
+          <a:p/>
+        </p:txBody>
+      </p:sp>
+      <p:sp>
+        <p:nvSpPr>
+          <p:cNvPr id="4" name="Text 2"/>
+          <p:cNvSpPr txBox="1"/>
+          <p:nvPr/>
+        </p:nvSpPr>
+        <p:spPr>
+          <a:xfrm>
+            <a:off x="777240" y="1536192"/>
+            <a:ext cx="2926080" cy="365760"/>
+          </a:xfrm>
+          <a:prstGeom prst="rect">
+            <a:avLst/>
+          </a:prstGeom>
+          <a:noFill/>
+          <a:ln/>
+        </p:spPr>
+        <p:txBody>
+          <a:bodyPr wrap="square" lIns="0" tIns="0" rIns="0" bIns="0" rtlCol="0" anchor="ctr"/>
+          <a:lstStyle/>
+          <a:p>
+            <a:pPr indent="0" marL="0">
+              <a:buNone/>
+            </a:pPr>
+            <a:r>
+              <a:rPr lang="en-US" sz="1600" b="1" dirty="0">
+                <a:solidFill>
+                  <a:srgbClr val="01485C"/>
+                </a:solidFill>
+                <a:latin typeface="Calibri" pitchFamily="34" charset="0"/>
+                <a:ea typeface="Calibri" pitchFamily="34" charset="-122"/>
+                <a:cs typeface="Calibri" pitchFamily="34" charset="-120"/>
+              </a:rPr>
+              <a:t>Issued centrally</a:t>
+            </a:r>
+            <a:endParaRPr lang="en-US" sz="1600" dirty="0"/>
+          </a:p>
+        </p:txBody>
+      </p:sp>
+      <p:sp>
+        <p:nvSpPr>
+          <p:cNvPr id="5" name="Text 3"/>
+          <p:cNvSpPr txBox="1"/>
+          <p:nvPr/>
+        </p:nvSpPr>
+        <p:spPr>
+          <a:xfrm>
+            <a:off x="777240" y="1938528"/>
+            <a:ext cx="2926080" cy="914400"/>
+          </a:xfrm>
+          <a:prstGeom prst="rect">
+            <a:avLst/>
+          </a:prstGeom>
+          <a:noFill/>
+          <a:ln/>
+        </p:spPr>
+        <p:txBody>
+          <a:bodyPr wrap="square" lIns="0" tIns="0" rIns="0" bIns="0" rtlCol="0" anchor="ctr"/>
+          <a:lstStyle/>
+          <a:p>
+            <a:pPr indent="0" marL="0">
+              <a:buNone/>
+            </a:pPr>
+            <a:r>
+              <a:rPr lang="en-US" sz="1250" dirty="0">
+                <a:solidFill>
+                  <a:srgbClr val="5F7178"/>
+                </a:solidFill>
+                <a:latin typeface="Calibri" pitchFamily="34" charset="0"/>
+                <a:ea typeface="Calibri" pitchFamily="34" charset="-122"/>
+                <a:cs typeface="Calibri" pitchFamily="34" charset="-120"/>
+              </a:rPr>
+              <a:t>Only the PoC lead’s offline keygen can sign a licence; the drive carries just the public key</a:t>
+            </a:r>
+            <a:endParaRPr lang="en-US" sz="1250" dirty="0"/>
+          </a:p>
+        </p:txBody>
+      </p:sp>
+      <p:sp>
+        <p:nvSpPr>
+          <p:cNvPr id="6" name="Shape 4"/>
+          <p:cNvSpPr/>
+          <p:nvPr/>
+        </p:nvSpPr>
+        <p:spPr>
+          <a:xfrm>
+            <a:off x="3977640" y="2148840"/>
+            <a:ext cx="320040" cy="0"/>
+          </a:xfrm>
+          <a:prstGeom prst="line">
+            <a:avLst/>
+          </a:prstGeom>
+          <a:noFill/>
+          <a:ln w="31750">
+            <a:solidFill>
+              <a:srgbClr val="01485C"/>
+            </a:solidFill>
+            <a:prstDash val="solid"/>
+            <a:tailEnd type="triangle"/>
+          </a:ln>
+        </p:spPr>
+        <p:txBody>
+          <a:bodyPr/>
+          <a:p/>
+        </p:txBody>
+      </p:sp>
+      <p:sp>
+        <p:nvSpPr>
+          <p:cNvPr id="7" name="Shape 5"/>
+          <p:cNvSpPr/>
+          <p:nvPr/>
+        </p:nvSpPr>
+        <p:spPr>
+          <a:xfrm>
+            <a:off x="4343400" y="1371600"/>
+            <a:ext cx="3383280" cy="1554480"/>
+          </a:xfrm>
+          <a:prstGeom prst="roundRect">
+            <a:avLst>
+              <a:gd name="adj" fmla="val 7059"/>
+            </a:avLst>
+          </a:prstGeom>
+          <a:solidFill>
+            <a:srgbClr val="E5F2F0"/>
+          </a:solidFill>
+          <a:ln/>
+        </p:spPr>
+        <p:txBody>
+          <a:bodyPr/>
+          <a:p/>
+        </p:txBody>
+      </p:sp>
+      <p:sp>
+        <p:nvSpPr>
+          <p:cNvPr id="8" name="Text 6"/>
+          <p:cNvSpPr txBox="1"/>
+          <p:nvPr/>
+        </p:nvSpPr>
+        <p:spPr>
+          <a:xfrm>
+            <a:off x="4572000" y="1536192"/>
+            <a:ext cx="2926080" cy="365760"/>
+          </a:xfrm>
+          <a:prstGeom prst="rect">
+            <a:avLst/>
+          </a:prstGeom>
+          <a:noFill/>
+          <a:ln/>
+        </p:spPr>
+        <p:txBody>
+          <a:bodyPr wrap="square" lIns="0" tIns="0" rIns="0" bIns="0" rtlCol="0" anchor="ctr"/>
+          <a:lstStyle/>
+          <a:p>
+            <a:pPr indent="0" marL="0">
+              <a:buNone/>
+            </a:pPr>
+            <a:r>
+              <a:rPr lang="en-US" sz="1600" b="1" dirty="0">
+                <a:solidFill>
+                  <a:srgbClr val="01485C"/>
+                </a:solidFill>
+                <a:latin typeface="Calibri" pitchFamily="34" charset="0"/>
+                <a:ea typeface="Calibri" pitchFamily="34" charset="-122"/>
+                <a:cs typeface="Calibri" pitchFamily="34" charset="-120"/>
+              </a:rPr>
+              <a:t>Bound to the motherboard</a:t>
+            </a:r>
+            <a:endParaRPr lang="en-US" sz="1600" dirty="0"/>
+          </a:p>
+        </p:txBody>
+      </p:sp>
+      <p:sp>
+        <p:nvSpPr>
+          <p:cNvPr id="9" name="Text 7"/>
+          <p:cNvSpPr txBox="1"/>
+          <p:nvPr/>
+        </p:nvSpPr>
+        <p:spPr>
+          <a:xfrm>
+            <a:off x="4572000" y="1938528"/>
+            <a:ext cx="2926080" cy="914400"/>
+          </a:xfrm>
+          <a:prstGeom prst="rect">
+            <a:avLst/>
+          </a:prstGeom>
+          <a:noFill/>
+          <a:ln/>
+        </p:spPr>
+        <p:txBody>
+          <a:bodyPr wrap="square" lIns="0" tIns="0" rIns="0" bIns="0" rtlCol="0" anchor="ctr"/>
+          <a:lstStyle/>
+          <a:p>
+            <a:pPr indent="0" marL="0">
+              <a:buNone/>
+            </a:pPr>
+            <a:r>
+              <a:rPr lang="en-US" sz="1250" dirty="0">
+                <a:solidFill>
+                  <a:srgbClr val="5F7178"/>
+                </a:solidFill>
+                <a:latin typeface="Calibri" pitchFamily="34" charset="0"/>
+                <a:ea typeface="Calibri" pitchFamily="34" charset="-122"/>
+                <a:cs typeface="Calibri" pitchFamily="34" charset="-120"/>
+              </a:rPr>
+              <a:t>ID = hash of system UUID, board serial, drive serial and hostname — a copied drive stays locked elsewhere</a:t>
+            </a:r>
+            <a:endParaRPr lang="en-US" sz="1250" dirty="0"/>
+          </a:p>
+        </p:txBody>
+      </p:sp>
+      <p:sp>
+        <p:nvSpPr>
+          <p:cNvPr id="10" name="Shape 8"/>
+          <p:cNvSpPr/>
+          <p:nvPr/>
+        </p:nvSpPr>
+        <p:spPr>
+          <a:xfrm>
+            <a:off x="7772400" y="2148840"/>
+            <a:ext cx="320040" cy="0"/>
+          </a:xfrm>
+          <a:prstGeom prst="line">
+            <a:avLst/>
+          </a:prstGeom>
+          <a:noFill/>
+          <a:ln w="31750">
+            <a:solidFill>
+              <a:srgbClr val="01485C"/>
+            </a:solidFill>
+            <a:prstDash val="solid"/>
+            <a:tailEnd type="triangle"/>
+          </a:ln>
+        </p:spPr>
+        <p:txBody>
+          <a:bodyPr/>
+          <a:p/>
+        </p:txBody>
+      </p:sp>
+      <p:sp>
+        <p:nvSpPr>
+          <p:cNvPr id="11" name="Shape 9"/>
+          <p:cNvSpPr/>
+          <p:nvPr/>
+        </p:nvSpPr>
+        <p:spPr>
+          <a:xfrm>
+            <a:off x="8138160" y="1371600"/>
+            <a:ext cx="3383280" cy="1554480"/>
+          </a:xfrm>
+          <a:prstGeom prst="roundRect">
+            <a:avLst>
+              <a:gd name="adj" fmla="val 7059"/>
+            </a:avLst>
+          </a:prstGeom>
+          <a:solidFill>
+            <a:srgbClr val="01485C"/>
+          </a:solidFill>
+          <a:ln/>
+        </p:spPr>
+        <p:txBody>
+          <a:bodyPr/>
+          <a:p/>
+        </p:txBody>
+      </p:sp>
+      <p:sp>
+        <p:nvSpPr>
+          <p:cNvPr id="12" name="Text 10"/>
+          <p:cNvSpPr txBox="1"/>
+          <p:nvPr/>
+        </p:nvSpPr>
+        <p:spPr>
+          <a:xfrm>
+            <a:off x="8366760" y="1536192"/>
+            <a:ext cx="2926080" cy="365760"/>
+          </a:xfrm>
+          <a:prstGeom prst="rect">
+            <a:avLst/>
+          </a:prstGeom>
+          <a:noFill/>
+          <a:ln/>
+        </p:spPr>
+        <p:txBody>
+          <a:bodyPr wrap="square" lIns="0" tIns="0" rIns="0" bIns="0" rtlCol="0" anchor="ctr"/>
+          <a:lstStyle/>
+          <a:p>
+            <a:pPr indent="0" marL="0">
+              <a:buNone/>
+            </a:pPr>
+            <a:r>
+              <a:rPr lang="en-US" sz="1600" b="1" dirty="0">
+                <a:solidFill>
+                  <a:srgbClr val="FFFFFF"/>
+                </a:solidFill>
+                <a:latin typeface="Calibri" pitchFamily="34" charset="0"/>
+                <a:ea typeface="Calibri" pitchFamily="34" charset="-122"/>
+                <a:cs typeface="Calibri" pitchFamily="34" charset="-120"/>
+              </a:rPr>
+              <a:t>12-month QIS term</a:t>
+            </a:r>
+            <a:endParaRPr lang="en-US" sz="1600" dirty="0"/>
+          </a:p>
+        </p:txBody>
+      </p:sp>
+      <p:sp>
+        <p:nvSpPr>
+          <p:cNvPr id="13" name="Text 11"/>
+          <p:cNvSpPr txBox="1"/>
+          <p:nvPr/>
+        </p:nvSpPr>
+        <p:spPr>
+          <a:xfrm>
+            <a:off x="8366760" y="1938528"/>
+            <a:ext cx="2926080" cy="914400"/>
+          </a:xfrm>
+          <a:prstGeom prst="rect">
+            <a:avLst/>
+          </a:prstGeom>
+          <a:noFill/>
+          <a:ln/>
+        </p:spPr>
+        <p:txBody>
+          <a:bodyPr wrap="square" lIns="0" tIns="0" rIns="0" bIns="0" rtlCol="0" anchor="ctr"/>
+          <a:lstStyle/>
+          <a:p>
+            <a:pPr indent="0" marL="0">
+              <a:buNone/>
+            </a:pPr>
+            <a:r>
+              <a:rPr lang="en-US" sz="1250" dirty="0">
+                <a:solidFill>
+                  <a:srgbClr val="6CCAD4"/>
+                </a:solidFill>
+                <a:latin typeface="Calibri" pitchFamily="34" charset="0"/>
+                <a:ea typeface="Calibri" pitchFamily="34" charset="-122"/>
+                <a:cs typeface="Calibri" pitchFamily="34" charset="-120"/>
+              </a:rPr>
+              <a:t>Each licence names the newest bundle it covers; a review means a new version and re-issued licences</a:t>
+            </a:r>
+            <a:endParaRPr lang="en-US" sz="1250" dirty="0"/>
+          </a:p>
+        </p:txBody>
+      </p:sp>
+      <p:sp>
+        <p:nvSpPr>
+          <p:cNvPr id="14" name="Text 12"/>
+          <p:cNvSpPr txBox="1"/>
+          <p:nvPr/>
+        </p:nvSpPr>
+        <p:spPr>
+          <a:xfrm>
+            <a:off x="548640" y="3383280"/>
+            <a:ext cx="6949440" cy="411480"/>
+          </a:xfrm>
+          <a:prstGeom prst="rect">
+            <a:avLst/>
+          </a:prstGeom>
+          <a:noFill/>
+          <a:ln/>
+        </p:spPr>
+        <p:txBody>
+          <a:bodyPr wrap="square" lIns="0" tIns="0" rIns="0" bIns="0" rtlCol="0" anchor="ctr"/>
+          <a:lstStyle/>
+          <a:p>
+            <a:pPr indent="0" marL="0">
+              <a:buNone/>
+            </a:pPr>
+            <a:r>
+              <a:rPr lang="en-US" sz="1400" b="1" dirty="0">
+                <a:solidFill>
+                  <a:srgbClr val="01485C"/>
+                </a:solidFill>
+                <a:latin typeface="Calibri" pitchFamily="34" charset="0"/>
+                <a:ea typeface="Calibri" pitchFamily="34" charset="-122"/>
+                <a:cs typeface="Calibri" pitchFamily="34" charset="-120"/>
+              </a:rPr>
+              <a:t>Licence file   </a:t>
+            </a:r>
+            <a:pPr indent="0" marL="0">
+              <a:buNone/>
+            </a:pPr>
+            <a:r>
+              <a:rPr lang="en-US" sz="1400" dirty="0">
+                <a:solidFill>
+                  <a:srgbClr val="17272E"/>
+                </a:solidFill>
+                <a:latin typeface="Calibri" pitchFamily="34" charset="0"/>
+                <a:ea typeface="Calibri" pitchFamily="34" charset="-122"/>
+                <a:cs typeface="Calibri" pitchFamily="34" charset="-120"/>
+              </a:rPr>
+              <a:t>Signed JSON (Ed25519): site, machine IDs, seat cap, expiry, max version — edits are refused</a:t>
+            </a:r>
+            <a:endParaRPr lang="en-US" sz="1400" dirty="0"/>
+          </a:p>
+        </p:txBody>
+      </p:sp>
+      <p:sp>
+        <p:nvSpPr>
+          <p:cNvPr id="15" name="Text 13"/>
+          <p:cNvSpPr txBox="1"/>
+          <p:nvPr/>
+        </p:nvSpPr>
+        <p:spPr>
+          <a:xfrm>
+            <a:off x="548640" y="3858768"/>
+            <a:ext cx="6949440" cy="411480"/>
+          </a:xfrm>
+          <a:prstGeom prst="rect">
+            <a:avLst/>
+          </a:prstGeom>
+          <a:noFill/>
+          <a:ln/>
+        </p:spPr>
+        <p:txBody>
+          <a:bodyPr wrap="square" lIns="0" tIns="0" rIns="0" bIns="0" rtlCol="0" anchor="ctr"/>
+          <a:lstStyle/>
+          <a:p>
+            <a:pPr indent="0" marL="0">
+              <a:buNone/>
+            </a:pPr>
+            <a:r>
+              <a:rPr lang="en-US" sz="1400" b="1" dirty="0">
+                <a:solidFill>
+                  <a:srgbClr val="01485C"/>
+                </a:solidFill>
+                <a:latin typeface="Calibri" pitchFamily="34" charset="0"/>
+                <a:ea typeface="Calibri" pitchFamily="34" charset="-122"/>
+                <a:cs typeface="Calibri" pitchFamily="34" charset="-120"/>
+              </a:rPr>
+              <a:t>Key custody   </a:t>
+            </a:r>
+            <a:pPr indent="0" marL="0">
+              <a:buNone/>
+            </a:pPr>
+            <a:r>
+              <a:rPr lang="en-US" sz="1400" dirty="0">
+                <a:solidFill>
+                  <a:srgbClr val="17272E"/>
+                </a:solidFill>
+                <a:latin typeface="Calibri" pitchFamily="34" charset="0"/>
+                <a:ea typeface="Calibri" pitchFamily="34" charset="-122"/>
+                <a:cs typeface="Calibri" pitchFamily="34" charset="-120"/>
+              </a:rPr>
+              <a:t>Private key kept off the drive (PQ_Licensing); loss means re-issuing, never a bypass</a:t>
+            </a:r>
+            <a:endParaRPr lang="en-US" sz="1400" dirty="0"/>
+          </a:p>
+        </p:txBody>
+      </p:sp>
+      <p:sp>
+        <p:nvSpPr>
+          <p:cNvPr id="16" name="Text 14"/>
+          <p:cNvSpPr txBox="1"/>
+          <p:nvPr/>
+        </p:nvSpPr>
+        <p:spPr>
+          <a:xfrm>
+            <a:off x="548640" y="4334256"/>
+            <a:ext cx="6949440" cy="411480"/>
+          </a:xfrm>
+          <a:prstGeom prst="rect">
+            <a:avLst/>
+          </a:prstGeom>
+          <a:noFill/>
+          <a:ln/>
+        </p:spPr>
+        <p:txBody>
+          <a:bodyPr wrap="square" lIns="0" tIns="0" rIns="0" bIns="0" rtlCol="0" anchor="ctr"/>
+          <a:lstStyle/>
+          <a:p>
+            <a:pPr indent="0" marL="0">
+              <a:buNone/>
+            </a:pPr>
+            <a:r>
+              <a:rPr lang="en-US" sz="1400" b="1" dirty="0">
+                <a:solidFill>
+                  <a:srgbClr val="01485C"/>
+                </a:solidFill>
+                <a:latin typeface="Calibri" pitchFamily="34" charset="0"/>
+                <a:ea typeface="Calibri" pitchFamily="34" charset="-122"/>
+                <a:cs typeface="Calibri" pitchFamily="34" charset="-120"/>
+              </a:rPr>
+              <a:t>Enforcement   </a:t>
+            </a:r>
+            <a:pPr indent="0" marL="0">
+              <a:buNone/>
+            </a:pPr>
+            <a:r>
+              <a:rPr lang="en-US" sz="1400" dirty="0">
+                <a:solidFill>
+                  <a:srgbClr val="17272E"/>
+                </a:solidFill>
+                <a:latin typeface="Calibri" pitchFamily="34" charset="0"/>
+                <a:ea typeface="Calibri" pitchFamily="34" charset="-122"/>
+                <a:cs typeface="Calibri" pitchFamily="34" charset="-120"/>
+              </a:rPr>
+              <a:t>Portal and both engines lock unless a licence covers this PC and version, in term</a:t>
+            </a:r>
+            <a:endParaRPr lang="en-US" sz="1400" dirty="0"/>
+          </a:p>
+        </p:txBody>
+      </p:sp>
+      <p:sp>
+        <p:nvSpPr>
+          <p:cNvPr id="17" name="Text 15"/>
+          <p:cNvSpPr txBox="1"/>
+          <p:nvPr/>
+        </p:nvSpPr>
+        <p:spPr>
+          <a:xfrm>
+            <a:off x="548640" y="4809744"/>
+            <a:ext cx="6949440" cy="411480"/>
+          </a:xfrm>
+          <a:prstGeom prst="rect">
+            <a:avLst/>
+          </a:prstGeom>
+          <a:noFill/>
+          <a:ln/>
+        </p:spPr>
+        <p:txBody>
+          <a:bodyPr wrap="square" lIns="0" tIns="0" rIns="0" bIns="0" rtlCol="0" anchor="ctr"/>
+          <a:lstStyle/>
+          <a:p>
+            <a:pPr indent="0" marL="0">
+              <a:buNone/>
+            </a:pPr>
+            <a:r>
+              <a:rPr lang="en-US" sz="1400" b="1" dirty="0">
+                <a:solidFill>
+                  <a:srgbClr val="01485C"/>
+                </a:solidFill>
+                <a:latin typeface="Calibri" pitchFamily="34" charset="0"/>
+                <a:ea typeface="Calibri" pitchFamily="34" charset="-122"/>
+                <a:cs typeface="Calibri" pitchFamily="34" charset="-120"/>
+              </a:rPr>
+              <a:t>Audit   </a:t>
+            </a:r>
+            <a:pPr indent="0" marL="0">
+              <a:buNone/>
+            </a:pPr>
+            <a:r>
+              <a:rPr lang="en-US" sz="1400" dirty="0">
+                <a:solidFill>
+                  <a:srgbClr val="17272E"/>
+                </a:solidFill>
+                <a:latin typeface="Calibri" pitchFamily="34" charset="0"/>
+                <a:ea typeface="Calibri" pitchFamily="34" charset="-122"/>
+                <a:cs typeface="Calibri" pitchFamily="34" charset="-120"/>
+              </a:rPr>
+              <a:t>Every launch, install and refusal with PC, user, network state; central ledger of copies</a:t>
+            </a:r>
+            <a:endParaRPr lang="en-US" sz="1400" dirty="0"/>
+          </a:p>
+        </p:txBody>
+      </p:sp>
+      <p:sp>
+        <p:nvSpPr>
+          <p:cNvPr id="18" name="Shape 16"/>
+          <p:cNvSpPr/>
+          <p:nvPr/>
+        </p:nvSpPr>
+        <p:spPr>
+          <a:xfrm>
+            <a:off x="7863840" y="3383280"/>
+            <a:ext cx="3794760" cy="2103120"/>
+          </a:xfrm>
+          <a:prstGeom prst="roundRect">
+            <a:avLst>
+              <a:gd name="adj" fmla="val 5217"/>
+            </a:avLst>
+          </a:prstGeom>
+          <a:solidFill>
+            <a:srgbClr val="FDF0E4"/>
+          </a:solidFill>
+          <a:ln w="19050">
+            <a:solidFill>
+              <a:srgbClr val="B4540A"/>
+            </a:solidFill>
+            <a:prstDash val="solid"/>
+          </a:ln>
+        </p:spPr>
+        <p:txBody>
+          <a:bodyPr/>
+          <a:p/>
+        </p:txBody>
+      </p:sp>
+      <p:sp>
+        <p:nvSpPr>
+          <p:cNvPr id="19" name="Shape 17"/>
+          <p:cNvSpPr/>
+          <p:nvPr/>
+        </p:nvSpPr>
+        <p:spPr>
+          <a:xfrm>
+            <a:off x="8138160" y="3611880"/>
+            <a:ext cx="640080" cy="640080"/>
+          </a:xfrm>
+          <a:prstGeom prst="ellipse">
+            <a:avLst/>
+          </a:prstGeom>
+          <a:solidFill>
+            <a:srgbClr val="B4540A"/>
+          </a:solidFill>
+          <a:ln/>
+        </p:spPr>
+        <p:txBody>
+          <a:bodyPr/>
+          <a:p/>
+        </p:txBody>
+      </p:sp>
+      <p:pic>
+        <p:nvPicPr>
+          <p:cNvPr id="20" name="Image 0" descr="icon_warn_w.png">    </p:cNvPr>
+          <p:cNvPicPr>
+            <a:picLocks noChangeAspect="1"/>
+          </p:cNvPicPr>
+          <p:nvPr/>
+        </p:nvPicPr>
+        <p:blipFill>
+          <a:blip r:embed="rId2"/>
+          <a:stretch>
+            <a:fillRect/>
+          </a:stretch>
+        </p:blipFill>
+        <p:spPr>
+          <a:xfrm>
+            <a:off x="8304581" y="3778301"/>
+            <a:ext cx="307238" cy="307238"/>
+          </a:xfrm>
+          <a:prstGeom prst="rect">
+            <a:avLst/>
+          </a:prstGeom>
+        </p:spPr>
+      </p:pic>
+      <p:sp>
+        <p:nvSpPr>
+          <p:cNvPr id="21" name="Text 18"/>
+          <p:cNvSpPr txBox="1"/>
+          <p:nvPr/>
+        </p:nvSpPr>
+        <p:spPr>
+          <a:xfrm>
+            <a:off x="8915400" y="3703320"/>
+            <a:ext cx="2651760" cy="457200"/>
+          </a:xfrm>
+          <a:prstGeom prst="rect">
+            <a:avLst/>
+          </a:prstGeom>
+          <a:noFill/>
+          <a:ln/>
+        </p:spPr>
+        <p:txBody>
+          <a:bodyPr wrap="square" lIns="0" tIns="0" rIns="0" bIns="0" rtlCol="0" anchor="ctr"/>
+          <a:lstStyle/>
+          <a:p>
+            <a:pPr indent="0" marL="0">
+              <a:buNone/>
+            </a:pPr>
+            <a:r>
+              <a:rPr lang="en-US" sz="1500" b="1" dirty="0">
+                <a:solidFill>
+                  <a:srgbClr val="B4540A"/>
+                </a:solidFill>
+                <a:latin typeface="Calibri" pitchFamily="34" charset="0"/>
+                <a:ea typeface="Calibri" pitchFamily="34" charset="-122"/>
+                <a:cs typeface="Calibri" pitchFamily="34" charset="-120"/>
+              </a:rPr>
+              <a:t>Not DRM — by design</a:t>
+            </a:r>
+            <a:endParaRPr lang="en-US" sz="1500" dirty="0"/>
+          </a:p>
+        </p:txBody>
+      </p:sp>
+      <p:sp>
+        <p:nvSpPr>
+          <p:cNvPr id="22" name="Text 19"/>
+          <p:cNvSpPr txBox="1"/>
+          <p:nvPr/>
+        </p:nvSpPr>
+        <p:spPr>
+          <a:xfrm>
+            <a:off x="8138160" y="4343400"/>
+            <a:ext cx="3291840" cy="1005840"/>
+          </a:xfrm>
+          <a:prstGeom prst="rect">
+            <a:avLst/>
+          </a:prstGeom>
+          <a:noFill/>
+          <a:ln/>
+        </p:spPr>
+        <p:txBody>
+          <a:bodyPr wrap="square" lIns="0" tIns="0" rIns="0" bIns="0" rtlCol="0" anchor="ctr"/>
+          <a:lstStyle/>
+          <a:p>
+            <a:pPr indent="0" marL="0">
+              <a:buNone/>
+            </a:pPr>
+            <a:r>
+              <a:rPr lang="en-US" sz="1250" dirty="0">
+                <a:solidFill>
+                  <a:srgbClr val="17272E"/>
+                </a:solidFill>
+                <a:latin typeface="Calibri" pitchFamily="34" charset="0"/>
+                <a:ea typeface="Calibri" pitchFamily="34" charset="-122"/>
+                <a:cs typeface="Calibri" pitchFamily="34" charset="-120"/>
+              </a:rPr>
+              <a:t>The check lives on the drive: a BitLocker holder who edits the Python could remove it. It is an administrative control with evidence and a central register, not copy protection.</a:t>
+            </a:r>
+            <a:endParaRPr lang="en-US" sz="1250" dirty="0"/>
+          </a:p>
+        </p:txBody>
+      </p:sp>
+      <p:sp>
+        <p:nvSpPr>
+          <p:cNvPr id="23" name="Shape 20"/>
+          <p:cNvSpPr/>
+          <p:nvPr/>
+        </p:nvSpPr>
+        <p:spPr>
+          <a:xfrm>
+            <a:off x="0" y="6793992"/>
+            <a:ext cx="2040636" cy="64008"/>
+          </a:xfrm>
+          <a:prstGeom prst="rect">
+            <a:avLst/>
+          </a:prstGeom>
+          <a:solidFill>
+            <a:srgbClr val="01485C"/>
+          </a:solidFill>
+          <a:ln/>
+        </p:spPr>
+      </p:sp>
+      <p:sp>
+        <p:nvSpPr>
+          <p:cNvPr id="24" name="Shape 21"/>
+          <p:cNvSpPr/>
+          <p:nvPr/>
+        </p:nvSpPr>
+        <p:spPr>
+          <a:xfrm>
+            <a:off x="2031492" y="6793992"/>
+            <a:ext cx="2040636" cy="64008"/>
+          </a:xfrm>
+          <a:prstGeom prst="rect">
+            <a:avLst/>
+          </a:prstGeom>
+          <a:solidFill>
+            <a:srgbClr val="146175"/>
+          </a:solidFill>
+          <a:ln/>
+        </p:spPr>
+      </p:sp>
+      <p:sp>
+        <p:nvSpPr>
+          <p:cNvPr id="25" name="Shape 22"/>
+          <p:cNvSpPr/>
+          <p:nvPr/>
+        </p:nvSpPr>
+        <p:spPr>
+          <a:xfrm>
+            <a:off x="4062984" y="6793992"/>
+            <a:ext cx="2040636" cy="64008"/>
+          </a:xfrm>
+          <a:prstGeom prst="rect">
+            <a:avLst/>
+          </a:prstGeom>
+          <a:solidFill>
+            <a:srgbClr val="11B5AE"/>
+          </a:solidFill>
+          <a:ln/>
+        </p:spPr>
+      </p:sp>
+      <p:sp>
+        <p:nvSpPr>
+          <p:cNvPr id="26" name="Shape 23"/>
+          <p:cNvSpPr/>
+          <p:nvPr/>
+        </p:nvSpPr>
+        <p:spPr>
+          <a:xfrm>
+            <a:off x="6094476" y="6793992"/>
+            <a:ext cx="2040636" cy="64008"/>
+          </a:xfrm>
+          <a:prstGeom prst="rect">
+            <a:avLst/>
+          </a:prstGeom>
+          <a:solidFill>
+            <a:srgbClr val="6CCAD4"/>
+          </a:solidFill>
+          <a:ln/>
+        </p:spPr>
+      </p:sp>
+      <p:sp>
+        <p:nvSpPr>
+          <p:cNvPr id="27" name="Shape 24"/>
+          <p:cNvSpPr/>
+          <p:nvPr/>
+        </p:nvSpPr>
+        <p:spPr>
+          <a:xfrm>
+            <a:off x="8125968" y="6793992"/>
+            <a:ext cx="2040636" cy="64008"/>
+          </a:xfrm>
+          <a:prstGeom prst="rect">
+            <a:avLst/>
+          </a:prstGeom>
+          <a:solidFill>
+            <a:srgbClr val="7FC04C"/>
+          </a:solidFill>
+          <a:ln/>
+        </p:spPr>
+      </p:sp>
+      <p:sp>
+        <p:nvSpPr>
+          <p:cNvPr id="28" name="Shape 25"/>
+          <p:cNvSpPr/>
+          <p:nvPr/>
+        </p:nvSpPr>
+        <p:spPr>
+          <a:xfrm>
+            <a:off x="10157460" y="6793992"/>
+            <a:ext cx="2040636" cy="64008"/>
+          </a:xfrm>
+          <a:prstGeom prst="rect">
+            <a:avLst/>
+          </a:prstGeom>
+          <a:solidFill>
+            <a:srgbClr val="E1DD57"/>
+          </a:solidFill>
+          <a:ln/>
+        </p:spPr>
       </p:sp>
     </p:spTree>
   </p:cSld>
@@ -5121,7 +5373,7 @@
                 <a:ea typeface="Calibri" pitchFamily="34" charset="-122"/>
                 <a:cs typeface="Calibri" pitchFamily="34" charset="-120"/>
               </a:rPr>
-              <a:t>Runs only on PCs the PoC team has enrolled — no installation, no admin rights, no system changes.</a:t>
+              <a:t>Runs only on PCs licensed by the PoC lead — no installation, no admin rights, no system changes.</a:t>
             </a:r>
             <a:endParaRPr lang="en-US" sz="1500" dirty="0"/>
           </a:p>
@@ -8911,7 +9163,7 @@
                 <a:ea typeface="Calibri" pitchFamily="34" charset="-122"/>
                 <a:cs typeface="Calibri" pitchFamily="34" charset="-120"/>
               </a:rPr>
-              <a:t>PC enrolment bound to the motherboard, 12-month term, signed registry, audited</a:t>
+              <a:t>Central licence per PC — motherboard-bound, 12-month QIS term, version-gated, signed</a:t>
             </a:r>
             <a:endParaRPr lang="en-US" sz="1250" dirty="0"/>
           </a:p>
@@ -11340,920 +11592,6 @@
 </file>
 
 <file path=ppt/slides/slide8.xml><?xml version="1.0" encoding="utf-8"?>
-<p:sld xmlns:a="http://schemas.openxmlformats.org/drawingml/2006/main" xmlns:p="http://schemas.openxmlformats.org/presentationml/2006/main" xmlns:r="http://schemas.openxmlformats.org/officeDocument/2006/relationships">
-  <p:cSld>
-    <p:spTree>
-      <p:nvGrpSpPr>
-        <p:cNvPr id="1" name=""/>
-        <p:cNvGrpSpPr/>
-        <p:nvPr/>
-      </p:nvGrpSpPr>
-      <p:grpSpPr/>
-      <p:sp>
-        <p:nvSpPr>
-          <p:cNvPr id="2" name="Text 0"/>
-          <p:cNvSpPr txBox="1"/>
-          <p:nvPr/>
-        </p:nvSpPr>
-        <p:spPr>
-          <a:xfrm>
-            <a:off x="548640" y="320040"/>
-            <a:ext cx="11064240" cy="685800"/>
-          </a:xfrm>
-          <a:prstGeom prst="rect">
-            <a:avLst/>
-          </a:prstGeom>
-          <a:noFill/>
-          <a:ln/>
-        </p:spPr>
-        <p:txBody>
-          <a:bodyPr wrap="square" lIns="0" tIns="0" rIns="0" bIns="0" rtlCol="0" anchor="ctr"/>
-          <a:lstStyle/>
-          <a:p>
-            <a:pPr algn="l" indent="0" marL="0">
-              <a:buNone/>
-            </a:pPr>
-            <a:r>
-              <a:rPr lang="en-US" sz="3000" b="1" dirty="0">
-                <a:solidFill>
-                  <a:srgbClr val="01485C"/>
-                </a:solidFill>
-                <a:latin typeface="Calibri" pitchFamily="34" charset="0"/>
-                <a:ea typeface="Calibri" pitchFamily="34" charset="-122"/>
-                <a:cs typeface="Calibri" pitchFamily="34" charset="-120"/>
-              </a:rPr>
-              <a:t>Where it can run — PC enrolment</a:t>
-            </a:r>
-            <a:endParaRPr lang="en-US" sz="3000" dirty="0"/>
-          </a:p>
-        </p:txBody>
-      </p:sp>
-      <p:sp>
-        <p:nvSpPr>
-          <p:cNvPr id="3" name="Shape 1"/>
-          <p:cNvSpPr/>
-          <p:nvPr/>
-        </p:nvSpPr>
-        <p:spPr>
-          <a:xfrm>
-            <a:off x="548640" y="1371600"/>
-            <a:ext cx="3383280" cy="1554480"/>
-          </a:xfrm>
-          <a:prstGeom prst="roundRect">
-            <a:avLst>
-              <a:gd name="adj" fmla="val 7059"/>
-            </a:avLst>
-          </a:prstGeom>
-          <a:solidFill>
-            <a:srgbClr val="E5F2F0"/>
-          </a:solidFill>
-          <a:ln/>
-        </p:spPr>
-        <p:txBody>
-          <a:bodyPr/>
-          <a:p/>
-        </p:txBody>
-      </p:sp>
-      <p:sp>
-        <p:nvSpPr>
-          <p:cNvPr id="4" name="Text 2"/>
-          <p:cNvSpPr txBox="1"/>
-          <p:nvPr/>
-        </p:nvSpPr>
-        <p:spPr>
-          <a:xfrm>
-            <a:off x="777240" y="1536192"/>
-            <a:ext cx="2926080" cy="365760"/>
-          </a:xfrm>
-          <a:prstGeom prst="rect">
-            <a:avLst/>
-          </a:prstGeom>
-          <a:noFill/>
-          <a:ln/>
-        </p:spPr>
-        <p:txBody>
-          <a:bodyPr wrap="square" lIns="0" tIns="0" rIns="0" bIns="0" rtlCol="0" anchor="ctr"/>
-          <a:lstStyle/>
-          <a:p>
-            <a:pPr indent="0" marL="0">
-              <a:buNone/>
-            </a:pPr>
-            <a:r>
-              <a:rPr lang="en-US" sz="1600" b="1" dirty="0">
-                <a:solidFill>
-                  <a:srgbClr val="01485C"/>
-                </a:solidFill>
-                <a:latin typeface="Calibri" pitchFamily="34" charset="0"/>
-                <a:ea typeface="Calibri" pitchFamily="34" charset="-122"/>
-                <a:cs typeface="Calibri" pitchFamily="34" charset="-120"/>
-              </a:rPr>
-              <a:t>Enrol once per PC</a:t>
-            </a:r>
-            <a:endParaRPr lang="en-US" sz="1600" dirty="0"/>
-          </a:p>
-        </p:txBody>
-      </p:sp>
-      <p:sp>
-        <p:nvSpPr>
-          <p:cNvPr id="5" name="Text 3"/>
-          <p:cNvSpPr txBox="1"/>
-          <p:nvPr/>
-        </p:nvSpPr>
-        <p:spPr>
-          <a:xfrm>
-            <a:off x="777240" y="1938528"/>
-            <a:ext cx="2926080" cy="914400"/>
-          </a:xfrm>
-          <a:prstGeom prst="rect">
-            <a:avLst/>
-          </a:prstGeom>
-          <a:noFill/>
-          <a:ln/>
-        </p:spPr>
-        <p:txBody>
-          <a:bodyPr wrap="square" lIns="0" tIns="0" rIns="0" bIns="0" rtlCol="0" anchor="ctr"/>
-          <a:lstStyle/>
-          <a:p>
-            <a:pPr indent="0" marL="0">
-              <a:buNone/>
-            </a:pPr>
-            <a:r>
-              <a:rPr lang="en-US" sz="1250" dirty="0">
-                <a:solidFill>
-                  <a:srgbClr val="5F7178"/>
-                </a:solidFill>
-                <a:latin typeface="Calibri" pitchFamily="34" charset="0"/>
-                <a:ea typeface="Calibri" pitchFamily="34" charset="-122"/>
-                <a:cs typeface="Calibri" pitchFamily="34" charset="-120"/>
-              </a:rPr>
-              <a:t>First launch on a PC shows its machine ID; a PoC team member enters the enrolment password</a:t>
-            </a:r>
-            <a:endParaRPr lang="en-US" sz="1250" dirty="0"/>
-          </a:p>
-        </p:txBody>
-      </p:sp>
-      <p:sp>
-        <p:nvSpPr>
-          <p:cNvPr id="6" name="Shape 4"/>
-          <p:cNvSpPr/>
-          <p:nvPr/>
-        </p:nvSpPr>
-        <p:spPr>
-          <a:xfrm>
-            <a:off x="3977640" y="2148840"/>
-            <a:ext cx="320040" cy="0"/>
-          </a:xfrm>
-          <a:prstGeom prst="line">
-            <a:avLst/>
-          </a:prstGeom>
-          <a:noFill/>
-          <a:ln w="31750">
-            <a:solidFill>
-              <a:srgbClr val="01485C"/>
-            </a:solidFill>
-            <a:prstDash val="solid"/>
-            <a:tailEnd type="triangle"/>
-          </a:ln>
-        </p:spPr>
-        <p:txBody>
-          <a:bodyPr/>
-          <a:p/>
-        </p:txBody>
-      </p:sp>
-      <p:sp>
-        <p:nvSpPr>
-          <p:cNvPr id="7" name="Shape 5"/>
-          <p:cNvSpPr/>
-          <p:nvPr/>
-        </p:nvSpPr>
-        <p:spPr>
-          <a:xfrm>
-            <a:off x="4343400" y="1371600"/>
-            <a:ext cx="3383280" cy="1554480"/>
-          </a:xfrm>
-          <a:prstGeom prst="roundRect">
-            <a:avLst>
-              <a:gd name="adj" fmla="val 7059"/>
-            </a:avLst>
-          </a:prstGeom>
-          <a:solidFill>
-            <a:srgbClr val="E5F2F0"/>
-          </a:solidFill>
-          <a:ln/>
-        </p:spPr>
-        <p:txBody>
-          <a:bodyPr/>
-          <a:p/>
-        </p:txBody>
-      </p:sp>
-      <p:sp>
-        <p:nvSpPr>
-          <p:cNvPr id="8" name="Text 6"/>
-          <p:cNvSpPr txBox="1"/>
-          <p:nvPr/>
-        </p:nvSpPr>
-        <p:spPr>
-          <a:xfrm>
-            <a:off x="4572000" y="1536192"/>
-            <a:ext cx="2926080" cy="365760"/>
-          </a:xfrm>
-          <a:prstGeom prst="rect">
-            <a:avLst/>
-          </a:prstGeom>
-          <a:noFill/>
-          <a:ln/>
-        </p:spPr>
-        <p:txBody>
-          <a:bodyPr wrap="square" lIns="0" tIns="0" rIns="0" bIns="0" rtlCol="0" anchor="ctr"/>
-          <a:lstStyle/>
-          <a:p>
-            <a:pPr indent="0" marL="0">
-              <a:buNone/>
-            </a:pPr>
-            <a:r>
-              <a:rPr lang="en-US" sz="1600" b="1" dirty="0">
-                <a:solidFill>
-                  <a:srgbClr val="01485C"/>
-                </a:solidFill>
-                <a:latin typeface="Calibri" pitchFamily="34" charset="0"/>
-                <a:ea typeface="Calibri" pitchFamily="34" charset="-122"/>
-                <a:cs typeface="Calibri" pitchFamily="34" charset="-120"/>
-              </a:rPr>
-              <a:t>Bound to the motherboard</a:t>
-            </a:r>
-            <a:endParaRPr lang="en-US" sz="1600" dirty="0"/>
-          </a:p>
-        </p:txBody>
-      </p:sp>
-      <p:sp>
-        <p:nvSpPr>
-          <p:cNvPr id="9" name="Text 7"/>
-          <p:cNvSpPr txBox="1"/>
-          <p:nvPr/>
-        </p:nvSpPr>
-        <p:spPr>
-          <a:xfrm>
-            <a:off x="4572000" y="1938528"/>
-            <a:ext cx="2926080" cy="914400"/>
-          </a:xfrm>
-          <a:prstGeom prst="rect">
-            <a:avLst/>
-          </a:prstGeom>
-          <a:noFill/>
-          <a:ln/>
-        </p:spPr>
-        <p:txBody>
-          <a:bodyPr wrap="square" lIns="0" tIns="0" rIns="0" bIns="0" rtlCol="0" anchor="ctr"/>
-          <a:lstStyle/>
-          <a:p>
-            <a:pPr indent="0" marL="0">
-              <a:buNone/>
-            </a:pPr>
-            <a:r>
-              <a:rPr lang="en-US" sz="1250" dirty="0">
-                <a:solidFill>
-                  <a:srgbClr val="5F7178"/>
-                </a:solidFill>
-                <a:latin typeface="Calibri" pitchFamily="34" charset="0"/>
-                <a:ea typeface="Calibri" pitchFamily="34" charset="-122"/>
-                <a:cs typeface="Calibri" pitchFamily="34" charset="-120"/>
-              </a:rPr>
-              <a:t>ID = hash of system UUID, board serial, drive serial and hostname — a copied drive stays locked elsewhere</a:t>
-            </a:r>
-            <a:endParaRPr lang="en-US" sz="1250" dirty="0"/>
-          </a:p>
-        </p:txBody>
-      </p:sp>
-      <p:sp>
-        <p:nvSpPr>
-          <p:cNvPr id="10" name="Shape 8"/>
-          <p:cNvSpPr/>
-          <p:nvPr/>
-        </p:nvSpPr>
-        <p:spPr>
-          <a:xfrm>
-            <a:off x="7772400" y="2148840"/>
-            <a:ext cx="320040" cy="0"/>
-          </a:xfrm>
-          <a:prstGeom prst="line">
-            <a:avLst/>
-          </a:prstGeom>
-          <a:noFill/>
-          <a:ln w="31750">
-            <a:solidFill>
-              <a:srgbClr val="01485C"/>
-            </a:solidFill>
-            <a:prstDash val="solid"/>
-            <a:tailEnd type="triangle"/>
-          </a:ln>
-        </p:spPr>
-        <p:txBody>
-          <a:bodyPr/>
-          <a:p/>
-        </p:txBody>
-      </p:sp>
-      <p:sp>
-        <p:nvSpPr>
-          <p:cNvPr id="11" name="Shape 9"/>
-          <p:cNvSpPr/>
-          <p:nvPr/>
-        </p:nvSpPr>
-        <p:spPr>
-          <a:xfrm>
-            <a:off x="8138160" y="1371600"/>
-            <a:ext cx="3383280" cy="1554480"/>
-          </a:xfrm>
-          <a:prstGeom prst="roundRect">
-            <a:avLst>
-              <a:gd name="adj" fmla="val 7059"/>
-            </a:avLst>
-          </a:prstGeom>
-          <a:solidFill>
-            <a:srgbClr val="01485C"/>
-          </a:solidFill>
-          <a:ln/>
-        </p:spPr>
-        <p:txBody>
-          <a:bodyPr/>
-          <a:p/>
-        </p:txBody>
-      </p:sp>
-      <p:sp>
-        <p:nvSpPr>
-          <p:cNvPr id="12" name="Text 10"/>
-          <p:cNvSpPr txBox="1"/>
-          <p:nvPr/>
-        </p:nvSpPr>
-        <p:spPr>
-          <a:xfrm>
-            <a:off x="8366760" y="1536192"/>
-            <a:ext cx="2926080" cy="365760"/>
-          </a:xfrm>
-          <a:prstGeom prst="rect">
-            <a:avLst/>
-          </a:prstGeom>
-          <a:noFill/>
-          <a:ln/>
-        </p:spPr>
-        <p:txBody>
-          <a:bodyPr wrap="square" lIns="0" tIns="0" rIns="0" bIns="0" rtlCol="0" anchor="ctr"/>
-          <a:lstStyle/>
-          <a:p>
-            <a:pPr indent="0" marL="0">
-              <a:buNone/>
-            </a:pPr>
-            <a:r>
-              <a:rPr lang="en-US" sz="1600" b="1" dirty="0">
-                <a:solidFill>
-                  <a:srgbClr val="FFFFFF"/>
-                </a:solidFill>
-                <a:latin typeface="Calibri" pitchFamily="34" charset="0"/>
-                <a:ea typeface="Calibri" pitchFamily="34" charset="-122"/>
-                <a:cs typeface="Calibri" pitchFamily="34" charset="-120"/>
-              </a:rPr>
-              <a:t>12-month term</a:t>
-            </a:r>
-            <a:endParaRPr lang="en-US" sz="1600" dirty="0"/>
-          </a:p>
-        </p:txBody>
-      </p:sp>
-      <p:sp>
-        <p:nvSpPr>
-          <p:cNvPr id="13" name="Text 11"/>
-          <p:cNvSpPr txBox="1"/>
-          <p:nvPr/>
-        </p:nvSpPr>
-        <p:spPr>
-          <a:xfrm>
-            <a:off x="8366760" y="1938528"/>
-            <a:ext cx="2926080" cy="914400"/>
-          </a:xfrm>
-          <a:prstGeom prst="rect">
-            <a:avLst/>
-          </a:prstGeom>
-          <a:noFill/>
-          <a:ln/>
-        </p:spPr>
-        <p:txBody>
-          <a:bodyPr wrap="square" lIns="0" tIns="0" rIns="0" bIns="0" rtlCol="0" anchor="ctr"/>
-          <a:lstStyle/>
-          <a:p>
-            <a:pPr indent="0" marL="0">
-              <a:buNone/>
-            </a:pPr>
-            <a:r>
-              <a:rPr lang="en-US" sz="1250" dirty="0">
-                <a:solidFill>
-                  <a:srgbClr val="6CCAD4"/>
-                </a:solidFill>
-                <a:latin typeface="Calibri" pitchFamily="34" charset="0"/>
-                <a:ea typeface="Calibri" pitchFamily="34" charset="-122"/>
-                <a:cs typeface="Calibri" pitchFamily="34" charset="-120"/>
-              </a:rPr>
-              <a:t>Each enrolment records the bundle version and expires; renewal brings the PC back for updates</a:t>
-            </a:r>
-            <a:endParaRPr lang="en-US" sz="1250" dirty="0"/>
-          </a:p>
-        </p:txBody>
-      </p:sp>
-      <p:sp>
-        <p:nvSpPr>
-          <p:cNvPr id="14" name="Text 12"/>
-          <p:cNvSpPr txBox="1"/>
-          <p:nvPr/>
-        </p:nvSpPr>
-        <p:spPr>
-          <a:xfrm>
-            <a:off x="548640" y="3383280"/>
-            <a:ext cx="6949440" cy="411480"/>
-          </a:xfrm>
-          <a:prstGeom prst="rect">
-            <a:avLst/>
-          </a:prstGeom>
-          <a:noFill/>
-          <a:ln/>
-        </p:spPr>
-        <p:txBody>
-          <a:bodyPr wrap="square" lIns="0" tIns="0" rIns="0" bIns="0" rtlCol="0" anchor="ctr"/>
-          <a:lstStyle/>
-          <a:p>
-            <a:pPr indent="0" marL="0">
-              <a:buNone/>
-            </a:pPr>
-            <a:r>
-              <a:rPr lang="en-US" sz="1400" b="1" dirty="0">
-                <a:solidFill>
-                  <a:srgbClr val="01485C"/>
-                </a:solidFill>
-                <a:latin typeface="Calibri" pitchFamily="34" charset="0"/>
-                <a:ea typeface="Calibri" pitchFamily="34" charset="-122"/>
-                <a:cs typeface="Calibri" pitchFamily="34" charset="-120"/>
-              </a:rPr>
-              <a:t>Registry   </a:t>
-            </a:r>
-            <a:pPr indent="0" marL="0">
-              <a:buNone/>
-            </a:pPr>
-            <a:r>
-              <a:rPr lang="en-US" sz="1400" dirty="0">
-                <a:solidFill>
-                  <a:srgbClr val="17272E"/>
-                </a:solidFill>
-                <a:latin typeface="Calibri" pitchFamily="34" charset="0"/>
-                <a:ea typeface="Calibri" pitchFamily="34" charset="-122"/>
-                <a:cs typeface="Calibri" pitchFamily="34" charset="-120"/>
-              </a:rPr>
-              <a:t>Ed25519-signed entries, verified at every launch — an edited entry stops counting</a:t>
-            </a:r>
-            <a:endParaRPr lang="en-US" sz="1400" dirty="0"/>
-          </a:p>
-        </p:txBody>
-      </p:sp>
-      <p:sp>
-        <p:nvSpPr>
-          <p:cNvPr id="15" name="Text 13"/>
-          <p:cNvSpPr txBox="1"/>
-          <p:nvPr/>
-        </p:nvSpPr>
-        <p:spPr>
-          <a:xfrm>
-            <a:off x="548640" y="3858768"/>
-            <a:ext cx="6949440" cy="411480"/>
-          </a:xfrm>
-          <a:prstGeom prst="rect">
-            <a:avLst/>
-          </a:prstGeom>
-          <a:noFill/>
-          <a:ln/>
-        </p:spPr>
-        <p:txBody>
-          <a:bodyPr wrap="square" lIns="0" tIns="0" rIns="0" bIns="0" rtlCol="0" anchor="ctr"/>
-          <a:lstStyle/>
-          <a:p>
-            <a:pPr indent="0" marL="0">
-              <a:buNone/>
-            </a:pPr>
-            <a:r>
-              <a:rPr lang="en-US" sz="1400" b="1" dirty="0">
-                <a:solidFill>
-                  <a:srgbClr val="01485C"/>
-                </a:solidFill>
-                <a:latin typeface="Calibri" pitchFamily="34" charset="0"/>
-                <a:ea typeface="Calibri" pitchFamily="34" charset="-122"/>
-                <a:cs typeface="Calibri" pitchFamily="34" charset="-120"/>
-              </a:rPr>
-              <a:t>Key custody   </a:t>
-            </a:r>
-            <a:pPr indent="0" marL="0">
-              <a:buNone/>
-            </a:pPr>
-            <a:r>
-              <a:rPr lang="en-US" sz="1400" dirty="0">
-                <a:solidFill>
-                  <a:srgbClr val="17272E"/>
-                </a:solidFill>
-                <a:latin typeface="Calibri" pitchFamily="34" charset="0"/>
-                <a:ea typeface="Calibri" pitchFamily="34" charset="-122"/>
-                <a:cs typeface="Calibri" pitchFamily="34" charset="-120"/>
-              </a:rPr>
-              <a:t>Signing key stored only encrypted with the enrolment password (PBKDF2, 600,000 rounds)</a:t>
-            </a:r>
-            <a:endParaRPr lang="en-US" sz="1400" dirty="0"/>
-          </a:p>
-        </p:txBody>
-      </p:sp>
-      <p:sp>
-        <p:nvSpPr>
-          <p:cNvPr id="16" name="Text 14"/>
-          <p:cNvSpPr txBox="1"/>
-          <p:nvPr/>
-        </p:nvSpPr>
-        <p:spPr>
-          <a:xfrm>
-            <a:off x="548640" y="4334256"/>
-            <a:ext cx="6949440" cy="411480"/>
-          </a:xfrm>
-          <a:prstGeom prst="rect">
-            <a:avLst/>
-          </a:prstGeom>
-          <a:noFill/>
-          <a:ln/>
-        </p:spPr>
-        <p:txBody>
-          <a:bodyPr wrap="square" lIns="0" tIns="0" rIns="0" bIns="0" rtlCol="0" anchor="ctr"/>
-          <a:lstStyle/>
-          <a:p>
-            <a:pPr indent="0" marL="0">
-              <a:buNone/>
-            </a:pPr>
-            <a:r>
-              <a:rPr lang="en-US" sz="1400" b="1" dirty="0">
-                <a:solidFill>
-                  <a:srgbClr val="01485C"/>
-                </a:solidFill>
-                <a:latin typeface="Calibri" pitchFamily="34" charset="0"/>
-                <a:ea typeface="Calibri" pitchFamily="34" charset="-122"/>
-                <a:cs typeface="Calibri" pitchFamily="34" charset="-120"/>
-              </a:rPr>
-              <a:t>Enforcement   </a:t>
-            </a:r>
-            <a:pPr indent="0" marL="0">
-              <a:buNone/>
-            </a:pPr>
-            <a:r>
-              <a:rPr lang="en-US" sz="1400" dirty="0">
-                <a:solidFill>
-                  <a:srgbClr val="17272E"/>
-                </a:solidFill>
-                <a:latin typeface="Calibri" pitchFamily="34" charset="0"/>
-                <a:ea typeface="Calibri" pitchFamily="34" charset="-122"/>
-                <a:cs typeface="Calibri" pitchFamily="34" charset="-120"/>
-              </a:rPr>
-              <a:t>Portal and both engines lock unless this PC is enrolled and within its term</a:t>
-            </a:r>
-            <a:endParaRPr lang="en-US" sz="1400" dirty="0"/>
-          </a:p>
-        </p:txBody>
-      </p:sp>
-      <p:sp>
-        <p:nvSpPr>
-          <p:cNvPr id="17" name="Text 15"/>
-          <p:cNvSpPr txBox="1"/>
-          <p:nvPr/>
-        </p:nvSpPr>
-        <p:spPr>
-          <a:xfrm>
-            <a:off x="548640" y="4809744"/>
-            <a:ext cx="6949440" cy="411480"/>
-          </a:xfrm>
-          <a:prstGeom prst="rect">
-            <a:avLst/>
-          </a:prstGeom>
-          <a:noFill/>
-          <a:ln/>
-        </p:spPr>
-        <p:txBody>
-          <a:bodyPr wrap="square" lIns="0" tIns="0" rIns="0" bIns="0" rtlCol="0" anchor="ctr"/>
-          <a:lstStyle/>
-          <a:p>
-            <a:pPr indent="0" marL="0">
-              <a:buNone/>
-            </a:pPr>
-            <a:r>
-              <a:rPr lang="en-US" sz="1400" b="1" dirty="0">
-                <a:solidFill>
-                  <a:srgbClr val="01485C"/>
-                </a:solidFill>
-                <a:latin typeface="Calibri" pitchFamily="34" charset="0"/>
-                <a:ea typeface="Calibri" pitchFamily="34" charset="-122"/>
-                <a:cs typeface="Calibri" pitchFamily="34" charset="-120"/>
-              </a:rPr>
-              <a:t>Audit   </a:t>
-            </a:r>
-            <a:pPr indent="0" marL="0">
-              <a:buNone/>
-            </a:pPr>
-            <a:r>
-              <a:rPr lang="en-US" sz="1400" dirty="0">
-                <a:solidFill>
-                  <a:srgbClr val="17272E"/>
-                </a:solidFill>
-                <a:latin typeface="Calibri" pitchFamily="34" charset="0"/>
-                <a:ea typeface="Calibri" pitchFamily="34" charset="-122"/>
-                <a:cs typeface="Calibri" pitchFamily="34" charset="-120"/>
-              </a:rPr>
-              <a:t>Every launch, enrolment, renewal, revocation and failed password — with PC, user, network state</a:t>
-            </a:r>
-            <a:endParaRPr lang="en-US" sz="1400" dirty="0"/>
-          </a:p>
-        </p:txBody>
-      </p:sp>
-      <p:sp>
-        <p:nvSpPr>
-          <p:cNvPr id="18" name="Shape 16"/>
-          <p:cNvSpPr/>
-          <p:nvPr/>
-        </p:nvSpPr>
-        <p:spPr>
-          <a:xfrm>
-            <a:off x="7863840" y="3383280"/>
-            <a:ext cx="3794760" cy="2103120"/>
-          </a:xfrm>
-          <a:prstGeom prst="roundRect">
-            <a:avLst>
-              <a:gd name="adj" fmla="val 5217"/>
-            </a:avLst>
-          </a:prstGeom>
-          <a:solidFill>
-            <a:srgbClr val="FDF0E4"/>
-          </a:solidFill>
-          <a:ln w="19050">
-            <a:solidFill>
-              <a:srgbClr val="B4540A"/>
-            </a:solidFill>
-            <a:prstDash val="solid"/>
-          </a:ln>
-        </p:spPr>
-        <p:txBody>
-          <a:bodyPr/>
-          <a:p/>
-        </p:txBody>
-      </p:sp>
-      <p:sp>
-        <p:nvSpPr>
-          <p:cNvPr id="19" name="Shape 17"/>
-          <p:cNvSpPr/>
-          <p:nvPr/>
-        </p:nvSpPr>
-        <p:spPr>
-          <a:xfrm>
-            <a:off x="8138160" y="3611880"/>
-            <a:ext cx="640080" cy="640080"/>
-          </a:xfrm>
-          <a:prstGeom prst="ellipse">
-            <a:avLst/>
-          </a:prstGeom>
-          <a:solidFill>
-            <a:srgbClr val="B4540A"/>
-          </a:solidFill>
-          <a:ln/>
-        </p:spPr>
-        <p:txBody>
-          <a:bodyPr/>
-          <a:p/>
-        </p:txBody>
-      </p:sp>
-      <p:pic>
-        <p:nvPicPr>
-          <p:cNvPr id="20" name="Image 0" descr="icon_warn_w.png">    </p:cNvPr>
-          <p:cNvPicPr>
-            <a:picLocks noChangeAspect="1"/>
-          </p:cNvPicPr>
-          <p:nvPr/>
-        </p:nvPicPr>
-        <p:blipFill>
-          <a:blip r:embed="rId2"/>
-          <a:stretch>
-            <a:fillRect/>
-          </a:stretch>
-        </p:blipFill>
-        <p:spPr>
-          <a:xfrm>
-            <a:off x="8304581" y="3778301"/>
-            <a:ext cx="307238" cy="307238"/>
-          </a:xfrm>
-          <a:prstGeom prst="rect">
-            <a:avLst/>
-          </a:prstGeom>
-        </p:spPr>
-      </p:pic>
-      <p:sp>
-        <p:nvSpPr>
-          <p:cNvPr id="21" name="Text 18"/>
-          <p:cNvSpPr txBox="1"/>
-          <p:nvPr/>
-        </p:nvSpPr>
-        <p:spPr>
-          <a:xfrm>
-            <a:off x="8915400" y="3703320"/>
-            <a:ext cx="2651760" cy="457200"/>
-          </a:xfrm>
-          <a:prstGeom prst="rect">
-            <a:avLst/>
-          </a:prstGeom>
-          <a:noFill/>
-          <a:ln/>
-        </p:spPr>
-        <p:txBody>
-          <a:bodyPr wrap="square" lIns="0" tIns="0" rIns="0" bIns="0" rtlCol="0" anchor="ctr"/>
-          <a:lstStyle/>
-          <a:p>
-            <a:pPr indent="0" marL="0">
-              <a:buNone/>
-            </a:pPr>
-            <a:r>
-              <a:rPr lang="en-US" sz="1500" b="1" dirty="0">
-                <a:solidFill>
-                  <a:srgbClr val="B4540A"/>
-                </a:solidFill>
-                <a:latin typeface="Calibri" pitchFamily="34" charset="0"/>
-                <a:ea typeface="Calibri" pitchFamily="34" charset="-122"/>
-                <a:cs typeface="Calibri" pitchFamily="34" charset="-120"/>
-              </a:rPr>
-              <a:t>Not DRM — by design</a:t>
-            </a:r>
-            <a:endParaRPr lang="en-US" sz="1500" dirty="0"/>
-          </a:p>
-        </p:txBody>
-      </p:sp>
-      <p:sp>
-        <p:nvSpPr>
-          <p:cNvPr id="22" name="Text 19"/>
-          <p:cNvSpPr txBox="1"/>
-          <p:nvPr/>
-        </p:nvSpPr>
-        <p:spPr>
-          <a:xfrm>
-            <a:off x="8138160" y="4343400"/>
-            <a:ext cx="3291840" cy="1005840"/>
-          </a:xfrm>
-          <a:prstGeom prst="rect">
-            <a:avLst/>
-          </a:prstGeom>
-          <a:noFill/>
-          <a:ln/>
-        </p:spPr>
-        <p:txBody>
-          <a:bodyPr wrap="square" lIns="0" tIns="0" rIns="0" bIns="0" rtlCol="0" anchor="ctr"/>
-          <a:lstStyle/>
-          <a:p>
-            <a:pPr indent="0" marL="0">
-              <a:buNone/>
-            </a:pPr>
-            <a:r>
-              <a:rPr lang="en-US" sz="1250" dirty="0">
-                <a:solidFill>
-                  <a:srgbClr val="17272E"/>
-                </a:solidFill>
-                <a:latin typeface="Calibri" pitchFamily="34" charset="0"/>
-                <a:ea typeface="Calibri" pitchFamily="34" charset="-122"/>
-                <a:cs typeface="Calibri" pitchFamily="34" charset="-120"/>
-              </a:rPr>
-              <a:t>The check lives on the drive: a BitLocker holder who edits the Python could remove it. It is an administrative control with evidence, not copy protection.</a:t>
-            </a:r>
-            <a:endParaRPr lang="en-US" sz="1250" dirty="0"/>
-          </a:p>
-        </p:txBody>
-      </p:sp>
-      <p:sp>
-        <p:nvSpPr>
-          <p:cNvPr id="23" name="Shape 20"/>
-          <p:cNvSpPr/>
-          <p:nvPr/>
-        </p:nvSpPr>
-        <p:spPr>
-          <a:xfrm>
-            <a:off x="0" y="6793992"/>
-            <a:ext cx="2040636" cy="64008"/>
-          </a:xfrm>
-          <a:prstGeom prst="rect">
-            <a:avLst/>
-          </a:prstGeom>
-          <a:solidFill>
-            <a:srgbClr val="01485C"/>
-          </a:solidFill>
-          <a:ln/>
-        </p:spPr>
-      </p:sp>
-      <p:sp>
-        <p:nvSpPr>
-          <p:cNvPr id="24" name="Shape 21"/>
-          <p:cNvSpPr/>
-          <p:nvPr/>
-        </p:nvSpPr>
-        <p:spPr>
-          <a:xfrm>
-            <a:off x="2031492" y="6793992"/>
-            <a:ext cx="2040636" cy="64008"/>
-          </a:xfrm>
-          <a:prstGeom prst="rect">
-            <a:avLst/>
-          </a:prstGeom>
-          <a:solidFill>
-            <a:srgbClr val="146175"/>
-          </a:solidFill>
-          <a:ln/>
-        </p:spPr>
-      </p:sp>
-      <p:sp>
-        <p:nvSpPr>
-          <p:cNvPr id="25" name="Shape 22"/>
-          <p:cNvSpPr/>
-          <p:nvPr/>
-        </p:nvSpPr>
-        <p:spPr>
-          <a:xfrm>
-            <a:off x="4062984" y="6793992"/>
-            <a:ext cx="2040636" cy="64008"/>
-          </a:xfrm>
-          <a:prstGeom prst="rect">
-            <a:avLst/>
-          </a:prstGeom>
-          <a:solidFill>
-            <a:srgbClr val="11B5AE"/>
-          </a:solidFill>
-          <a:ln/>
-        </p:spPr>
-      </p:sp>
-      <p:sp>
-        <p:nvSpPr>
-          <p:cNvPr id="26" name="Shape 23"/>
-          <p:cNvSpPr/>
-          <p:nvPr/>
-        </p:nvSpPr>
-        <p:spPr>
-          <a:xfrm>
-            <a:off x="6094476" y="6793992"/>
-            <a:ext cx="2040636" cy="64008"/>
-          </a:xfrm>
-          <a:prstGeom prst="rect">
-            <a:avLst/>
-          </a:prstGeom>
-          <a:solidFill>
-            <a:srgbClr val="6CCAD4"/>
-          </a:solidFill>
-          <a:ln/>
-        </p:spPr>
-      </p:sp>
-      <p:sp>
-        <p:nvSpPr>
-          <p:cNvPr id="27" name="Shape 24"/>
-          <p:cNvSpPr/>
-          <p:nvPr/>
-        </p:nvSpPr>
-        <p:spPr>
-          <a:xfrm>
-            <a:off x="8125968" y="6793992"/>
-            <a:ext cx="2040636" cy="64008"/>
-          </a:xfrm>
-          <a:prstGeom prst="rect">
-            <a:avLst/>
-          </a:prstGeom>
-          <a:solidFill>
-            <a:srgbClr val="7FC04C"/>
-          </a:solidFill>
-          <a:ln/>
-        </p:spPr>
-      </p:sp>
-      <p:sp>
-        <p:nvSpPr>
-          <p:cNvPr id="28" name="Shape 25"/>
-          <p:cNvSpPr/>
-          <p:nvPr/>
-        </p:nvSpPr>
-        <p:spPr>
-          <a:xfrm>
-            <a:off x="10157460" y="6793992"/>
-            <a:ext cx="2040636" cy="64008"/>
-          </a:xfrm>
-          <a:prstGeom prst="rect">
-            <a:avLst/>
-          </a:prstGeom>
-          <a:solidFill>
-            <a:srgbClr val="E1DD57"/>
-          </a:solidFill>
-          <a:ln/>
-        </p:spPr>
-      </p:sp>
-    </p:spTree>
-  </p:cSld>
-  <p:clrMapOvr>
-    <a:masterClrMapping/>
-  </p:clrMapOvr>
-</p:sld>
-</file>
-
-<file path=ppt/slides/slide9.xml><?xml version="1.0" encoding="utf-8"?>
 <p:sld xmlns:a="http://schemas.openxmlformats.org/drawingml/2006/main" xmlns:r="http://schemas.openxmlformats.org/officeDocument/2006/relationships" xmlns:p="http://schemas.openxmlformats.org/presentationml/2006/main">
   <p:cSld name="Slide 8">
     <p:bg>
@@ -13313,6 +12651,668 @@
       <p:sp>
         <p:nvSpPr>
           <p:cNvPr id="38" name="Shape 30"/>
+          <p:cNvSpPr/>
+          <p:nvPr/>
+        </p:nvSpPr>
+        <p:spPr>
+          <a:xfrm>
+            <a:off x="10157460" y="6793992"/>
+            <a:ext cx="2040636" cy="64008"/>
+          </a:xfrm>
+          <a:prstGeom prst="rect">
+            <a:avLst/>
+          </a:prstGeom>
+          <a:solidFill>
+            <a:srgbClr val="E1DD57"/>
+          </a:solidFill>
+          <a:ln/>
+        </p:spPr>
+      </p:sp>
+    </p:spTree>
+  </p:cSld>
+  <p:clrMapOvr>
+    <a:masterClrMapping/>
+  </p:clrMapOvr>
+</p:sld>
+</file>
+
+<file path=ppt/slides/slide9.xml><?xml version="1.0" encoding="utf-8"?>
+<p:sld xmlns:a="http://schemas.openxmlformats.org/drawingml/2006/main" xmlns:r="http://schemas.openxmlformats.org/officeDocument/2006/relationships" xmlns:p="http://schemas.openxmlformats.org/presentationml/2006/main">
+  <p:cSld name="Slide 9">
+    <p:bg>
+      <p:bgPr>
+        <a:solidFill>
+          <a:srgbClr val="FFFFFF"/>
+        </a:solidFill>
+      </p:bgPr>
+    </p:bg>
+    <p:spTree>
+      <p:nvGrpSpPr>
+        <p:cNvPr id="1" name=""/>
+        <p:cNvGrpSpPr/>
+        <p:nvPr/>
+      </p:nvGrpSpPr>
+      <p:grpSpPr>
+        <a:xfrm>
+          <a:off x="0" y="0"/>
+          <a:ext cx="0" cy="0"/>
+          <a:chOff x="0" y="0"/>
+          <a:chExt cx="0" cy="0"/>
+        </a:xfrm>
+      </p:grpSpPr>
+      <p:sp>
+        <p:nvSpPr>
+          <p:cNvPr id="2" name="Text 0"/>
+          <p:cNvSpPr txBox="1"/>
+          <p:nvPr/>
+        </p:nvSpPr>
+        <p:spPr>
+          <a:xfrm>
+            <a:off x="548640" y="320040"/>
+            <a:ext cx="11064240" cy="685800"/>
+          </a:xfrm>
+          <a:prstGeom prst="rect">
+            <a:avLst/>
+          </a:prstGeom>
+          <a:noFill/>
+          <a:ln/>
+        </p:spPr>
+        <p:txBody>
+          <a:bodyPr wrap="square" lIns="0" tIns="0" rIns="0" bIns="0" rtlCol="0" anchor="ctr"/>
+          <a:lstStyle/>
+          <a:p>
+            <a:pPr algn="l" indent="0" marL="0">
+              <a:buNone/>
+            </a:pPr>
+            <a:r>
+              <a:rPr lang="en-US" sz="3000" b="1" dirty="0">
+                <a:solidFill>
+                  <a:srgbClr val="01485C"/>
+                </a:solidFill>
+                <a:latin typeface="Calibri" pitchFamily="34" charset="0"/>
+                <a:ea typeface="Calibri" pitchFamily="34" charset="-122"/>
+                <a:cs typeface="Calibri" pitchFamily="34" charset="-120"/>
+              </a:rPr>
+              <a:t>Audit &amp; accountability</a:t>
+            </a:r>
+            <a:endParaRPr lang="en-US" sz="3000" dirty="0"/>
+          </a:p>
+        </p:txBody>
+      </p:sp>
+      <p:sp>
+        <p:nvSpPr>
+          <p:cNvPr id="3" name="Shape 1"/>
+          <p:cNvSpPr/>
+          <p:nvPr/>
+        </p:nvSpPr>
+        <p:spPr>
+          <a:xfrm>
+            <a:off x="548640" y="1463040"/>
+            <a:ext cx="3611880" cy="3108960"/>
+          </a:xfrm>
+          <a:prstGeom prst="roundRect">
+            <a:avLst>
+              <a:gd name="adj" fmla="val 3529"/>
+            </a:avLst>
+          </a:prstGeom>
+          <a:solidFill>
+            <a:srgbClr val="E5F2F0"/>
+          </a:solidFill>
+          <a:ln/>
+        </p:spPr>
+      </p:sp>
+      <p:sp>
+        <p:nvSpPr>
+          <p:cNvPr id="4" name="Shape 2"/>
+          <p:cNvSpPr/>
+          <p:nvPr/>
+        </p:nvSpPr>
+        <p:spPr>
+          <a:xfrm>
+            <a:off x="822960" y="1755648"/>
+            <a:ext cx="658368" cy="658368"/>
+          </a:xfrm>
+          <a:prstGeom prst="ellipse">
+            <a:avLst/>
+          </a:prstGeom>
+          <a:solidFill>
+            <a:srgbClr val="01485C"/>
+          </a:solidFill>
+          <a:ln/>
+        </p:spPr>
+      </p:sp>
+      <p:pic>
+        <p:nvPicPr>
+          <p:cNvPr id="5" name="Image 0" descr="icon_clipboard_w.png">    </p:cNvPr>
+          <p:cNvPicPr>
+            <a:picLocks noChangeAspect="1"/>
+          </p:cNvPicPr>
+          <p:nvPr/>
+        </p:nvPicPr>
+        <p:blipFill>
+          <a:blip r:embed="rId1"/>
+          <a:stretch>
+            <a:fillRect/>
+          </a:stretch>
+        </p:blipFill>
+        <p:spPr>
+          <a:xfrm>
+            <a:off x="994136" y="1926824"/>
+            <a:ext cx="316017" cy="316017"/>
+          </a:xfrm>
+          <a:prstGeom prst="rect">
+            <a:avLst/>
+          </a:prstGeom>
+        </p:spPr>
+      </p:pic>
+      <p:sp>
+        <p:nvSpPr>
+          <p:cNvPr id="6" name="Text 3"/>
+          <p:cNvSpPr txBox="1"/>
+          <p:nvPr/>
+        </p:nvSpPr>
+        <p:spPr>
+          <a:xfrm>
+            <a:off x="822960" y="2606040"/>
+            <a:ext cx="3063240" cy="457200"/>
+          </a:xfrm>
+          <a:prstGeom prst="rect">
+            <a:avLst/>
+          </a:prstGeom>
+          <a:noFill/>
+          <a:ln/>
+        </p:spPr>
+        <p:txBody>
+          <a:bodyPr wrap="square" lIns="0" tIns="0" rIns="0" bIns="0" rtlCol="0" anchor="ctr"/>
+          <a:lstStyle/>
+          <a:p>
+            <a:pPr indent="0" marL="0">
+              <a:buNone/>
+            </a:pPr>
+            <a:r>
+              <a:rPr lang="en-US" sz="1600" b="1" dirty="0">
+                <a:solidFill>
+                  <a:srgbClr val="01485C"/>
+                </a:solidFill>
+                <a:latin typeface="Calibri" pitchFamily="34" charset="0"/>
+                <a:ea typeface="Calibri" pitchFamily="34" charset="-122"/>
+                <a:cs typeface="Calibri" pitchFamily="34" charset="-120"/>
+              </a:rPr>
+              <a:t>audit.log</a:t>
+            </a:r>
+            <a:endParaRPr lang="en-US" sz="1600" dirty="0"/>
+          </a:p>
+        </p:txBody>
+      </p:sp>
+      <p:sp>
+        <p:nvSpPr>
+          <p:cNvPr id="7" name="Text 4"/>
+          <p:cNvSpPr txBox="1"/>
+          <p:nvPr/>
+        </p:nvSpPr>
+        <p:spPr>
+          <a:xfrm>
+            <a:off x="822960" y="3108960"/>
+            <a:ext cx="3063240" cy="1371600"/>
+          </a:xfrm>
+          <a:prstGeom prst="rect">
+            <a:avLst/>
+          </a:prstGeom>
+          <a:noFill/>
+          <a:ln/>
+        </p:spPr>
+        <p:txBody>
+          <a:bodyPr wrap="square" lIns="0" tIns="0" rIns="0" bIns="0" rtlCol="0" anchor="ctr"/>
+          <a:lstStyle/>
+          <a:p>
+            <a:pPr indent="0" marL="0">
+              <a:buNone/>
+            </a:pPr>
+            <a:r>
+              <a:rPr lang="en-US" sz="1250" dirty="0">
+                <a:solidFill>
+                  <a:srgbClr val="17272E"/>
+                </a:solidFill>
+                <a:latin typeface="Calibri" pitchFamily="34" charset="0"/>
+                <a:ea typeface="Calibri" pitchFamily="34" charset="-122"/>
+                <a:cs typeface="Calibri" pitchFamily="34" charset="-120"/>
+              </a:rPr>
+              <a:t>Every report generation: timestamp, Windows username, period, scope — plus every history unlock attempt, including failures</a:t>
+            </a:r>
+            <a:endParaRPr lang="en-US" sz="1250" dirty="0"/>
+          </a:p>
+        </p:txBody>
+      </p:sp>
+      <p:sp>
+        <p:nvSpPr>
+          <p:cNvPr id="8" name="Shape 5"/>
+          <p:cNvSpPr/>
+          <p:nvPr/>
+        </p:nvSpPr>
+        <p:spPr>
+          <a:xfrm>
+            <a:off x="4370832" y="1463040"/>
+            <a:ext cx="3611880" cy="3108960"/>
+          </a:xfrm>
+          <a:prstGeom prst="roundRect">
+            <a:avLst>
+              <a:gd name="adj" fmla="val 3529"/>
+            </a:avLst>
+          </a:prstGeom>
+          <a:solidFill>
+            <a:srgbClr val="E5F2F0"/>
+          </a:solidFill>
+          <a:ln/>
+        </p:spPr>
+      </p:sp>
+      <p:sp>
+        <p:nvSpPr>
+          <p:cNvPr id="9" name="Shape 6"/>
+          <p:cNvSpPr/>
+          <p:nvPr/>
+        </p:nvSpPr>
+        <p:spPr>
+          <a:xfrm>
+            <a:off x="4645152" y="1755648"/>
+            <a:ext cx="658368" cy="658368"/>
+          </a:xfrm>
+          <a:prstGeom prst="ellipse">
+            <a:avLst/>
+          </a:prstGeom>
+          <a:solidFill>
+            <a:srgbClr val="01485C"/>
+          </a:solidFill>
+          <a:ln/>
+        </p:spPr>
+      </p:sp>
+      <p:pic>
+        <p:nvPicPr>
+          <p:cNvPr id="10" name="Image 1" descr="icon_clipboard_w.png">    </p:cNvPr>
+          <p:cNvPicPr>
+            <a:picLocks noChangeAspect="1"/>
+          </p:cNvPicPr>
+          <p:nvPr/>
+        </p:nvPicPr>
+        <p:blipFill>
+          <a:blip r:embed="rId2"/>
+          <a:stretch>
+            <a:fillRect/>
+          </a:stretch>
+        </p:blipFill>
+        <p:spPr>
+          <a:xfrm>
+            <a:off x="4816328" y="1926824"/>
+            <a:ext cx="316017" cy="316017"/>
+          </a:xfrm>
+          <a:prstGeom prst="rect">
+            <a:avLst/>
+          </a:prstGeom>
+        </p:spPr>
+      </p:pic>
+      <p:sp>
+        <p:nvSpPr>
+          <p:cNvPr id="11" name="Text 7"/>
+          <p:cNvSpPr txBox="1"/>
+          <p:nvPr/>
+        </p:nvSpPr>
+        <p:spPr>
+          <a:xfrm>
+            <a:off x="4645152" y="2606040"/>
+            <a:ext cx="3063240" cy="457200"/>
+          </a:xfrm>
+          <a:prstGeom prst="rect">
+            <a:avLst/>
+          </a:prstGeom>
+          <a:noFill/>
+          <a:ln/>
+        </p:spPr>
+        <p:txBody>
+          <a:bodyPr wrap="square" lIns="0" tIns="0" rIns="0" bIns="0" rtlCol="0" anchor="ctr"/>
+          <a:lstStyle/>
+          <a:p>
+            <a:pPr indent="0" marL="0">
+              <a:buNone/>
+            </a:pPr>
+            <a:r>
+              <a:rPr lang="en-US" sz="1600" b="1" dirty="0">
+                <a:solidFill>
+                  <a:srgbClr val="01485C"/>
+                </a:solidFill>
+                <a:latin typeface="Calibri" pitchFamily="34" charset="0"/>
+                <a:ea typeface="Calibri" pitchFamily="34" charset="-122"/>
+                <a:cs typeface="Calibri" pitchFamily="34" charset="-120"/>
+              </a:rPr>
+              <a:t>Network audit logs</a:t>
+            </a:r>
+            <a:endParaRPr lang="en-US" sz="1600" dirty="0"/>
+          </a:p>
+        </p:txBody>
+      </p:sp>
+      <p:sp>
+        <p:nvSpPr>
+          <p:cNvPr id="12" name="Text 8"/>
+          <p:cNvSpPr txBox="1"/>
+          <p:nvPr/>
+        </p:nvSpPr>
+        <p:spPr>
+          <a:xfrm>
+            <a:off x="4645152" y="3108960"/>
+            <a:ext cx="3063240" cy="1371600"/>
+          </a:xfrm>
+          <a:prstGeom prst="rect">
+            <a:avLst/>
+          </a:prstGeom>
+          <a:noFill/>
+          <a:ln/>
+        </p:spPr>
+        <p:txBody>
+          <a:bodyPr wrap="square" lIns="0" tIns="0" rIns="0" bIns="0" rtlCol="0" anchor="ctr"/>
+          <a:lstStyle/>
+          <a:p>
+            <a:pPr indent="0" marL="0">
+              <a:buNone/>
+            </a:pPr>
+            <a:r>
+              <a:rPr lang="en-US" sz="1250" dirty="0">
+                <a:solidFill>
+                  <a:srgbClr val="17272E"/>
+                </a:solidFill>
+                <a:latin typeface="Calibri" pitchFamily="34" charset="0"/>
+                <a:ea typeface="Calibri" pitchFamily="34" charset="-122"/>
+                <a:cs typeface="Calibri" pitchFamily="34" charset="-120"/>
+              </a:rPr>
+              <a:t>The guard’s record: activation lines under normal use; any outbound attempt would appear as BLOCKED with the destination</a:t>
+            </a:r>
+            <a:endParaRPr lang="en-US" sz="1250" dirty="0"/>
+          </a:p>
+        </p:txBody>
+      </p:sp>
+      <p:sp>
+        <p:nvSpPr>
+          <p:cNvPr id="13" name="Shape 9"/>
+          <p:cNvSpPr/>
+          <p:nvPr/>
+        </p:nvSpPr>
+        <p:spPr>
+          <a:xfrm>
+            <a:off x="8193024" y="1463040"/>
+            <a:ext cx="3611880" cy="3108960"/>
+          </a:xfrm>
+          <a:prstGeom prst="roundRect">
+            <a:avLst>
+              <a:gd name="adj" fmla="val 3529"/>
+            </a:avLst>
+          </a:prstGeom>
+          <a:solidFill>
+            <a:srgbClr val="E5F2F0"/>
+          </a:solidFill>
+          <a:ln/>
+        </p:spPr>
+      </p:sp>
+      <p:sp>
+        <p:nvSpPr>
+          <p:cNvPr id="14" name="Shape 10"/>
+          <p:cNvSpPr/>
+          <p:nvPr/>
+        </p:nvSpPr>
+        <p:spPr>
+          <a:xfrm>
+            <a:off x="8467344" y="1755648"/>
+            <a:ext cx="658368" cy="658368"/>
+          </a:xfrm>
+          <a:prstGeom prst="ellipse">
+            <a:avLst/>
+          </a:prstGeom>
+          <a:solidFill>
+            <a:srgbClr val="01485C"/>
+          </a:solidFill>
+          <a:ln/>
+        </p:spPr>
+      </p:sp>
+      <p:pic>
+        <p:nvPicPr>
+          <p:cNvPr id="15" name="Image 2" descr="icon_clipboard_w.png">    </p:cNvPr>
+          <p:cNvPicPr>
+            <a:picLocks noChangeAspect="1"/>
+          </p:cNvPicPr>
+          <p:nvPr/>
+        </p:nvPicPr>
+        <p:blipFill>
+          <a:blip r:embed="rId3"/>
+          <a:stretch>
+            <a:fillRect/>
+          </a:stretch>
+        </p:blipFill>
+        <p:spPr>
+          <a:xfrm>
+            <a:off x="8638520" y="1926824"/>
+            <a:ext cx="316017" cy="316017"/>
+          </a:xfrm>
+          <a:prstGeom prst="rect">
+            <a:avLst/>
+          </a:prstGeom>
+        </p:spPr>
+      </p:pic>
+      <p:sp>
+        <p:nvSpPr>
+          <p:cNvPr id="16" name="Text 11"/>
+          <p:cNvSpPr txBox="1"/>
+          <p:nvPr/>
+        </p:nvSpPr>
+        <p:spPr>
+          <a:xfrm>
+            <a:off x="8467344" y="2606040"/>
+            <a:ext cx="3063240" cy="457200"/>
+          </a:xfrm>
+          <a:prstGeom prst="rect">
+            <a:avLst/>
+          </a:prstGeom>
+          <a:noFill/>
+          <a:ln/>
+        </p:spPr>
+        <p:txBody>
+          <a:bodyPr wrap="square" lIns="0" tIns="0" rIns="0" bIns="0" rtlCol="0" anchor="ctr"/>
+          <a:lstStyle/>
+          <a:p>
+            <a:pPr indent="0" marL="0">
+              <a:buNone/>
+            </a:pPr>
+            <a:r>
+              <a:rPr lang="en-US" sz="1600" b="1" dirty="0">
+                <a:solidFill>
+                  <a:srgbClr val="01485C"/>
+                </a:solidFill>
+                <a:latin typeface="Calibri" pitchFamily="34" charset="0"/>
+                <a:ea typeface="Calibri" pitchFamily="34" charset="-122"/>
+                <a:cs typeface="Calibri" pitchFamily="34" charset="-120"/>
+              </a:rPr>
+              <a:t>Human-readable, on-device</a:t>
+            </a:r>
+            <a:endParaRPr lang="en-US" sz="1600" dirty="0"/>
+          </a:p>
+        </p:txBody>
+      </p:sp>
+      <p:sp>
+        <p:nvSpPr>
+          <p:cNvPr id="17" name="Text 12"/>
+          <p:cNvSpPr txBox="1"/>
+          <p:nvPr/>
+        </p:nvSpPr>
+        <p:spPr>
+          <a:xfrm>
+            <a:off x="8467344" y="3108960"/>
+            <a:ext cx="3063240" cy="1371600"/>
+          </a:xfrm>
+          <a:prstGeom prst="rect">
+            <a:avLst/>
+          </a:prstGeom>
+          <a:noFill/>
+          <a:ln/>
+        </p:spPr>
+        <p:txBody>
+          <a:bodyPr wrap="square" lIns="0" tIns="0" rIns="0" bIns="0" rtlCol="0" anchor="ctr"/>
+          <a:lstStyle/>
+          <a:p>
+            <a:pPr indent="0" marL="0">
+              <a:buNone/>
+            </a:pPr>
+            <a:r>
+              <a:rPr lang="en-US" sz="1250" dirty="0">
+                <a:solidFill>
+                  <a:srgbClr val="17272E"/>
+                </a:solidFill>
+                <a:latin typeface="Calibri" pitchFamily="34" charset="0"/>
+                <a:ea typeface="Calibri" pitchFamily="34" charset="-122"/>
+                <a:cs typeface="Calibri" pitchFamily="34" charset="-120"/>
+              </a:rPr>
+              <a:t>Plain text on the drive — reviewable by any auditor without tooling, tied to OS usernames</a:t>
+            </a:r>
+            <a:endParaRPr lang="en-US" sz="1250" dirty="0"/>
+          </a:p>
+        </p:txBody>
+      </p:sp>
+      <p:sp>
+        <p:nvSpPr>
+          <p:cNvPr id="18" name="Text 13"/>
+          <p:cNvSpPr txBox="1"/>
+          <p:nvPr/>
+        </p:nvSpPr>
+        <p:spPr>
+          <a:xfrm>
+            <a:off x="548640" y="5029200"/>
+            <a:ext cx="11064240" cy="457200"/>
+          </a:xfrm>
+          <a:prstGeom prst="rect">
+            <a:avLst/>
+          </a:prstGeom>
+          <a:noFill/>
+          <a:ln/>
+        </p:spPr>
+        <p:txBody>
+          <a:bodyPr wrap="square" lIns="0" tIns="0" rIns="0" bIns="0" rtlCol="0" anchor="ctr"/>
+          <a:lstStyle/>
+          <a:p>
+            <a:pPr indent="0" marL="0">
+              <a:buNone/>
+            </a:pPr>
+            <a:r>
+              <a:rPr lang="en-US" sz="1400" i="1" dirty="0">
+                <a:solidFill>
+                  <a:srgbClr val="5F7178"/>
+                </a:solidFill>
+                <a:latin typeface="Calibri" pitchFamily="34" charset="0"/>
+                <a:ea typeface="Calibri" pitchFamily="34" charset="-122"/>
+                <a:cs typeface="Calibri" pitchFamily="34" charset="-120"/>
+              </a:rPr>
+              <a:t>Failed password attempts are recorded — repeated failures on a found drive leave evidence.</a:t>
+            </a:r>
+            <a:endParaRPr lang="en-US" sz="1400" dirty="0"/>
+          </a:p>
+        </p:txBody>
+      </p:sp>
+      <p:sp>
+        <p:nvSpPr>
+          <p:cNvPr id="19" name="Shape 14"/>
+          <p:cNvSpPr/>
+          <p:nvPr/>
+        </p:nvSpPr>
+        <p:spPr>
+          <a:xfrm>
+            <a:off x="0" y="6793992"/>
+            <a:ext cx="2040636" cy="64008"/>
+          </a:xfrm>
+          <a:prstGeom prst="rect">
+            <a:avLst/>
+          </a:prstGeom>
+          <a:solidFill>
+            <a:srgbClr val="01485C"/>
+          </a:solidFill>
+          <a:ln/>
+        </p:spPr>
+      </p:sp>
+      <p:sp>
+        <p:nvSpPr>
+          <p:cNvPr id="20" name="Shape 15"/>
+          <p:cNvSpPr/>
+          <p:nvPr/>
+        </p:nvSpPr>
+        <p:spPr>
+          <a:xfrm>
+            <a:off x="2031492" y="6793992"/>
+            <a:ext cx="2040636" cy="64008"/>
+          </a:xfrm>
+          <a:prstGeom prst="rect">
+            <a:avLst/>
+          </a:prstGeom>
+          <a:solidFill>
+            <a:srgbClr val="146175"/>
+          </a:solidFill>
+          <a:ln/>
+        </p:spPr>
+      </p:sp>
+      <p:sp>
+        <p:nvSpPr>
+          <p:cNvPr id="21" name="Shape 16"/>
+          <p:cNvSpPr/>
+          <p:nvPr/>
+        </p:nvSpPr>
+        <p:spPr>
+          <a:xfrm>
+            <a:off x="4062984" y="6793992"/>
+            <a:ext cx="2040636" cy="64008"/>
+          </a:xfrm>
+          <a:prstGeom prst="rect">
+            <a:avLst/>
+          </a:prstGeom>
+          <a:solidFill>
+            <a:srgbClr val="11B5AE"/>
+          </a:solidFill>
+          <a:ln/>
+        </p:spPr>
+      </p:sp>
+      <p:sp>
+        <p:nvSpPr>
+          <p:cNvPr id="22" name="Shape 17"/>
+          <p:cNvSpPr/>
+          <p:nvPr/>
+        </p:nvSpPr>
+        <p:spPr>
+          <a:xfrm>
+            <a:off x="6094476" y="6793992"/>
+            <a:ext cx="2040636" cy="64008"/>
+          </a:xfrm>
+          <a:prstGeom prst="rect">
+            <a:avLst/>
+          </a:prstGeom>
+          <a:solidFill>
+            <a:srgbClr val="6CCAD4"/>
+          </a:solidFill>
+          <a:ln/>
+        </p:spPr>
+      </p:sp>
+      <p:sp>
+        <p:nvSpPr>
+          <p:cNvPr id="23" name="Shape 18"/>
+          <p:cNvSpPr/>
+          <p:nvPr/>
+        </p:nvSpPr>
+        <p:spPr>
+          <a:xfrm>
+            <a:off x="8125968" y="6793992"/>
+            <a:ext cx="2040636" cy="64008"/>
+          </a:xfrm>
+          <a:prstGeom prst="rect">
+            <a:avLst/>
+          </a:prstGeom>
+          <a:solidFill>
+            <a:srgbClr val="7FC04C"/>
+          </a:solidFill>
+          <a:ln/>
+        </p:spPr>
+      </p:sp>
+      <p:sp>
+        <p:nvSpPr>
+          <p:cNvPr id="24" name="Shape 19"/>
           <p:cNvSpPr/>
           <p:nvPr/>
         </p:nvSpPr>

</xml_diff>

<commit_message>
Credit line and About card: conceived, designed and built by Craig MacKenzie
Portal footer, About this tool card (scope, security posture, version and
licence), both engine pages, both deck title slides and the READMEs.

Co-Authored-By: Claude Fable 5.1 <noreply@anthropic.com>
</commit_message>
<xml_diff>
--- a/PQ_Report_Generator_Security_Briefing.pptx
+++ b/PQ_Report_Generator_Security_Briefing.pptx
@@ -1787,6 +1787,10 @@
           </a:solidFill>
           <a:ln/>
         </p:spPr>
+        <p:txBody>
+          <a:bodyPr/>
+          <a:p/>
+        </p:txBody>
       </p:sp>
       <p:sp>
         <p:nvSpPr>
@@ -1809,6 +1813,10 @@
           </a:solidFill>
           <a:ln/>
         </p:spPr>
+        <p:txBody>
+          <a:bodyPr/>
+          <a:p/>
+        </p:txBody>
       </p:sp>
       <p:pic>
         <p:nvPicPr>
@@ -1879,6 +1887,10 @@
           </a:solidFill>
           <a:ln/>
         </p:spPr>
+        <p:txBody>
+          <a:bodyPr/>
+          <a:p/>
+        </p:txBody>
       </p:sp>
       <p:pic>
         <p:nvPicPr>
@@ -2093,7 +2105,7 @@
                 <a:ea typeface="Calibri" pitchFamily="34" charset="-122"/>
                 <a:cs typeface="Calibri" pitchFamily="34" charset="-120"/>
               </a:rPr>
-              <a:t>Designed by Craig MacKenzie · Chemistry Department · Townsville Group Laboratory</a:t>
+              <a:t>Conceived, designed and built by Craig MacKenzie · Chemistry Department, Townsville Group Laboratory · Pathology Queensland</a:t>
             </a:r>
             <a:endParaRPr lang="en-US" sz="1100" dirty="0"/>
           </a:p>
@@ -2118,6 +2130,10 @@
           </a:solidFill>
           <a:ln/>
         </p:spPr>
+        <p:txBody>
+          <a:bodyPr/>
+          <a:p/>
+        </p:txBody>
       </p:sp>
       <p:sp>
         <p:nvSpPr>
@@ -2138,6 +2154,10 @@
           </a:solidFill>
           <a:ln/>
         </p:spPr>
+        <p:txBody>
+          <a:bodyPr/>
+          <a:p/>
+        </p:txBody>
       </p:sp>
       <p:sp>
         <p:nvSpPr>
@@ -2158,6 +2178,10 @@
           </a:solidFill>
           <a:ln/>
         </p:spPr>
+        <p:txBody>
+          <a:bodyPr/>
+          <a:p/>
+        </p:txBody>
       </p:sp>
       <p:sp>
         <p:nvSpPr>
@@ -2178,6 +2202,10 @@
           </a:solidFill>
           <a:ln/>
         </p:spPr>
+        <p:txBody>
+          <a:bodyPr/>
+          <a:p/>
+        </p:txBody>
       </p:sp>
       <p:sp>
         <p:nvSpPr>
@@ -2198,6 +2226,10 @@
           </a:solidFill>
           <a:ln/>
         </p:spPr>
+        <p:txBody>
+          <a:bodyPr/>
+          <a:p/>
+        </p:txBody>
       </p:sp>
       <p:sp>
         <p:nvSpPr>
@@ -2218,6 +2250,10 @@
           </a:solidFill>
           <a:ln/>
         </p:spPr>
+        <p:txBody>
+          <a:bodyPr/>
+          <a:p/>
+        </p:txBody>
       </p:sp>
     </p:spTree>
   </p:cSld>
@@ -2228,6 +2264,668 @@
 </file>
 
 <file path=ppt/slides/slide10.xml><?xml version="1.0" encoding="utf-8"?>
+<p:sld xmlns:a="http://schemas.openxmlformats.org/drawingml/2006/main" xmlns:r="http://schemas.openxmlformats.org/officeDocument/2006/relationships" xmlns:p="http://schemas.openxmlformats.org/presentationml/2006/main">
+  <p:cSld name="Slide 9">
+    <p:bg>
+      <p:bgPr>
+        <a:solidFill>
+          <a:srgbClr val="FFFFFF"/>
+        </a:solidFill>
+      </p:bgPr>
+    </p:bg>
+    <p:spTree>
+      <p:nvGrpSpPr>
+        <p:cNvPr id="1" name=""/>
+        <p:cNvGrpSpPr/>
+        <p:nvPr/>
+      </p:nvGrpSpPr>
+      <p:grpSpPr>
+        <a:xfrm>
+          <a:off x="0" y="0"/>
+          <a:ext cx="0" cy="0"/>
+          <a:chOff x="0" y="0"/>
+          <a:chExt cx="0" cy="0"/>
+        </a:xfrm>
+      </p:grpSpPr>
+      <p:sp>
+        <p:nvSpPr>
+          <p:cNvPr id="2" name="Text 0"/>
+          <p:cNvSpPr txBox="1"/>
+          <p:nvPr/>
+        </p:nvSpPr>
+        <p:spPr>
+          <a:xfrm>
+            <a:off x="548640" y="320040"/>
+            <a:ext cx="11064240" cy="685800"/>
+          </a:xfrm>
+          <a:prstGeom prst="rect">
+            <a:avLst/>
+          </a:prstGeom>
+          <a:noFill/>
+          <a:ln/>
+        </p:spPr>
+        <p:txBody>
+          <a:bodyPr wrap="square" lIns="0" tIns="0" rIns="0" bIns="0" rtlCol="0" anchor="ctr"/>
+          <a:lstStyle/>
+          <a:p>
+            <a:pPr algn="l" indent="0" marL="0">
+              <a:buNone/>
+            </a:pPr>
+            <a:r>
+              <a:rPr lang="en-US" sz="3000" b="1" dirty="0">
+                <a:solidFill>
+                  <a:srgbClr val="01485C"/>
+                </a:solidFill>
+                <a:latin typeface="Calibri" pitchFamily="34" charset="0"/>
+                <a:ea typeface="Calibri" pitchFamily="34" charset="-122"/>
+                <a:cs typeface="Calibri" pitchFamily="34" charset="-120"/>
+              </a:rPr>
+              <a:t>Audit &amp; accountability</a:t>
+            </a:r>
+            <a:endParaRPr lang="en-US" sz="3000" dirty="0"/>
+          </a:p>
+        </p:txBody>
+      </p:sp>
+      <p:sp>
+        <p:nvSpPr>
+          <p:cNvPr id="3" name="Shape 1"/>
+          <p:cNvSpPr/>
+          <p:nvPr/>
+        </p:nvSpPr>
+        <p:spPr>
+          <a:xfrm>
+            <a:off x="548640" y="1463040"/>
+            <a:ext cx="3611880" cy="3108960"/>
+          </a:xfrm>
+          <a:prstGeom prst="roundRect">
+            <a:avLst>
+              <a:gd name="adj" fmla="val 3529"/>
+            </a:avLst>
+          </a:prstGeom>
+          <a:solidFill>
+            <a:srgbClr val="E5F2F0"/>
+          </a:solidFill>
+          <a:ln/>
+        </p:spPr>
+      </p:sp>
+      <p:sp>
+        <p:nvSpPr>
+          <p:cNvPr id="4" name="Shape 2"/>
+          <p:cNvSpPr/>
+          <p:nvPr/>
+        </p:nvSpPr>
+        <p:spPr>
+          <a:xfrm>
+            <a:off x="822960" y="1755648"/>
+            <a:ext cx="658368" cy="658368"/>
+          </a:xfrm>
+          <a:prstGeom prst="ellipse">
+            <a:avLst/>
+          </a:prstGeom>
+          <a:solidFill>
+            <a:srgbClr val="01485C"/>
+          </a:solidFill>
+          <a:ln/>
+        </p:spPr>
+      </p:sp>
+      <p:pic>
+        <p:nvPicPr>
+          <p:cNvPr id="5" name="Image 0" descr="icon_clipboard_w.png">    </p:cNvPr>
+          <p:cNvPicPr>
+            <a:picLocks noChangeAspect="1"/>
+          </p:cNvPicPr>
+          <p:nvPr/>
+        </p:nvPicPr>
+        <p:blipFill>
+          <a:blip r:embed="rId1"/>
+          <a:stretch>
+            <a:fillRect/>
+          </a:stretch>
+        </p:blipFill>
+        <p:spPr>
+          <a:xfrm>
+            <a:off x="994136" y="1926824"/>
+            <a:ext cx="316017" cy="316017"/>
+          </a:xfrm>
+          <a:prstGeom prst="rect">
+            <a:avLst/>
+          </a:prstGeom>
+        </p:spPr>
+      </p:pic>
+      <p:sp>
+        <p:nvSpPr>
+          <p:cNvPr id="6" name="Text 3"/>
+          <p:cNvSpPr txBox="1"/>
+          <p:nvPr/>
+        </p:nvSpPr>
+        <p:spPr>
+          <a:xfrm>
+            <a:off x="822960" y="2606040"/>
+            <a:ext cx="3063240" cy="457200"/>
+          </a:xfrm>
+          <a:prstGeom prst="rect">
+            <a:avLst/>
+          </a:prstGeom>
+          <a:noFill/>
+          <a:ln/>
+        </p:spPr>
+        <p:txBody>
+          <a:bodyPr wrap="square" lIns="0" tIns="0" rIns="0" bIns="0" rtlCol="0" anchor="ctr"/>
+          <a:lstStyle/>
+          <a:p>
+            <a:pPr indent="0" marL="0">
+              <a:buNone/>
+            </a:pPr>
+            <a:r>
+              <a:rPr lang="en-US" sz="1600" b="1" dirty="0">
+                <a:solidFill>
+                  <a:srgbClr val="01485C"/>
+                </a:solidFill>
+                <a:latin typeface="Calibri" pitchFamily="34" charset="0"/>
+                <a:ea typeface="Calibri" pitchFamily="34" charset="-122"/>
+                <a:cs typeface="Calibri" pitchFamily="34" charset="-120"/>
+              </a:rPr>
+              <a:t>audit.log</a:t>
+            </a:r>
+            <a:endParaRPr lang="en-US" sz="1600" dirty="0"/>
+          </a:p>
+        </p:txBody>
+      </p:sp>
+      <p:sp>
+        <p:nvSpPr>
+          <p:cNvPr id="7" name="Text 4"/>
+          <p:cNvSpPr txBox="1"/>
+          <p:nvPr/>
+        </p:nvSpPr>
+        <p:spPr>
+          <a:xfrm>
+            <a:off x="822960" y="3108960"/>
+            <a:ext cx="3063240" cy="1371600"/>
+          </a:xfrm>
+          <a:prstGeom prst="rect">
+            <a:avLst/>
+          </a:prstGeom>
+          <a:noFill/>
+          <a:ln/>
+        </p:spPr>
+        <p:txBody>
+          <a:bodyPr wrap="square" lIns="0" tIns="0" rIns="0" bIns="0" rtlCol="0" anchor="ctr"/>
+          <a:lstStyle/>
+          <a:p>
+            <a:pPr indent="0" marL="0">
+              <a:buNone/>
+            </a:pPr>
+            <a:r>
+              <a:rPr lang="en-US" sz="1250" dirty="0">
+                <a:solidFill>
+                  <a:srgbClr val="17272E"/>
+                </a:solidFill>
+                <a:latin typeface="Calibri" pitchFamily="34" charset="0"/>
+                <a:ea typeface="Calibri" pitchFamily="34" charset="-122"/>
+                <a:cs typeface="Calibri" pitchFamily="34" charset="-120"/>
+              </a:rPr>
+              <a:t>Every report generation: timestamp, Windows username, period, scope — plus every history unlock attempt, including failures</a:t>
+            </a:r>
+            <a:endParaRPr lang="en-US" sz="1250" dirty="0"/>
+          </a:p>
+        </p:txBody>
+      </p:sp>
+      <p:sp>
+        <p:nvSpPr>
+          <p:cNvPr id="8" name="Shape 5"/>
+          <p:cNvSpPr/>
+          <p:nvPr/>
+        </p:nvSpPr>
+        <p:spPr>
+          <a:xfrm>
+            <a:off x="4370832" y="1463040"/>
+            <a:ext cx="3611880" cy="3108960"/>
+          </a:xfrm>
+          <a:prstGeom prst="roundRect">
+            <a:avLst>
+              <a:gd name="adj" fmla="val 3529"/>
+            </a:avLst>
+          </a:prstGeom>
+          <a:solidFill>
+            <a:srgbClr val="E5F2F0"/>
+          </a:solidFill>
+          <a:ln/>
+        </p:spPr>
+      </p:sp>
+      <p:sp>
+        <p:nvSpPr>
+          <p:cNvPr id="9" name="Shape 6"/>
+          <p:cNvSpPr/>
+          <p:nvPr/>
+        </p:nvSpPr>
+        <p:spPr>
+          <a:xfrm>
+            <a:off x="4645152" y="1755648"/>
+            <a:ext cx="658368" cy="658368"/>
+          </a:xfrm>
+          <a:prstGeom prst="ellipse">
+            <a:avLst/>
+          </a:prstGeom>
+          <a:solidFill>
+            <a:srgbClr val="01485C"/>
+          </a:solidFill>
+          <a:ln/>
+        </p:spPr>
+      </p:sp>
+      <p:pic>
+        <p:nvPicPr>
+          <p:cNvPr id="10" name="Image 1" descr="icon_clipboard_w.png">    </p:cNvPr>
+          <p:cNvPicPr>
+            <a:picLocks noChangeAspect="1"/>
+          </p:cNvPicPr>
+          <p:nvPr/>
+        </p:nvPicPr>
+        <p:blipFill>
+          <a:blip r:embed="rId2"/>
+          <a:stretch>
+            <a:fillRect/>
+          </a:stretch>
+        </p:blipFill>
+        <p:spPr>
+          <a:xfrm>
+            <a:off x="4816328" y="1926824"/>
+            <a:ext cx="316017" cy="316017"/>
+          </a:xfrm>
+          <a:prstGeom prst="rect">
+            <a:avLst/>
+          </a:prstGeom>
+        </p:spPr>
+      </p:pic>
+      <p:sp>
+        <p:nvSpPr>
+          <p:cNvPr id="11" name="Text 7"/>
+          <p:cNvSpPr txBox="1"/>
+          <p:nvPr/>
+        </p:nvSpPr>
+        <p:spPr>
+          <a:xfrm>
+            <a:off x="4645152" y="2606040"/>
+            <a:ext cx="3063240" cy="457200"/>
+          </a:xfrm>
+          <a:prstGeom prst="rect">
+            <a:avLst/>
+          </a:prstGeom>
+          <a:noFill/>
+          <a:ln/>
+        </p:spPr>
+        <p:txBody>
+          <a:bodyPr wrap="square" lIns="0" tIns="0" rIns="0" bIns="0" rtlCol="0" anchor="ctr"/>
+          <a:lstStyle/>
+          <a:p>
+            <a:pPr indent="0" marL="0">
+              <a:buNone/>
+            </a:pPr>
+            <a:r>
+              <a:rPr lang="en-US" sz="1600" b="1" dirty="0">
+                <a:solidFill>
+                  <a:srgbClr val="01485C"/>
+                </a:solidFill>
+                <a:latin typeface="Calibri" pitchFamily="34" charset="0"/>
+                <a:ea typeface="Calibri" pitchFamily="34" charset="-122"/>
+                <a:cs typeface="Calibri" pitchFamily="34" charset="-120"/>
+              </a:rPr>
+              <a:t>Network audit logs</a:t>
+            </a:r>
+            <a:endParaRPr lang="en-US" sz="1600" dirty="0"/>
+          </a:p>
+        </p:txBody>
+      </p:sp>
+      <p:sp>
+        <p:nvSpPr>
+          <p:cNvPr id="12" name="Text 8"/>
+          <p:cNvSpPr txBox="1"/>
+          <p:nvPr/>
+        </p:nvSpPr>
+        <p:spPr>
+          <a:xfrm>
+            <a:off x="4645152" y="3108960"/>
+            <a:ext cx="3063240" cy="1371600"/>
+          </a:xfrm>
+          <a:prstGeom prst="rect">
+            <a:avLst/>
+          </a:prstGeom>
+          <a:noFill/>
+          <a:ln/>
+        </p:spPr>
+        <p:txBody>
+          <a:bodyPr wrap="square" lIns="0" tIns="0" rIns="0" bIns="0" rtlCol="0" anchor="ctr"/>
+          <a:lstStyle/>
+          <a:p>
+            <a:pPr indent="0" marL="0">
+              <a:buNone/>
+            </a:pPr>
+            <a:r>
+              <a:rPr lang="en-US" sz="1250" dirty="0">
+                <a:solidFill>
+                  <a:srgbClr val="17272E"/>
+                </a:solidFill>
+                <a:latin typeface="Calibri" pitchFamily="34" charset="0"/>
+                <a:ea typeface="Calibri" pitchFamily="34" charset="-122"/>
+                <a:cs typeface="Calibri" pitchFamily="34" charset="-120"/>
+              </a:rPr>
+              <a:t>The guard’s record: activation lines under normal use; any outbound attempt would appear as BLOCKED with the destination</a:t>
+            </a:r>
+            <a:endParaRPr lang="en-US" sz="1250" dirty="0"/>
+          </a:p>
+        </p:txBody>
+      </p:sp>
+      <p:sp>
+        <p:nvSpPr>
+          <p:cNvPr id="13" name="Shape 9"/>
+          <p:cNvSpPr/>
+          <p:nvPr/>
+        </p:nvSpPr>
+        <p:spPr>
+          <a:xfrm>
+            <a:off x="8193024" y="1463040"/>
+            <a:ext cx="3611880" cy="3108960"/>
+          </a:xfrm>
+          <a:prstGeom prst="roundRect">
+            <a:avLst>
+              <a:gd name="adj" fmla="val 3529"/>
+            </a:avLst>
+          </a:prstGeom>
+          <a:solidFill>
+            <a:srgbClr val="E5F2F0"/>
+          </a:solidFill>
+          <a:ln/>
+        </p:spPr>
+      </p:sp>
+      <p:sp>
+        <p:nvSpPr>
+          <p:cNvPr id="14" name="Shape 10"/>
+          <p:cNvSpPr/>
+          <p:nvPr/>
+        </p:nvSpPr>
+        <p:spPr>
+          <a:xfrm>
+            <a:off x="8467344" y="1755648"/>
+            <a:ext cx="658368" cy="658368"/>
+          </a:xfrm>
+          <a:prstGeom prst="ellipse">
+            <a:avLst/>
+          </a:prstGeom>
+          <a:solidFill>
+            <a:srgbClr val="01485C"/>
+          </a:solidFill>
+          <a:ln/>
+        </p:spPr>
+      </p:sp>
+      <p:pic>
+        <p:nvPicPr>
+          <p:cNvPr id="15" name="Image 2" descr="icon_clipboard_w.png">    </p:cNvPr>
+          <p:cNvPicPr>
+            <a:picLocks noChangeAspect="1"/>
+          </p:cNvPicPr>
+          <p:nvPr/>
+        </p:nvPicPr>
+        <p:blipFill>
+          <a:blip r:embed="rId3"/>
+          <a:stretch>
+            <a:fillRect/>
+          </a:stretch>
+        </p:blipFill>
+        <p:spPr>
+          <a:xfrm>
+            <a:off x="8638520" y="1926824"/>
+            <a:ext cx="316017" cy="316017"/>
+          </a:xfrm>
+          <a:prstGeom prst="rect">
+            <a:avLst/>
+          </a:prstGeom>
+        </p:spPr>
+      </p:pic>
+      <p:sp>
+        <p:nvSpPr>
+          <p:cNvPr id="16" name="Text 11"/>
+          <p:cNvSpPr txBox="1"/>
+          <p:nvPr/>
+        </p:nvSpPr>
+        <p:spPr>
+          <a:xfrm>
+            <a:off x="8467344" y="2606040"/>
+            <a:ext cx="3063240" cy="457200"/>
+          </a:xfrm>
+          <a:prstGeom prst="rect">
+            <a:avLst/>
+          </a:prstGeom>
+          <a:noFill/>
+          <a:ln/>
+        </p:spPr>
+        <p:txBody>
+          <a:bodyPr wrap="square" lIns="0" tIns="0" rIns="0" bIns="0" rtlCol="0" anchor="ctr"/>
+          <a:lstStyle/>
+          <a:p>
+            <a:pPr indent="0" marL="0">
+              <a:buNone/>
+            </a:pPr>
+            <a:r>
+              <a:rPr lang="en-US" sz="1600" b="1" dirty="0">
+                <a:solidFill>
+                  <a:srgbClr val="01485C"/>
+                </a:solidFill>
+                <a:latin typeface="Calibri" pitchFamily="34" charset="0"/>
+                <a:ea typeface="Calibri" pitchFamily="34" charset="-122"/>
+                <a:cs typeface="Calibri" pitchFamily="34" charset="-120"/>
+              </a:rPr>
+              <a:t>Human-readable, on-device</a:t>
+            </a:r>
+            <a:endParaRPr lang="en-US" sz="1600" dirty="0"/>
+          </a:p>
+        </p:txBody>
+      </p:sp>
+      <p:sp>
+        <p:nvSpPr>
+          <p:cNvPr id="17" name="Text 12"/>
+          <p:cNvSpPr txBox="1"/>
+          <p:nvPr/>
+        </p:nvSpPr>
+        <p:spPr>
+          <a:xfrm>
+            <a:off x="8467344" y="3108960"/>
+            <a:ext cx="3063240" cy="1371600"/>
+          </a:xfrm>
+          <a:prstGeom prst="rect">
+            <a:avLst/>
+          </a:prstGeom>
+          <a:noFill/>
+          <a:ln/>
+        </p:spPr>
+        <p:txBody>
+          <a:bodyPr wrap="square" lIns="0" tIns="0" rIns="0" bIns="0" rtlCol="0" anchor="ctr"/>
+          <a:lstStyle/>
+          <a:p>
+            <a:pPr indent="0" marL="0">
+              <a:buNone/>
+            </a:pPr>
+            <a:r>
+              <a:rPr lang="en-US" sz="1250" dirty="0">
+                <a:solidFill>
+                  <a:srgbClr val="17272E"/>
+                </a:solidFill>
+                <a:latin typeface="Calibri" pitchFamily="34" charset="0"/>
+                <a:ea typeface="Calibri" pitchFamily="34" charset="-122"/>
+                <a:cs typeface="Calibri" pitchFamily="34" charset="-120"/>
+              </a:rPr>
+              <a:t>Plain text on the drive — reviewable by any auditor without tooling, tied to OS usernames</a:t>
+            </a:r>
+            <a:endParaRPr lang="en-US" sz="1250" dirty="0"/>
+          </a:p>
+        </p:txBody>
+      </p:sp>
+      <p:sp>
+        <p:nvSpPr>
+          <p:cNvPr id="18" name="Text 13"/>
+          <p:cNvSpPr txBox="1"/>
+          <p:nvPr/>
+        </p:nvSpPr>
+        <p:spPr>
+          <a:xfrm>
+            <a:off x="548640" y="5029200"/>
+            <a:ext cx="11064240" cy="457200"/>
+          </a:xfrm>
+          <a:prstGeom prst="rect">
+            <a:avLst/>
+          </a:prstGeom>
+          <a:noFill/>
+          <a:ln/>
+        </p:spPr>
+        <p:txBody>
+          <a:bodyPr wrap="square" lIns="0" tIns="0" rIns="0" bIns="0" rtlCol="0" anchor="ctr"/>
+          <a:lstStyle/>
+          <a:p>
+            <a:pPr indent="0" marL="0">
+              <a:buNone/>
+            </a:pPr>
+            <a:r>
+              <a:rPr lang="en-US" sz="1400" i="1" dirty="0">
+                <a:solidFill>
+                  <a:srgbClr val="5F7178"/>
+                </a:solidFill>
+                <a:latin typeface="Calibri" pitchFamily="34" charset="0"/>
+                <a:ea typeface="Calibri" pitchFamily="34" charset="-122"/>
+                <a:cs typeface="Calibri" pitchFamily="34" charset="-120"/>
+              </a:rPr>
+              <a:t>Failed password attempts are recorded — repeated failures on a found drive leave evidence.</a:t>
+            </a:r>
+            <a:endParaRPr lang="en-US" sz="1400" dirty="0"/>
+          </a:p>
+        </p:txBody>
+      </p:sp>
+      <p:sp>
+        <p:nvSpPr>
+          <p:cNvPr id="19" name="Shape 14"/>
+          <p:cNvSpPr/>
+          <p:nvPr/>
+        </p:nvSpPr>
+        <p:spPr>
+          <a:xfrm>
+            <a:off x="0" y="6793992"/>
+            <a:ext cx="2040636" cy="64008"/>
+          </a:xfrm>
+          <a:prstGeom prst="rect">
+            <a:avLst/>
+          </a:prstGeom>
+          <a:solidFill>
+            <a:srgbClr val="01485C"/>
+          </a:solidFill>
+          <a:ln/>
+        </p:spPr>
+      </p:sp>
+      <p:sp>
+        <p:nvSpPr>
+          <p:cNvPr id="20" name="Shape 15"/>
+          <p:cNvSpPr/>
+          <p:nvPr/>
+        </p:nvSpPr>
+        <p:spPr>
+          <a:xfrm>
+            <a:off x="2031492" y="6793992"/>
+            <a:ext cx="2040636" cy="64008"/>
+          </a:xfrm>
+          <a:prstGeom prst="rect">
+            <a:avLst/>
+          </a:prstGeom>
+          <a:solidFill>
+            <a:srgbClr val="146175"/>
+          </a:solidFill>
+          <a:ln/>
+        </p:spPr>
+      </p:sp>
+      <p:sp>
+        <p:nvSpPr>
+          <p:cNvPr id="21" name="Shape 16"/>
+          <p:cNvSpPr/>
+          <p:nvPr/>
+        </p:nvSpPr>
+        <p:spPr>
+          <a:xfrm>
+            <a:off x="4062984" y="6793992"/>
+            <a:ext cx="2040636" cy="64008"/>
+          </a:xfrm>
+          <a:prstGeom prst="rect">
+            <a:avLst/>
+          </a:prstGeom>
+          <a:solidFill>
+            <a:srgbClr val="11B5AE"/>
+          </a:solidFill>
+          <a:ln/>
+        </p:spPr>
+      </p:sp>
+      <p:sp>
+        <p:nvSpPr>
+          <p:cNvPr id="22" name="Shape 17"/>
+          <p:cNvSpPr/>
+          <p:nvPr/>
+        </p:nvSpPr>
+        <p:spPr>
+          <a:xfrm>
+            <a:off x="6094476" y="6793992"/>
+            <a:ext cx="2040636" cy="64008"/>
+          </a:xfrm>
+          <a:prstGeom prst="rect">
+            <a:avLst/>
+          </a:prstGeom>
+          <a:solidFill>
+            <a:srgbClr val="6CCAD4"/>
+          </a:solidFill>
+          <a:ln/>
+        </p:spPr>
+      </p:sp>
+      <p:sp>
+        <p:nvSpPr>
+          <p:cNvPr id="23" name="Shape 18"/>
+          <p:cNvSpPr/>
+          <p:nvPr/>
+        </p:nvSpPr>
+        <p:spPr>
+          <a:xfrm>
+            <a:off x="8125968" y="6793992"/>
+            <a:ext cx="2040636" cy="64008"/>
+          </a:xfrm>
+          <a:prstGeom prst="rect">
+            <a:avLst/>
+          </a:prstGeom>
+          <a:solidFill>
+            <a:srgbClr val="7FC04C"/>
+          </a:solidFill>
+          <a:ln/>
+        </p:spPr>
+      </p:sp>
+      <p:sp>
+        <p:nvSpPr>
+          <p:cNvPr id="24" name="Shape 19"/>
+          <p:cNvSpPr/>
+          <p:nvPr/>
+        </p:nvSpPr>
+        <p:spPr>
+          <a:xfrm>
+            <a:off x="10157460" y="6793992"/>
+            <a:ext cx="2040636" cy="64008"/>
+          </a:xfrm>
+          <a:prstGeom prst="rect">
+            <a:avLst/>
+          </a:prstGeom>
+          <a:solidFill>
+            <a:srgbClr val="E1DD57"/>
+          </a:solidFill>
+          <a:ln/>
+        </p:spPr>
+      </p:sp>
+    </p:spTree>
+  </p:cSld>
+  <p:clrMapOvr>
+    <a:masterClrMapping/>
+  </p:clrMapOvr>
+</p:sld>
+</file>
+
+<file path=ppt/slides/slide11.xml><?xml version="1.0" encoding="utf-8"?>
 <p:sld xmlns:a="http://schemas.openxmlformats.org/drawingml/2006/main" xmlns:r="http://schemas.openxmlformats.org/officeDocument/2006/relationships" xmlns:p="http://schemas.openxmlformats.org/presentationml/2006/main">
   <p:cSld name="Slide 10">
     <p:bg>
@@ -3285,7 +3983,7 @@
 </p:sld>
 </file>
 
-<file path=ppt/slides/slide11.xml><?xml version="1.0" encoding="utf-8"?>
+<file path=ppt/slides/slide12.xml><?xml version="1.0" encoding="utf-8"?>
 <p:sld xmlns:a="http://schemas.openxmlformats.org/drawingml/2006/main" xmlns:r="http://schemas.openxmlformats.org/officeDocument/2006/relationships" xmlns:p="http://schemas.openxmlformats.org/presentationml/2006/main">
   <p:cSld name="Slide 11">
     <p:bg>
@@ -4329,920 +5027,6 @@
             <a:endParaRPr lang="en-US" sz="1550" dirty="0"/>
           </a:p>
         </p:txBody>
-      </p:sp>
-    </p:spTree>
-  </p:cSld>
-  <p:clrMapOvr>
-    <a:masterClrMapping/>
-  </p:clrMapOvr>
-</p:sld>
-</file>
-
-<file path=ppt/slides/slide12.xml><?xml version="1.0" encoding="utf-8"?>
-<p:sld xmlns:a="http://schemas.openxmlformats.org/drawingml/2006/main" xmlns:p="http://schemas.openxmlformats.org/presentationml/2006/main" xmlns:r="http://schemas.openxmlformats.org/officeDocument/2006/relationships">
-  <p:cSld>
-    <p:spTree>
-      <p:nvGrpSpPr>
-        <p:cNvPr id="1" name=""/>
-        <p:cNvGrpSpPr/>
-        <p:nvPr/>
-      </p:nvGrpSpPr>
-      <p:grpSpPr/>
-      <p:sp>
-        <p:nvSpPr>
-          <p:cNvPr id="2" name="Text 0"/>
-          <p:cNvSpPr txBox="1"/>
-          <p:nvPr/>
-        </p:nvSpPr>
-        <p:spPr>
-          <a:xfrm>
-            <a:off x="548640" y="320040"/>
-            <a:ext cx="11064240" cy="685800"/>
-          </a:xfrm>
-          <a:prstGeom prst="rect">
-            <a:avLst/>
-          </a:prstGeom>
-          <a:noFill/>
-          <a:ln/>
-        </p:spPr>
-        <p:txBody>
-          <a:bodyPr wrap="square" lIns="0" tIns="0" rIns="0" bIns="0" rtlCol="0" anchor="ctr"/>
-          <a:lstStyle/>
-          <a:p>
-            <a:pPr algn="l" indent="0" marL="0">
-              <a:buNone/>
-            </a:pPr>
-            <a:r>
-              <a:rPr lang="en-US" sz="3000" b="1" dirty="0">
-                <a:solidFill>
-                  <a:srgbClr val="01485C"/>
-                </a:solidFill>
-                <a:latin typeface="Calibri" pitchFamily="34" charset="0"/>
-                <a:ea typeface="Calibri" pitchFamily="34" charset="-122"/>
-                <a:cs typeface="Calibri" pitchFamily="34" charset="-120"/>
-              </a:rPr>
-              <a:t>Where it can run — central licensing</a:t>
-            </a:r>
-            <a:endParaRPr lang="en-US" sz="3000" dirty="0"/>
-          </a:p>
-        </p:txBody>
-      </p:sp>
-      <p:sp>
-        <p:nvSpPr>
-          <p:cNvPr id="3" name="Shape 1"/>
-          <p:cNvSpPr/>
-          <p:nvPr/>
-        </p:nvSpPr>
-        <p:spPr>
-          <a:xfrm>
-            <a:off x="548640" y="1371600"/>
-            <a:ext cx="3383280" cy="1554480"/>
-          </a:xfrm>
-          <a:prstGeom prst="roundRect">
-            <a:avLst>
-              <a:gd name="adj" fmla="val 7059"/>
-            </a:avLst>
-          </a:prstGeom>
-          <a:solidFill>
-            <a:srgbClr val="E5F2F0"/>
-          </a:solidFill>
-          <a:ln/>
-        </p:spPr>
-        <p:txBody>
-          <a:bodyPr/>
-          <a:p/>
-        </p:txBody>
-      </p:sp>
-      <p:sp>
-        <p:nvSpPr>
-          <p:cNvPr id="4" name="Text 2"/>
-          <p:cNvSpPr txBox="1"/>
-          <p:nvPr/>
-        </p:nvSpPr>
-        <p:spPr>
-          <a:xfrm>
-            <a:off x="777240" y="1536192"/>
-            <a:ext cx="2926080" cy="365760"/>
-          </a:xfrm>
-          <a:prstGeom prst="rect">
-            <a:avLst/>
-          </a:prstGeom>
-          <a:noFill/>
-          <a:ln/>
-        </p:spPr>
-        <p:txBody>
-          <a:bodyPr wrap="square" lIns="0" tIns="0" rIns="0" bIns="0" rtlCol="0" anchor="ctr"/>
-          <a:lstStyle/>
-          <a:p>
-            <a:pPr indent="0" marL="0">
-              <a:buNone/>
-            </a:pPr>
-            <a:r>
-              <a:rPr lang="en-US" sz="1600" b="1" dirty="0">
-                <a:solidFill>
-                  <a:srgbClr val="01485C"/>
-                </a:solidFill>
-                <a:latin typeface="Calibri" pitchFamily="34" charset="0"/>
-                <a:ea typeface="Calibri" pitchFamily="34" charset="-122"/>
-                <a:cs typeface="Calibri" pitchFamily="34" charset="-120"/>
-              </a:rPr>
-              <a:t>Issued centrally</a:t>
-            </a:r>
-            <a:endParaRPr lang="en-US" sz="1600" dirty="0"/>
-          </a:p>
-        </p:txBody>
-      </p:sp>
-      <p:sp>
-        <p:nvSpPr>
-          <p:cNvPr id="5" name="Text 3"/>
-          <p:cNvSpPr txBox="1"/>
-          <p:nvPr/>
-        </p:nvSpPr>
-        <p:spPr>
-          <a:xfrm>
-            <a:off x="777240" y="1938528"/>
-            <a:ext cx="2926080" cy="914400"/>
-          </a:xfrm>
-          <a:prstGeom prst="rect">
-            <a:avLst/>
-          </a:prstGeom>
-          <a:noFill/>
-          <a:ln/>
-        </p:spPr>
-        <p:txBody>
-          <a:bodyPr wrap="square" lIns="0" tIns="0" rIns="0" bIns="0" rtlCol="0" anchor="ctr"/>
-          <a:lstStyle/>
-          <a:p>
-            <a:pPr indent="0" marL="0">
-              <a:buNone/>
-            </a:pPr>
-            <a:r>
-              <a:rPr lang="en-US" sz="1250" dirty="0">
-                <a:solidFill>
-                  <a:srgbClr val="5F7178"/>
-                </a:solidFill>
-                <a:latin typeface="Calibri" pitchFamily="34" charset="0"/>
-                <a:ea typeface="Calibri" pitchFamily="34" charset="-122"/>
-                <a:cs typeface="Calibri" pitchFamily="34" charset="-120"/>
-              </a:rPr>
-              <a:t>Only the PoC lead’s offline keygen can sign a licence; the drive carries just the public key</a:t>
-            </a:r>
-            <a:endParaRPr lang="en-US" sz="1250" dirty="0"/>
-          </a:p>
-        </p:txBody>
-      </p:sp>
-      <p:sp>
-        <p:nvSpPr>
-          <p:cNvPr id="6" name="Shape 4"/>
-          <p:cNvSpPr/>
-          <p:nvPr/>
-        </p:nvSpPr>
-        <p:spPr>
-          <a:xfrm>
-            <a:off x="3977640" y="2148840"/>
-            <a:ext cx="320040" cy="0"/>
-          </a:xfrm>
-          <a:prstGeom prst="line">
-            <a:avLst/>
-          </a:prstGeom>
-          <a:noFill/>
-          <a:ln w="31750">
-            <a:solidFill>
-              <a:srgbClr val="01485C"/>
-            </a:solidFill>
-            <a:prstDash val="solid"/>
-            <a:tailEnd type="triangle"/>
-          </a:ln>
-        </p:spPr>
-        <p:txBody>
-          <a:bodyPr/>
-          <a:p/>
-        </p:txBody>
-      </p:sp>
-      <p:sp>
-        <p:nvSpPr>
-          <p:cNvPr id="7" name="Shape 5"/>
-          <p:cNvSpPr/>
-          <p:nvPr/>
-        </p:nvSpPr>
-        <p:spPr>
-          <a:xfrm>
-            <a:off x="4343400" y="1371600"/>
-            <a:ext cx="3383280" cy="1554480"/>
-          </a:xfrm>
-          <a:prstGeom prst="roundRect">
-            <a:avLst>
-              <a:gd name="adj" fmla="val 7059"/>
-            </a:avLst>
-          </a:prstGeom>
-          <a:solidFill>
-            <a:srgbClr val="E5F2F0"/>
-          </a:solidFill>
-          <a:ln/>
-        </p:spPr>
-        <p:txBody>
-          <a:bodyPr/>
-          <a:p/>
-        </p:txBody>
-      </p:sp>
-      <p:sp>
-        <p:nvSpPr>
-          <p:cNvPr id="8" name="Text 6"/>
-          <p:cNvSpPr txBox="1"/>
-          <p:nvPr/>
-        </p:nvSpPr>
-        <p:spPr>
-          <a:xfrm>
-            <a:off x="4572000" y="1536192"/>
-            <a:ext cx="2926080" cy="365760"/>
-          </a:xfrm>
-          <a:prstGeom prst="rect">
-            <a:avLst/>
-          </a:prstGeom>
-          <a:noFill/>
-          <a:ln/>
-        </p:spPr>
-        <p:txBody>
-          <a:bodyPr wrap="square" lIns="0" tIns="0" rIns="0" bIns="0" rtlCol="0" anchor="ctr"/>
-          <a:lstStyle/>
-          <a:p>
-            <a:pPr indent="0" marL="0">
-              <a:buNone/>
-            </a:pPr>
-            <a:r>
-              <a:rPr lang="en-US" sz="1600" b="1" dirty="0">
-                <a:solidFill>
-                  <a:srgbClr val="01485C"/>
-                </a:solidFill>
-                <a:latin typeface="Calibri" pitchFamily="34" charset="0"/>
-                <a:ea typeface="Calibri" pitchFamily="34" charset="-122"/>
-                <a:cs typeface="Calibri" pitchFamily="34" charset="-120"/>
-              </a:rPr>
-              <a:t>Bound to the motherboard</a:t>
-            </a:r>
-            <a:endParaRPr lang="en-US" sz="1600" dirty="0"/>
-          </a:p>
-        </p:txBody>
-      </p:sp>
-      <p:sp>
-        <p:nvSpPr>
-          <p:cNvPr id="9" name="Text 7"/>
-          <p:cNvSpPr txBox="1"/>
-          <p:nvPr/>
-        </p:nvSpPr>
-        <p:spPr>
-          <a:xfrm>
-            <a:off x="4572000" y="1938528"/>
-            <a:ext cx="2926080" cy="914400"/>
-          </a:xfrm>
-          <a:prstGeom prst="rect">
-            <a:avLst/>
-          </a:prstGeom>
-          <a:noFill/>
-          <a:ln/>
-        </p:spPr>
-        <p:txBody>
-          <a:bodyPr wrap="square" lIns="0" tIns="0" rIns="0" bIns="0" rtlCol="0" anchor="ctr"/>
-          <a:lstStyle/>
-          <a:p>
-            <a:pPr indent="0" marL="0">
-              <a:buNone/>
-            </a:pPr>
-            <a:r>
-              <a:rPr lang="en-US" sz="1250" dirty="0">
-                <a:solidFill>
-                  <a:srgbClr val="5F7178"/>
-                </a:solidFill>
-                <a:latin typeface="Calibri" pitchFamily="34" charset="0"/>
-                <a:ea typeface="Calibri" pitchFamily="34" charset="-122"/>
-                <a:cs typeface="Calibri" pitchFamily="34" charset="-120"/>
-              </a:rPr>
-              <a:t>ID = hash of system UUID, board serial, drive serial and hostname — a copied drive stays locked elsewhere</a:t>
-            </a:r>
-            <a:endParaRPr lang="en-US" sz="1250" dirty="0"/>
-          </a:p>
-        </p:txBody>
-      </p:sp>
-      <p:sp>
-        <p:nvSpPr>
-          <p:cNvPr id="10" name="Shape 8"/>
-          <p:cNvSpPr/>
-          <p:nvPr/>
-        </p:nvSpPr>
-        <p:spPr>
-          <a:xfrm>
-            <a:off x="7772400" y="2148840"/>
-            <a:ext cx="320040" cy="0"/>
-          </a:xfrm>
-          <a:prstGeom prst="line">
-            <a:avLst/>
-          </a:prstGeom>
-          <a:noFill/>
-          <a:ln w="31750">
-            <a:solidFill>
-              <a:srgbClr val="01485C"/>
-            </a:solidFill>
-            <a:prstDash val="solid"/>
-            <a:tailEnd type="triangle"/>
-          </a:ln>
-        </p:spPr>
-        <p:txBody>
-          <a:bodyPr/>
-          <a:p/>
-        </p:txBody>
-      </p:sp>
-      <p:sp>
-        <p:nvSpPr>
-          <p:cNvPr id="11" name="Shape 9"/>
-          <p:cNvSpPr/>
-          <p:nvPr/>
-        </p:nvSpPr>
-        <p:spPr>
-          <a:xfrm>
-            <a:off x="8138160" y="1371600"/>
-            <a:ext cx="3383280" cy="1554480"/>
-          </a:xfrm>
-          <a:prstGeom prst="roundRect">
-            <a:avLst>
-              <a:gd name="adj" fmla="val 7059"/>
-            </a:avLst>
-          </a:prstGeom>
-          <a:solidFill>
-            <a:srgbClr val="01485C"/>
-          </a:solidFill>
-          <a:ln/>
-        </p:spPr>
-        <p:txBody>
-          <a:bodyPr/>
-          <a:p/>
-        </p:txBody>
-      </p:sp>
-      <p:sp>
-        <p:nvSpPr>
-          <p:cNvPr id="12" name="Text 10"/>
-          <p:cNvSpPr txBox="1"/>
-          <p:nvPr/>
-        </p:nvSpPr>
-        <p:spPr>
-          <a:xfrm>
-            <a:off x="8366760" y="1536192"/>
-            <a:ext cx="2926080" cy="365760"/>
-          </a:xfrm>
-          <a:prstGeom prst="rect">
-            <a:avLst/>
-          </a:prstGeom>
-          <a:noFill/>
-          <a:ln/>
-        </p:spPr>
-        <p:txBody>
-          <a:bodyPr wrap="square" lIns="0" tIns="0" rIns="0" bIns="0" rtlCol="0" anchor="ctr"/>
-          <a:lstStyle/>
-          <a:p>
-            <a:pPr indent="0" marL="0">
-              <a:buNone/>
-            </a:pPr>
-            <a:r>
-              <a:rPr lang="en-US" sz="1600" b="1" dirty="0">
-                <a:solidFill>
-                  <a:srgbClr val="FFFFFF"/>
-                </a:solidFill>
-                <a:latin typeface="Calibri" pitchFamily="34" charset="0"/>
-                <a:ea typeface="Calibri" pitchFamily="34" charset="-122"/>
-                <a:cs typeface="Calibri" pitchFamily="34" charset="-120"/>
-              </a:rPr>
-              <a:t>12-month QIS term</a:t>
-            </a:r>
-            <a:endParaRPr lang="en-US" sz="1600" dirty="0"/>
-          </a:p>
-        </p:txBody>
-      </p:sp>
-      <p:sp>
-        <p:nvSpPr>
-          <p:cNvPr id="13" name="Text 11"/>
-          <p:cNvSpPr txBox="1"/>
-          <p:nvPr/>
-        </p:nvSpPr>
-        <p:spPr>
-          <a:xfrm>
-            <a:off x="8366760" y="1938528"/>
-            <a:ext cx="2926080" cy="914400"/>
-          </a:xfrm>
-          <a:prstGeom prst="rect">
-            <a:avLst/>
-          </a:prstGeom>
-          <a:noFill/>
-          <a:ln/>
-        </p:spPr>
-        <p:txBody>
-          <a:bodyPr wrap="square" lIns="0" tIns="0" rIns="0" bIns="0" rtlCol="0" anchor="ctr"/>
-          <a:lstStyle/>
-          <a:p>
-            <a:pPr indent="0" marL="0">
-              <a:buNone/>
-            </a:pPr>
-            <a:r>
-              <a:rPr lang="en-US" sz="1250" dirty="0">
-                <a:solidFill>
-                  <a:srgbClr val="6CCAD4"/>
-                </a:solidFill>
-                <a:latin typeface="Calibri" pitchFamily="34" charset="0"/>
-                <a:ea typeface="Calibri" pitchFamily="34" charset="-122"/>
-                <a:cs typeface="Calibri" pitchFamily="34" charset="-120"/>
-              </a:rPr>
-              <a:t>Each licence names the newest bundle it covers; a review means a new version and re-issued licences</a:t>
-            </a:r>
-            <a:endParaRPr lang="en-US" sz="1250" dirty="0"/>
-          </a:p>
-        </p:txBody>
-      </p:sp>
-      <p:sp>
-        <p:nvSpPr>
-          <p:cNvPr id="14" name="Text 12"/>
-          <p:cNvSpPr txBox="1"/>
-          <p:nvPr/>
-        </p:nvSpPr>
-        <p:spPr>
-          <a:xfrm>
-            <a:off x="548640" y="3383280"/>
-            <a:ext cx="6949440" cy="411480"/>
-          </a:xfrm>
-          <a:prstGeom prst="rect">
-            <a:avLst/>
-          </a:prstGeom>
-          <a:noFill/>
-          <a:ln/>
-        </p:spPr>
-        <p:txBody>
-          <a:bodyPr wrap="square" lIns="0" tIns="0" rIns="0" bIns="0" rtlCol="0" anchor="ctr"/>
-          <a:lstStyle/>
-          <a:p>
-            <a:pPr indent="0" marL="0">
-              <a:buNone/>
-            </a:pPr>
-            <a:r>
-              <a:rPr lang="en-US" sz="1400" b="1" dirty="0">
-                <a:solidFill>
-                  <a:srgbClr val="01485C"/>
-                </a:solidFill>
-                <a:latin typeface="Calibri" pitchFamily="34" charset="0"/>
-                <a:ea typeface="Calibri" pitchFamily="34" charset="-122"/>
-                <a:cs typeface="Calibri" pitchFamily="34" charset="-120"/>
-              </a:rPr>
-              <a:t>Licence file   </a:t>
-            </a:r>
-            <a:pPr indent="0" marL="0">
-              <a:buNone/>
-            </a:pPr>
-            <a:r>
-              <a:rPr lang="en-US" sz="1400" dirty="0">
-                <a:solidFill>
-                  <a:srgbClr val="17272E"/>
-                </a:solidFill>
-                <a:latin typeface="Calibri" pitchFamily="34" charset="0"/>
-                <a:ea typeface="Calibri" pitchFamily="34" charset="-122"/>
-                <a:cs typeface="Calibri" pitchFamily="34" charset="-120"/>
-              </a:rPr>
-              <a:t>Signed JSON (Ed25519): site, machine IDs, seat cap, expiry, max version — edits are refused</a:t>
-            </a:r>
-            <a:endParaRPr lang="en-US" sz="1400" dirty="0"/>
-          </a:p>
-        </p:txBody>
-      </p:sp>
-      <p:sp>
-        <p:nvSpPr>
-          <p:cNvPr id="15" name="Text 13"/>
-          <p:cNvSpPr txBox="1"/>
-          <p:nvPr/>
-        </p:nvSpPr>
-        <p:spPr>
-          <a:xfrm>
-            <a:off x="548640" y="3858768"/>
-            <a:ext cx="6949440" cy="411480"/>
-          </a:xfrm>
-          <a:prstGeom prst="rect">
-            <a:avLst/>
-          </a:prstGeom>
-          <a:noFill/>
-          <a:ln/>
-        </p:spPr>
-        <p:txBody>
-          <a:bodyPr wrap="square" lIns="0" tIns="0" rIns="0" bIns="0" rtlCol="0" anchor="ctr"/>
-          <a:lstStyle/>
-          <a:p>
-            <a:pPr indent="0" marL="0">
-              <a:buNone/>
-            </a:pPr>
-            <a:r>
-              <a:rPr lang="en-US" sz="1400" b="1" dirty="0">
-                <a:solidFill>
-                  <a:srgbClr val="01485C"/>
-                </a:solidFill>
-                <a:latin typeface="Calibri" pitchFamily="34" charset="0"/>
-                <a:ea typeface="Calibri" pitchFamily="34" charset="-122"/>
-                <a:cs typeface="Calibri" pitchFamily="34" charset="-120"/>
-              </a:rPr>
-              <a:t>Key custody   </a:t>
-            </a:r>
-            <a:pPr indent="0" marL="0">
-              <a:buNone/>
-            </a:pPr>
-            <a:r>
-              <a:rPr lang="en-US" sz="1400" dirty="0">
-                <a:solidFill>
-                  <a:srgbClr val="17272E"/>
-                </a:solidFill>
-                <a:latin typeface="Calibri" pitchFamily="34" charset="0"/>
-                <a:ea typeface="Calibri" pitchFamily="34" charset="-122"/>
-                <a:cs typeface="Calibri" pitchFamily="34" charset="-120"/>
-              </a:rPr>
-              <a:t>Private key kept off the drive (PQ_Licensing); loss means re-issuing, never a bypass</a:t>
-            </a:r>
-            <a:endParaRPr lang="en-US" sz="1400" dirty="0"/>
-          </a:p>
-        </p:txBody>
-      </p:sp>
-      <p:sp>
-        <p:nvSpPr>
-          <p:cNvPr id="16" name="Text 14"/>
-          <p:cNvSpPr txBox="1"/>
-          <p:nvPr/>
-        </p:nvSpPr>
-        <p:spPr>
-          <a:xfrm>
-            <a:off x="548640" y="4334256"/>
-            <a:ext cx="6949440" cy="411480"/>
-          </a:xfrm>
-          <a:prstGeom prst="rect">
-            <a:avLst/>
-          </a:prstGeom>
-          <a:noFill/>
-          <a:ln/>
-        </p:spPr>
-        <p:txBody>
-          <a:bodyPr wrap="square" lIns="0" tIns="0" rIns="0" bIns="0" rtlCol="0" anchor="ctr"/>
-          <a:lstStyle/>
-          <a:p>
-            <a:pPr indent="0" marL="0">
-              <a:buNone/>
-            </a:pPr>
-            <a:r>
-              <a:rPr lang="en-US" sz="1400" b="1" dirty="0">
-                <a:solidFill>
-                  <a:srgbClr val="01485C"/>
-                </a:solidFill>
-                <a:latin typeface="Calibri" pitchFamily="34" charset="0"/>
-                <a:ea typeface="Calibri" pitchFamily="34" charset="-122"/>
-                <a:cs typeface="Calibri" pitchFamily="34" charset="-120"/>
-              </a:rPr>
-              <a:t>Enforcement   </a:t>
-            </a:r>
-            <a:pPr indent="0" marL="0">
-              <a:buNone/>
-            </a:pPr>
-            <a:r>
-              <a:rPr lang="en-US" sz="1400" dirty="0">
-                <a:solidFill>
-                  <a:srgbClr val="17272E"/>
-                </a:solidFill>
-                <a:latin typeface="Calibri" pitchFamily="34" charset="0"/>
-                <a:ea typeface="Calibri" pitchFamily="34" charset="-122"/>
-                <a:cs typeface="Calibri" pitchFamily="34" charset="-120"/>
-              </a:rPr>
-              <a:t>Portal and both engines lock unless a licence covers this PC and version, in term</a:t>
-            </a:r>
-            <a:endParaRPr lang="en-US" sz="1400" dirty="0"/>
-          </a:p>
-        </p:txBody>
-      </p:sp>
-      <p:sp>
-        <p:nvSpPr>
-          <p:cNvPr id="17" name="Text 15"/>
-          <p:cNvSpPr txBox="1"/>
-          <p:nvPr/>
-        </p:nvSpPr>
-        <p:spPr>
-          <a:xfrm>
-            <a:off x="548640" y="4809744"/>
-            <a:ext cx="6949440" cy="411480"/>
-          </a:xfrm>
-          <a:prstGeom prst="rect">
-            <a:avLst/>
-          </a:prstGeom>
-          <a:noFill/>
-          <a:ln/>
-        </p:spPr>
-        <p:txBody>
-          <a:bodyPr wrap="square" lIns="0" tIns="0" rIns="0" bIns="0" rtlCol="0" anchor="ctr"/>
-          <a:lstStyle/>
-          <a:p>
-            <a:pPr indent="0" marL="0">
-              <a:buNone/>
-            </a:pPr>
-            <a:r>
-              <a:rPr lang="en-US" sz="1400" b="1" dirty="0">
-                <a:solidFill>
-                  <a:srgbClr val="01485C"/>
-                </a:solidFill>
-                <a:latin typeface="Calibri" pitchFamily="34" charset="0"/>
-                <a:ea typeface="Calibri" pitchFamily="34" charset="-122"/>
-                <a:cs typeface="Calibri" pitchFamily="34" charset="-120"/>
-              </a:rPr>
-              <a:t>Audit   </a:t>
-            </a:r>
-            <a:pPr indent="0" marL="0">
-              <a:buNone/>
-            </a:pPr>
-            <a:r>
-              <a:rPr lang="en-US" sz="1400" dirty="0">
-                <a:solidFill>
-                  <a:srgbClr val="17272E"/>
-                </a:solidFill>
-                <a:latin typeface="Calibri" pitchFamily="34" charset="0"/>
-                <a:ea typeface="Calibri" pitchFamily="34" charset="-122"/>
-                <a:cs typeface="Calibri" pitchFamily="34" charset="-120"/>
-              </a:rPr>
-              <a:t>Every launch, install and refusal with PC, user, network state; central ledger of copies</a:t>
-            </a:r>
-            <a:endParaRPr lang="en-US" sz="1400" dirty="0"/>
-          </a:p>
-        </p:txBody>
-      </p:sp>
-      <p:sp>
-        <p:nvSpPr>
-          <p:cNvPr id="18" name="Shape 16"/>
-          <p:cNvSpPr/>
-          <p:nvPr/>
-        </p:nvSpPr>
-        <p:spPr>
-          <a:xfrm>
-            <a:off x="7863840" y="3383280"/>
-            <a:ext cx="3794760" cy="2103120"/>
-          </a:xfrm>
-          <a:prstGeom prst="roundRect">
-            <a:avLst>
-              <a:gd name="adj" fmla="val 5217"/>
-            </a:avLst>
-          </a:prstGeom>
-          <a:solidFill>
-            <a:srgbClr val="FDF0E4"/>
-          </a:solidFill>
-          <a:ln w="19050">
-            <a:solidFill>
-              <a:srgbClr val="B4540A"/>
-            </a:solidFill>
-            <a:prstDash val="solid"/>
-          </a:ln>
-        </p:spPr>
-        <p:txBody>
-          <a:bodyPr/>
-          <a:p/>
-        </p:txBody>
-      </p:sp>
-      <p:sp>
-        <p:nvSpPr>
-          <p:cNvPr id="19" name="Shape 17"/>
-          <p:cNvSpPr/>
-          <p:nvPr/>
-        </p:nvSpPr>
-        <p:spPr>
-          <a:xfrm>
-            <a:off x="8138160" y="3611880"/>
-            <a:ext cx="640080" cy="640080"/>
-          </a:xfrm>
-          <a:prstGeom prst="ellipse">
-            <a:avLst/>
-          </a:prstGeom>
-          <a:solidFill>
-            <a:srgbClr val="B4540A"/>
-          </a:solidFill>
-          <a:ln/>
-        </p:spPr>
-        <p:txBody>
-          <a:bodyPr/>
-          <a:p/>
-        </p:txBody>
-      </p:sp>
-      <p:pic>
-        <p:nvPicPr>
-          <p:cNvPr id="20" name="Image 0" descr="icon_warn_w.png">    </p:cNvPr>
-          <p:cNvPicPr>
-            <a:picLocks noChangeAspect="1"/>
-          </p:cNvPicPr>
-          <p:nvPr/>
-        </p:nvPicPr>
-        <p:blipFill>
-          <a:blip r:embed="rId2"/>
-          <a:stretch>
-            <a:fillRect/>
-          </a:stretch>
-        </p:blipFill>
-        <p:spPr>
-          <a:xfrm>
-            <a:off x="8304581" y="3778301"/>
-            <a:ext cx="307238" cy="307238"/>
-          </a:xfrm>
-          <a:prstGeom prst="rect">
-            <a:avLst/>
-          </a:prstGeom>
-        </p:spPr>
-      </p:pic>
-      <p:sp>
-        <p:nvSpPr>
-          <p:cNvPr id="21" name="Text 18"/>
-          <p:cNvSpPr txBox="1"/>
-          <p:nvPr/>
-        </p:nvSpPr>
-        <p:spPr>
-          <a:xfrm>
-            <a:off x="8915400" y="3703320"/>
-            <a:ext cx="2651760" cy="457200"/>
-          </a:xfrm>
-          <a:prstGeom prst="rect">
-            <a:avLst/>
-          </a:prstGeom>
-          <a:noFill/>
-          <a:ln/>
-        </p:spPr>
-        <p:txBody>
-          <a:bodyPr wrap="square" lIns="0" tIns="0" rIns="0" bIns="0" rtlCol="0" anchor="ctr"/>
-          <a:lstStyle/>
-          <a:p>
-            <a:pPr indent="0" marL="0">
-              <a:buNone/>
-            </a:pPr>
-            <a:r>
-              <a:rPr lang="en-US" sz="1500" b="1" dirty="0">
-                <a:solidFill>
-                  <a:srgbClr val="B4540A"/>
-                </a:solidFill>
-                <a:latin typeface="Calibri" pitchFamily="34" charset="0"/>
-                <a:ea typeface="Calibri" pitchFamily="34" charset="-122"/>
-                <a:cs typeface="Calibri" pitchFamily="34" charset="-120"/>
-              </a:rPr>
-              <a:t>Not DRM — by design</a:t>
-            </a:r>
-            <a:endParaRPr lang="en-US" sz="1500" dirty="0"/>
-          </a:p>
-        </p:txBody>
-      </p:sp>
-      <p:sp>
-        <p:nvSpPr>
-          <p:cNvPr id="22" name="Text 19"/>
-          <p:cNvSpPr txBox="1"/>
-          <p:nvPr/>
-        </p:nvSpPr>
-        <p:spPr>
-          <a:xfrm>
-            <a:off x="8138160" y="4343400"/>
-            <a:ext cx="3291840" cy="1005840"/>
-          </a:xfrm>
-          <a:prstGeom prst="rect">
-            <a:avLst/>
-          </a:prstGeom>
-          <a:noFill/>
-          <a:ln/>
-        </p:spPr>
-        <p:txBody>
-          <a:bodyPr wrap="square" lIns="0" tIns="0" rIns="0" bIns="0" rtlCol="0" anchor="ctr"/>
-          <a:lstStyle/>
-          <a:p>
-            <a:pPr indent="0" marL="0">
-              <a:buNone/>
-            </a:pPr>
-            <a:r>
-              <a:rPr lang="en-US" sz="1250" dirty="0">
-                <a:solidFill>
-                  <a:srgbClr val="17272E"/>
-                </a:solidFill>
-                <a:latin typeface="Calibri" pitchFamily="34" charset="0"/>
-                <a:ea typeface="Calibri" pitchFamily="34" charset="-122"/>
-                <a:cs typeface="Calibri" pitchFamily="34" charset="-120"/>
-              </a:rPr>
-              <a:t>The check lives on the drive: a BitLocker holder who edits the Python could remove it. It is an administrative control with evidence and a central register, not copy protection.</a:t>
-            </a:r>
-            <a:endParaRPr lang="en-US" sz="1250" dirty="0"/>
-          </a:p>
-        </p:txBody>
-      </p:sp>
-      <p:sp>
-        <p:nvSpPr>
-          <p:cNvPr id="23" name="Shape 20"/>
-          <p:cNvSpPr/>
-          <p:nvPr/>
-        </p:nvSpPr>
-        <p:spPr>
-          <a:xfrm>
-            <a:off x="0" y="6793992"/>
-            <a:ext cx="2040636" cy="64008"/>
-          </a:xfrm>
-          <a:prstGeom prst="rect">
-            <a:avLst/>
-          </a:prstGeom>
-          <a:solidFill>
-            <a:srgbClr val="01485C"/>
-          </a:solidFill>
-          <a:ln/>
-        </p:spPr>
-      </p:sp>
-      <p:sp>
-        <p:nvSpPr>
-          <p:cNvPr id="24" name="Shape 21"/>
-          <p:cNvSpPr/>
-          <p:nvPr/>
-        </p:nvSpPr>
-        <p:spPr>
-          <a:xfrm>
-            <a:off x="2031492" y="6793992"/>
-            <a:ext cx="2040636" cy="64008"/>
-          </a:xfrm>
-          <a:prstGeom prst="rect">
-            <a:avLst/>
-          </a:prstGeom>
-          <a:solidFill>
-            <a:srgbClr val="146175"/>
-          </a:solidFill>
-          <a:ln/>
-        </p:spPr>
-      </p:sp>
-      <p:sp>
-        <p:nvSpPr>
-          <p:cNvPr id="25" name="Shape 22"/>
-          <p:cNvSpPr/>
-          <p:nvPr/>
-        </p:nvSpPr>
-        <p:spPr>
-          <a:xfrm>
-            <a:off x="4062984" y="6793992"/>
-            <a:ext cx="2040636" cy="64008"/>
-          </a:xfrm>
-          <a:prstGeom prst="rect">
-            <a:avLst/>
-          </a:prstGeom>
-          <a:solidFill>
-            <a:srgbClr val="11B5AE"/>
-          </a:solidFill>
-          <a:ln/>
-        </p:spPr>
-      </p:sp>
-      <p:sp>
-        <p:nvSpPr>
-          <p:cNvPr id="26" name="Shape 23"/>
-          <p:cNvSpPr/>
-          <p:nvPr/>
-        </p:nvSpPr>
-        <p:spPr>
-          <a:xfrm>
-            <a:off x="6094476" y="6793992"/>
-            <a:ext cx="2040636" cy="64008"/>
-          </a:xfrm>
-          <a:prstGeom prst="rect">
-            <a:avLst/>
-          </a:prstGeom>
-          <a:solidFill>
-            <a:srgbClr val="6CCAD4"/>
-          </a:solidFill>
-          <a:ln/>
-        </p:spPr>
-      </p:sp>
-      <p:sp>
-        <p:nvSpPr>
-          <p:cNvPr id="27" name="Shape 24"/>
-          <p:cNvSpPr/>
-          <p:nvPr/>
-        </p:nvSpPr>
-        <p:spPr>
-          <a:xfrm>
-            <a:off x="8125968" y="6793992"/>
-            <a:ext cx="2040636" cy="64008"/>
-          </a:xfrm>
-          <a:prstGeom prst="rect">
-            <a:avLst/>
-          </a:prstGeom>
-          <a:solidFill>
-            <a:srgbClr val="7FC04C"/>
-          </a:solidFill>
-          <a:ln/>
-        </p:spPr>
-      </p:sp>
-      <p:sp>
-        <p:nvSpPr>
-          <p:cNvPr id="28" name="Shape 25"/>
-          <p:cNvSpPr/>
-          <p:nvPr/>
-        </p:nvSpPr>
-        <p:spPr>
-          <a:xfrm>
-            <a:off x="10157460" y="6793992"/>
-            <a:ext cx="2040636" cy="64008"/>
-          </a:xfrm>
-          <a:prstGeom prst="rect">
-            <a:avLst/>
-          </a:prstGeom>
-          <a:solidFill>
-            <a:srgbClr val="E1DD57"/>
-          </a:solidFill>
-          <a:ln/>
-        </p:spPr>
       </p:sp>
     </p:spTree>
   </p:cSld>
@@ -11592,6 +11376,920 @@
 </file>
 
 <file path=ppt/slides/slide8.xml><?xml version="1.0" encoding="utf-8"?>
+<p:sld xmlns:a="http://schemas.openxmlformats.org/drawingml/2006/main" xmlns:p="http://schemas.openxmlformats.org/presentationml/2006/main" xmlns:r="http://schemas.openxmlformats.org/officeDocument/2006/relationships">
+  <p:cSld>
+    <p:spTree>
+      <p:nvGrpSpPr>
+        <p:cNvPr id="1" name=""/>
+        <p:cNvGrpSpPr/>
+        <p:nvPr/>
+      </p:nvGrpSpPr>
+      <p:grpSpPr/>
+      <p:sp>
+        <p:nvSpPr>
+          <p:cNvPr id="2" name="Text 0"/>
+          <p:cNvSpPr txBox="1"/>
+          <p:nvPr/>
+        </p:nvSpPr>
+        <p:spPr>
+          <a:xfrm>
+            <a:off x="548640" y="320040"/>
+            <a:ext cx="11064240" cy="685800"/>
+          </a:xfrm>
+          <a:prstGeom prst="rect">
+            <a:avLst/>
+          </a:prstGeom>
+          <a:noFill/>
+          <a:ln/>
+        </p:spPr>
+        <p:txBody>
+          <a:bodyPr wrap="square" lIns="0" tIns="0" rIns="0" bIns="0" rtlCol="0" anchor="ctr"/>
+          <a:lstStyle/>
+          <a:p>
+            <a:pPr algn="l" indent="0" marL="0">
+              <a:buNone/>
+            </a:pPr>
+            <a:r>
+              <a:rPr lang="en-US" sz="3000" b="1" dirty="0">
+                <a:solidFill>
+                  <a:srgbClr val="01485C"/>
+                </a:solidFill>
+                <a:latin typeface="Calibri" pitchFamily="34" charset="0"/>
+                <a:ea typeface="Calibri" pitchFamily="34" charset="-122"/>
+                <a:cs typeface="Calibri" pitchFamily="34" charset="-120"/>
+              </a:rPr>
+              <a:t>Where it can run — central licensing</a:t>
+            </a:r>
+            <a:endParaRPr lang="en-US" sz="3000" dirty="0"/>
+          </a:p>
+        </p:txBody>
+      </p:sp>
+      <p:sp>
+        <p:nvSpPr>
+          <p:cNvPr id="3" name="Shape 1"/>
+          <p:cNvSpPr/>
+          <p:nvPr/>
+        </p:nvSpPr>
+        <p:spPr>
+          <a:xfrm>
+            <a:off x="548640" y="1371600"/>
+            <a:ext cx="3383280" cy="1554480"/>
+          </a:xfrm>
+          <a:prstGeom prst="roundRect">
+            <a:avLst>
+              <a:gd name="adj" fmla="val 7059"/>
+            </a:avLst>
+          </a:prstGeom>
+          <a:solidFill>
+            <a:srgbClr val="E5F2F0"/>
+          </a:solidFill>
+          <a:ln/>
+        </p:spPr>
+        <p:txBody>
+          <a:bodyPr/>
+          <a:p/>
+        </p:txBody>
+      </p:sp>
+      <p:sp>
+        <p:nvSpPr>
+          <p:cNvPr id="4" name="Text 2"/>
+          <p:cNvSpPr txBox="1"/>
+          <p:nvPr/>
+        </p:nvSpPr>
+        <p:spPr>
+          <a:xfrm>
+            <a:off x="777240" y="1536192"/>
+            <a:ext cx="2926080" cy="365760"/>
+          </a:xfrm>
+          <a:prstGeom prst="rect">
+            <a:avLst/>
+          </a:prstGeom>
+          <a:noFill/>
+          <a:ln/>
+        </p:spPr>
+        <p:txBody>
+          <a:bodyPr wrap="square" lIns="0" tIns="0" rIns="0" bIns="0" rtlCol="0" anchor="ctr"/>
+          <a:lstStyle/>
+          <a:p>
+            <a:pPr indent="0" marL="0">
+              <a:buNone/>
+            </a:pPr>
+            <a:r>
+              <a:rPr lang="en-US" sz="1600" b="1" dirty="0">
+                <a:solidFill>
+                  <a:srgbClr val="01485C"/>
+                </a:solidFill>
+                <a:latin typeface="Calibri" pitchFamily="34" charset="0"/>
+                <a:ea typeface="Calibri" pitchFamily="34" charset="-122"/>
+                <a:cs typeface="Calibri" pitchFamily="34" charset="-120"/>
+              </a:rPr>
+              <a:t>Issued centrally</a:t>
+            </a:r>
+            <a:endParaRPr lang="en-US" sz="1600" dirty="0"/>
+          </a:p>
+        </p:txBody>
+      </p:sp>
+      <p:sp>
+        <p:nvSpPr>
+          <p:cNvPr id="5" name="Text 3"/>
+          <p:cNvSpPr txBox="1"/>
+          <p:nvPr/>
+        </p:nvSpPr>
+        <p:spPr>
+          <a:xfrm>
+            <a:off x="777240" y="1938528"/>
+            <a:ext cx="2926080" cy="914400"/>
+          </a:xfrm>
+          <a:prstGeom prst="rect">
+            <a:avLst/>
+          </a:prstGeom>
+          <a:noFill/>
+          <a:ln/>
+        </p:spPr>
+        <p:txBody>
+          <a:bodyPr wrap="square" lIns="0" tIns="0" rIns="0" bIns="0" rtlCol="0" anchor="ctr"/>
+          <a:lstStyle/>
+          <a:p>
+            <a:pPr indent="0" marL="0">
+              <a:buNone/>
+            </a:pPr>
+            <a:r>
+              <a:rPr lang="en-US" sz="1250" dirty="0">
+                <a:solidFill>
+                  <a:srgbClr val="5F7178"/>
+                </a:solidFill>
+                <a:latin typeface="Calibri" pitchFamily="34" charset="0"/>
+                <a:ea typeface="Calibri" pitchFamily="34" charset="-122"/>
+                <a:cs typeface="Calibri" pitchFamily="34" charset="-120"/>
+              </a:rPr>
+              <a:t>Only the PoC lead’s offline keygen can sign a licence; the drive carries just the public key</a:t>
+            </a:r>
+            <a:endParaRPr lang="en-US" sz="1250" dirty="0"/>
+          </a:p>
+        </p:txBody>
+      </p:sp>
+      <p:sp>
+        <p:nvSpPr>
+          <p:cNvPr id="6" name="Shape 4"/>
+          <p:cNvSpPr/>
+          <p:nvPr/>
+        </p:nvSpPr>
+        <p:spPr>
+          <a:xfrm>
+            <a:off x="3977640" y="2148840"/>
+            <a:ext cx="320040" cy="0"/>
+          </a:xfrm>
+          <a:prstGeom prst="line">
+            <a:avLst/>
+          </a:prstGeom>
+          <a:noFill/>
+          <a:ln w="31750">
+            <a:solidFill>
+              <a:srgbClr val="01485C"/>
+            </a:solidFill>
+            <a:prstDash val="solid"/>
+            <a:tailEnd type="triangle"/>
+          </a:ln>
+        </p:spPr>
+        <p:txBody>
+          <a:bodyPr/>
+          <a:p/>
+        </p:txBody>
+      </p:sp>
+      <p:sp>
+        <p:nvSpPr>
+          <p:cNvPr id="7" name="Shape 5"/>
+          <p:cNvSpPr/>
+          <p:nvPr/>
+        </p:nvSpPr>
+        <p:spPr>
+          <a:xfrm>
+            <a:off x="4343400" y="1371600"/>
+            <a:ext cx="3383280" cy="1554480"/>
+          </a:xfrm>
+          <a:prstGeom prst="roundRect">
+            <a:avLst>
+              <a:gd name="adj" fmla="val 7059"/>
+            </a:avLst>
+          </a:prstGeom>
+          <a:solidFill>
+            <a:srgbClr val="E5F2F0"/>
+          </a:solidFill>
+          <a:ln/>
+        </p:spPr>
+        <p:txBody>
+          <a:bodyPr/>
+          <a:p/>
+        </p:txBody>
+      </p:sp>
+      <p:sp>
+        <p:nvSpPr>
+          <p:cNvPr id="8" name="Text 6"/>
+          <p:cNvSpPr txBox="1"/>
+          <p:nvPr/>
+        </p:nvSpPr>
+        <p:spPr>
+          <a:xfrm>
+            <a:off x="4572000" y="1536192"/>
+            <a:ext cx="2926080" cy="365760"/>
+          </a:xfrm>
+          <a:prstGeom prst="rect">
+            <a:avLst/>
+          </a:prstGeom>
+          <a:noFill/>
+          <a:ln/>
+        </p:spPr>
+        <p:txBody>
+          <a:bodyPr wrap="square" lIns="0" tIns="0" rIns="0" bIns="0" rtlCol="0" anchor="ctr"/>
+          <a:lstStyle/>
+          <a:p>
+            <a:pPr indent="0" marL="0">
+              <a:buNone/>
+            </a:pPr>
+            <a:r>
+              <a:rPr lang="en-US" sz="1600" b="1" dirty="0">
+                <a:solidFill>
+                  <a:srgbClr val="01485C"/>
+                </a:solidFill>
+                <a:latin typeface="Calibri" pitchFamily="34" charset="0"/>
+                <a:ea typeface="Calibri" pitchFamily="34" charset="-122"/>
+                <a:cs typeface="Calibri" pitchFamily="34" charset="-120"/>
+              </a:rPr>
+              <a:t>Bound to the motherboard</a:t>
+            </a:r>
+            <a:endParaRPr lang="en-US" sz="1600" dirty="0"/>
+          </a:p>
+        </p:txBody>
+      </p:sp>
+      <p:sp>
+        <p:nvSpPr>
+          <p:cNvPr id="9" name="Text 7"/>
+          <p:cNvSpPr txBox="1"/>
+          <p:nvPr/>
+        </p:nvSpPr>
+        <p:spPr>
+          <a:xfrm>
+            <a:off x="4572000" y="1938528"/>
+            <a:ext cx="2926080" cy="914400"/>
+          </a:xfrm>
+          <a:prstGeom prst="rect">
+            <a:avLst/>
+          </a:prstGeom>
+          <a:noFill/>
+          <a:ln/>
+        </p:spPr>
+        <p:txBody>
+          <a:bodyPr wrap="square" lIns="0" tIns="0" rIns="0" bIns="0" rtlCol="0" anchor="ctr"/>
+          <a:lstStyle/>
+          <a:p>
+            <a:pPr indent="0" marL="0">
+              <a:buNone/>
+            </a:pPr>
+            <a:r>
+              <a:rPr lang="en-US" sz="1250" dirty="0">
+                <a:solidFill>
+                  <a:srgbClr val="5F7178"/>
+                </a:solidFill>
+                <a:latin typeface="Calibri" pitchFamily="34" charset="0"/>
+                <a:ea typeface="Calibri" pitchFamily="34" charset="-122"/>
+                <a:cs typeface="Calibri" pitchFamily="34" charset="-120"/>
+              </a:rPr>
+              <a:t>ID = hash of system UUID, board serial, drive serial and hostname — a copied drive stays locked elsewhere</a:t>
+            </a:r>
+            <a:endParaRPr lang="en-US" sz="1250" dirty="0"/>
+          </a:p>
+        </p:txBody>
+      </p:sp>
+      <p:sp>
+        <p:nvSpPr>
+          <p:cNvPr id="10" name="Shape 8"/>
+          <p:cNvSpPr/>
+          <p:nvPr/>
+        </p:nvSpPr>
+        <p:spPr>
+          <a:xfrm>
+            <a:off x="7772400" y="2148840"/>
+            <a:ext cx="320040" cy="0"/>
+          </a:xfrm>
+          <a:prstGeom prst="line">
+            <a:avLst/>
+          </a:prstGeom>
+          <a:noFill/>
+          <a:ln w="31750">
+            <a:solidFill>
+              <a:srgbClr val="01485C"/>
+            </a:solidFill>
+            <a:prstDash val="solid"/>
+            <a:tailEnd type="triangle"/>
+          </a:ln>
+        </p:spPr>
+        <p:txBody>
+          <a:bodyPr/>
+          <a:p/>
+        </p:txBody>
+      </p:sp>
+      <p:sp>
+        <p:nvSpPr>
+          <p:cNvPr id="11" name="Shape 9"/>
+          <p:cNvSpPr/>
+          <p:nvPr/>
+        </p:nvSpPr>
+        <p:spPr>
+          <a:xfrm>
+            <a:off x="8138160" y="1371600"/>
+            <a:ext cx="3383280" cy="1554480"/>
+          </a:xfrm>
+          <a:prstGeom prst="roundRect">
+            <a:avLst>
+              <a:gd name="adj" fmla="val 7059"/>
+            </a:avLst>
+          </a:prstGeom>
+          <a:solidFill>
+            <a:srgbClr val="01485C"/>
+          </a:solidFill>
+          <a:ln/>
+        </p:spPr>
+        <p:txBody>
+          <a:bodyPr/>
+          <a:p/>
+        </p:txBody>
+      </p:sp>
+      <p:sp>
+        <p:nvSpPr>
+          <p:cNvPr id="12" name="Text 10"/>
+          <p:cNvSpPr txBox="1"/>
+          <p:nvPr/>
+        </p:nvSpPr>
+        <p:spPr>
+          <a:xfrm>
+            <a:off x="8366760" y="1536192"/>
+            <a:ext cx="2926080" cy="365760"/>
+          </a:xfrm>
+          <a:prstGeom prst="rect">
+            <a:avLst/>
+          </a:prstGeom>
+          <a:noFill/>
+          <a:ln/>
+        </p:spPr>
+        <p:txBody>
+          <a:bodyPr wrap="square" lIns="0" tIns="0" rIns="0" bIns="0" rtlCol="0" anchor="ctr"/>
+          <a:lstStyle/>
+          <a:p>
+            <a:pPr indent="0" marL="0">
+              <a:buNone/>
+            </a:pPr>
+            <a:r>
+              <a:rPr lang="en-US" sz="1600" b="1" dirty="0">
+                <a:solidFill>
+                  <a:srgbClr val="FFFFFF"/>
+                </a:solidFill>
+                <a:latin typeface="Calibri" pitchFamily="34" charset="0"/>
+                <a:ea typeface="Calibri" pitchFamily="34" charset="-122"/>
+                <a:cs typeface="Calibri" pitchFamily="34" charset="-120"/>
+              </a:rPr>
+              <a:t>12-month QIS term</a:t>
+            </a:r>
+            <a:endParaRPr lang="en-US" sz="1600" dirty="0"/>
+          </a:p>
+        </p:txBody>
+      </p:sp>
+      <p:sp>
+        <p:nvSpPr>
+          <p:cNvPr id="13" name="Text 11"/>
+          <p:cNvSpPr txBox="1"/>
+          <p:nvPr/>
+        </p:nvSpPr>
+        <p:spPr>
+          <a:xfrm>
+            <a:off x="8366760" y="1938528"/>
+            <a:ext cx="2926080" cy="914400"/>
+          </a:xfrm>
+          <a:prstGeom prst="rect">
+            <a:avLst/>
+          </a:prstGeom>
+          <a:noFill/>
+          <a:ln/>
+        </p:spPr>
+        <p:txBody>
+          <a:bodyPr wrap="square" lIns="0" tIns="0" rIns="0" bIns="0" rtlCol="0" anchor="ctr"/>
+          <a:lstStyle/>
+          <a:p>
+            <a:pPr indent="0" marL="0">
+              <a:buNone/>
+            </a:pPr>
+            <a:r>
+              <a:rPr lang="en-US" sz="1250" dirty="0">
+                <a:solidFill>
+                  <a:srgbClr val="6CCAD4"/>
+                </a:solidFill>
+                <a:latin typeface="Calibri" pitchFamily="34" charset="0"/>
+                <a:ea typeface="Calibri" pitchFamily="34" charset="-122"/>
+                <a:cs typeface="Calibri" pitchFamily="34" charset="-120"/>
+              </a:rPr>
+              <a:t>Each licence names the newest bundle it covers; a review means a new version and re-issued licences</a:t>
+            </a:r>
+            <a:endParaRPr lang="en-US" sz="1250" dirty="0"/>
+          </a:p>
+        </p:txBody>
+      </p:sp>
+      <p:sp>
+        <p:nvSpPr>
+          <p:cNvPr id="14" name="Text 12"/>
+          <p:cNvSpPr txBox="1"/>
+          <p:nvPr/>
+        </p:nvSpPr>
+        <p:spPr>
+          <a:xfrm>
+            <a:off x="548640" y="3383280"/>
+            <a:ext cx="6949440" cy="411480"/>
+          </a:xfrm>
+          <a:prstGeom prst="rect">
+            <a:avLst/>
+          </a:prstGeom>
+          <a:noFill/>
+          <a:ln/>
+        </p:spPr>
+        <p:txBody>
+          <a:bodyPr wrap="square" lIns="0" tIns="0" rIns="0" bIns="0" rtlCol="0" anchor="ctr"/>
+          <a:lstStyle/>
+          <a:p>
+            <a:pPr indent="0" marL="0">
+              <a:buNone/>
+            </a:pPr>
+            <a:r>
+              <a:rPr lang="en-US" sz="1400" b="1" dirty="0">
+                <a:solidFill>
+                  <a:srgbClr val="01485C"/>
+                </a:solidFill>
+                <a:latin typeface="Calibri" pitchFamily="34" charset="0"/>
+                <a:ea typeface="Calibri" pitchFamily="34" charset="-122"/>
+                <a:cs typeface="Calibri" pitchFamily="34" charset="-120"/>
+              </a:rPr>
+              <a:t>Licence file   </a:t>
+            </a:r>
+            <a:pPr indent="0" marL="0">
+              <a:buNone/>
+            </a:pPr>
+            <a:r>
+              <a:rPr lang="en-US" sz="1400" dirty="0">
+                <a:solidFill>
+                  <a:srgbClr val="17272E"/>
+                </a:solidFill>
+                <a:latin typeface="Calibri" pitchFamily="34" charset="0"/>
+                <a:ea typeface="Calibri" pitchFamily="34" charset="-122"/>
+                <a:cs typeface="Calibri" pitchFamily="34" charset="-120"/>
+              </a:rPr>
+              <a:t>Signed JSON (Ed25519): site, machine IDs, seat cap, expiry, max version — edits are refused</a:t>
+            </a:r>
+            <a:endParaRPr lang="en-US" sz="1400" dirty="0"/>
+          </a:p>
+        </p:txBody>
+      </p:sp>
+      <p:sp>
+        <p:nvSpPr>
+          <p:cNvPr id="15" name="Text 13"/>
+          <p:cNvSpPr txBox="1"/>
+          <p:nvPr/>
+        </p:nvSpPr>
+        <p:spPr>
+          <a:xfrm>
+            <a:off x="548640" y="3858768"/>
+            <a:ext cx="6949440" cy="411480"/>
+          </a:xfrm>
+          <a:prstGeom prst="rect">
+            <a:avLst/>
+          </a:prstGeom>
+          <a:noFill/>
+          <a:ln/>
+        </p:spPr>
+        <p:txBody>
+          <a:bodyPr wrap="square" lIns="0" tIns="0" rIns="0" bIns="0" rtlCol="0" anchor="ctr"/>
+          <a:lstStyle/>
+          <a:p>
+            <a:pPr indent="0" marL="0">
+              <a:buNone/>
+            </a:pPr>
+            <a:r>
+              <a:rPr lang="en-US" sz="1400" b="1" dirty="0">
+                <a:solidFill>
+                  <a:srgbClr val="01485C"/>
+                </a:solidFill>
+                <a:latin typeface="Calibri" pitchFamily="34" charset="0"/>
+                <a:ea typeface="Calibri" pitchFamily="34" charset="-122"/>
+                <a:cs typeface="Calibri" pitchFamily="34" charset="-120"/>
+              </a:rPr>
+              <a:t>Key custody   </a:t>
+            </a:r>
+            <a:pPr indent="0" marL="0">
+              <a:buNone/>
+            </a:pPr>
+            <a:r>
+              <a:rPr lang="en-US" sz="1400" dirty="0">
+                <a:solidFill>
+                  <a:srgbClr val="17272E"/>
+                </a:solidFill>
+                <a:latin typeface="Calibri" pitchFamily="34" charset="0"/>
+                <a:ea typeface="Calibri" pitchFamily="34" charset="-122"/>
+                <a:cs typeface="Calibri" pitchFamily="34" charset="-120"/>
+              </a:rPr>
+              <a:t>Private key kept off the drive (PQ_Licensing); loss means re-issuing, never a bypass</a:t>
+            </a:r>
+            <a:endParaRPr lang="en-US" sz="1400" dirty="0"/>
+          </a:p>
+        </p:txBody>
+      </p:sp>
+      <p:sp>
+        <p:nvSpPr>
+          <p:cNvPr id="16" name="Text 14"/>
+          <p:cNvSpPr txBox="1"/>
+          <p:nvPr/>
+        </p:nvSpPr>
+        <p:spPr>
+          <a:xfrm>
+            <a:off x="548640" y="4334256"/>
+            <a:ext cx="6949440" cy="411480"/>
+          </a:xfrm>
+          <a:prstGeom prst="rect">
+            <a:avLst/>
+          </a:prstGeom>
+          <a:noFill/>
+          <a:ln/>
+        </p:spPr>
+        <p:txBody>
+          <a:bodyPr wrap="square" lIns="0" tIns="0" rIns="0" bIns="0" rtlCol="0" anchor="ctr"/>
+          <a:lstStyle/>
+          <a:p>
+            <a:pPr indent="0" marL="0">
+              <a:buNone/>
+            </a:pPr>
+            <a:r>
+              <a:rPr lang="en-US" sz="1400" b="1" dirty="0">
+                <a:solidFill>
+                  <a:srgbClr val="01485C"/>
+                </a:solidFill>
+                <a:latin typeface="Calibri" pitchFamily="34" charset="0"/>
+                <a:ea typeface="Calibri" pitchFamily="34" charset="-122"/>
+                <a:cs typeface="Calibri" pitchFamily="34" charset="-120"/>
+              </a:rPr>
+              <a:t>Enforcement   </a:t>
+            </a:r>
+            <a:pPr indent="0" marL="0">
+              <a:buNone/>
+            </a:pPr>
+            <a:r>
+              <a:rPr lang="en-US" sz="1400" dirty="0">
+                <a:solidFill>
+                  <a:srgbClr val="17272E"/>
+                </a:solidFill>
+                <a:latin typeface="Calibri" pitchFamily="34" charset="0"/>
+                <a:ea typeface="Calibri" pitchFamily="34" charset="-122"/>
+                <a:cs typeface="Calibri" pitchFamily="34" charset="-120"/>
+              </a:rPr>
+              <a:t>Portal and both engines lock unless a licence covers this PC and version, in term</a:t>
+            </a:r>
+            <a:endParaRPr lang="en-US" sz="1400" dirty="0"/>
+          </a:p>
+        </p:txBody>
+      </p:sp>
+      <p:sp>
+        <p:nvSpPr>
+          <p:cNvPr id="17" name="Text 15"/>
+          <p:cNvSpPr txBox="1"/>
+          <p:nvPr/>
+        </p:nvSpPr>
+        <p:spPr>
+          <a:xfrm>
+            <a:off x="548640" y="4809744"/>
+            <a:ext cx="6949440" cy="411480"/>
+          </a:xfrm>
+          <a:prstGeom prst="rect">
+            <a:avLst/>
+          </a:prstGeom>
+          <a:noFill/>
+          <a:ln/>
+        </p:spPr>
+        <p:txBody>
+          <a:bodyPr wrap="square" lIns="0" tIns="0" rIns="0" bIns="0" rtlCol="0" anchor="ctr"/>
+          <a:lstStyle/>
+          <a:p>
+            <a:pPr indent="0" marL="0">
+              <a:buNone/>
+            </a:pPr>
+            <a:r>
+              <a:rPr lang="en-US" sz="1400" b="1" dirty="0">
+                <a:solidFill>
+                  <a:srgbClr val="01485C"/>
+                </a:solidFill>
+                <a:latin typeface="Calibri" pitchFamily="34" charset="0"/>
+                <a:ea typeface="Calibri" pitchFamily="34" charset="-122"/>
+                <a:cs typeface="Calibri" pitchFamily="34" charset="-120"/>
+              </a:rPr>
+              <a:t>Audit   </a:t>
+            </a:r>
+            <a:pPr indent="0" marL="0">
+              <a:buNone/>
+            </a:pPr>
+            <a:r>
+              <a:rPr lang="en-US" sz="1400" dirty="0">
+                <a:solidFill>
+                  <a:srgbClr val="17272E"/>
+                </a:solidFill>
+                <a:latin typeface="Calibri" pitchFamily="34" charset="0"/>
+                <a:ea typeface="Calibri" pitchFamily="34" charset="-122"/>
+                <a:cs typeface="Calibri" pitchFamily="34" charset="-120"/>
+              </a:rPr>
+              <a:t>Every launch, install and refusal with PC, user, network state; central ledger of copies</a:t>
+            </a:r>
+            <a:endParaRPr lang="en-US" sz="1400" dirty="0"/>
+          </a:p>
+        </p:txBody>
+      </p:sp>
+      <p:sp>
+        <p:nvSpPr>
+          <p:cNvPr id="18" name="Shape 16"/>
+          <p:cNvSpPr/>
+          <p:nvPr/>
+        </p:nvSpPr>
+        <p:spPr>
+          <a:xfrm>
+            <a:off x="7863840" y="3383280"/>
+            <a:ext cx="3794760" cy="2103120"/>
+          </a:xfrm>
+          <a:prstGeom prst="roundRect">
+            <a:avLst>
+              <a:gd name="adj" fmla="val 5217"/>
+            </a:avLst>
+          </a:prstGeom>
+          <a:solidFill>
+            <a:srgbClr val="FDF0E4"/>
+          </a:solidFill>
+          <a:ln w="19050">
+            <a:solidFill>
+              <a:srgbClr val="B4540A"/>
+            </a:solidFill>
+            <a:prstDash val="solid"/>
+          </a:ln>
+        </p:spPr>
+        <p:txBody>
+          <a:bodyPr/>
+          <a:p/>
+        </p:txBody>
+      </p:sp>
+      <p:sp>
+        <p:nvSpPr>
+          <p:cNvPr id="19" name="Shape 17"/>
+          <p:cNvSpPr/>
+          <p:nvPr/>
+        </p:nvSpPr>
+        <p:spPr>
+          <a:xfrm>
+            <a:off x="8138160" y="3611880"/>
+            <a:ext cx="640080" cy="640080"/>
+          </a:xfrm>
+          <a:prstGeom prst="ellipse">
+            <a:avLst/>
+          </a:prstGeom>
+          <a:solidFill>
+            <a:srgbClr val="B4540A"/>
+          </a:solidFill>
+          <a:ln/>
+        </p:spPr>
+        <p:txBody>
+          <a:bodyPr/>
+          <a:p/>
+        </p:txBody>
+      </p:sp>
+      <p:pic>
+        <p:nvPicPr>
+          <p:cNvPr id="20" name="Image 0" descr="icon_warn_w.png">    </p:cNvPr>
+          <p:cNvPicPr>
+            <a:picLocks noChangeAspect="1"/>
+          </p:cNvPicPr>
+          <p:nvPr/>
+        </p:nvPicPr>
+        <p:blipFill>
+          <a:blip r:embed="rId2"/>
+          <a:stretch>
+            <a:fillRect/>
+          </a:stretch>
+        </p:blipFill>
+        <p:spPr>
+          <a:xfrm>
+            <a:off x="8304581" y="3778301"/>
+            <a:ext cx="307238" cy="307238"/>
+          </a:xfrm>
+          <a:prstGeom prst="rect">
+            <a:avLst/>
+          </a:prstGeom>
+        </p:spPr>
+      </p:pic>
+      <p:sp>
+        <p:nvSpPr>
+          <p:cNvPr id="21" name="Text 18"/>
+          <p:cNvSpPr txBox="1"/>
+          <p:nvPr/>
+        </p:nvSpPr>
+        <p:spPr>
+          <a:xfrm>
+            <a:off x="8915400" y="3703320"/>
+            <a:ext cx="2651760" cy="457200"/>
+          </a:xfrm>
+          <a:prstGeom prst="rect">
+            <a:avLst/>
+          </a:prstGeom>
+          <a:noFill/>
+          <a:ln/>
+        </p:spPr>
+        <p:txBody>
+          <a:bodyPr wrap="square" lIns="0" tIns="0" rIns="0" bIns="0" rtlCol="0" anchor="ctr"/>
+          <a:lstStyle/>
+          <a:p>
+            <a:pPr indent="0" marL="0">
+              <a:buNone/>
+            </a:pPr>
+            <a:r>
+              <a:rPr lang="en-US" sz="1500" b="1" dirty="0">
+                <a:solidFill>
+                  <a:srgbClr val="B4540A"/>
+                </a:solidFill>
+                <a:latin typeface="Calibri" pitchFamily="34" charset="0"/>
+                <a:ea typeface="Calibri" pitchFamily="34" charset="-122"/>
+                <a:cs typeface="Calibri" pitchFamily="34" charset="-120"/>
+              </a:rPr>
+              <a:t>Not DRM — by design</a:t>
+            </a:r>
+            <a:endParaRPr lang="en-US" sz="1500" dirty="0"/>
+          </a:p>
+        </p:txBody>
+      </p:sp>
+      <p:sp>
+        <p:nvSpPr>
+          <p:cNvPr id="22" name="Text 19"/>
+          <p:cNvSpPr txBox="1"/>
+          <p:nvPr/>
+        </p:nvSpPr>
+        <p:spPr>
+          <a:xfrm>
+            <a:off x="8138160" y="4343400"/>
+            <a:ext cx="3291840" cy="1005840"/>
+          </a:xfrm>
+          <a:prstGeom prst="rect">
+            <a:avLst/>
+          </a:prstGeom>
+          <a:noFill/>
+          <a:ln/>
+        </p:spPr>
+        <p:txBody>
+          <a:bodyPr wrap="square" lIns="0" tIns="0" rIns="0" bIns="0" rtlCol="0" anchor="ctr"/>
+          <a:lstStyle/>
+          <a:p>
+            <a:pPr indent="0" marL="0">
+              <a:buNone/>
+            </a:pPr>
+            <a:r>
+              <a:rPr lang="en-US" sz="1250" dirty="0">
+                <a:solidFill>
+                  <a:srgbClr val="17272E"/>
+                </a:solidFill>
+                <a:latin typeface="Calibri" pitchFamily="34" charset="0"/>
+                <a:ea typeface="Calibri" pitchFamily="34" charset="-122"/>
+                <a:cs typeface="Calibri" pitchFamily="34" charset="-120"/>
+              </a:rPr>
+              <a:t>The check lives on the drive: a BitLocker holder who edits the Python could remove it. It is an administrative control with evidence and a central register, not copy protection.</a:t>
+            </a:r>
+            <a:endParaRPr lang="en-US" sz="1250" dirty="0"/>
+          </a:p>
+        </p:txBody>
+      </p:sp>
+      <p:sp>
+        <p:nvSpPr>
+          <p:cNvPr id="23" name="Shape 20"/>
+          <p:cNvSpPr/>
+          <p:nvPr/>
+        </p:nvSpPr>
+        <p:spPr>
+          <a:xfrm>
+            <a:off x="0" y="6793992"/>
+            <a:ext cx="2040636" cy="64008"/>
+          </a:xfrm>
+          <a:prstGeom prst="rect">
+            <a:avLst/>
+          </a:prstGeom>
+          <a:solidFill>
+            <a:srgbClr val="01485C"/>
+          </a:solidFill>
+          <a:ln/>
+        </p:spPr>
+      </p:sp>
+      <p:sp>
+        <p:nvSpPr>
+          <p:cNvPr id="24" name="Shape 21"/>
+          <p:cNvSpPr/>
+          <p:nvPr/>
+        </p:nvSpPr>
+        <p:spPr>
+          <a:xfrm>
+            <a:off x="2031492" y="6793992"/>
+            <a:ext cx="2040636" cy="64008"/>
+          </a:xfrm>
+          <a:prstGeom prst="rect">
+            <a:avLst/>
+          </a:prstGeom>
+          <a:solidFill>
+            <a:srgbClr val="146175"/>
+          </a:solidFill>
+          <a:ln/>
+        </p:spPr>
+      </p:sp>
+      <p:sp>
+        <p:nvSpPr>
+          <p:cNvPr id="25" name="Shape 22"/>
+          <p:cNvSpPr/>
+          <p:nvPr/>
+        </p:nvSpPr>
+        <p:spPr>
+          <a:xfrm>
+            <a:off x="4062984" y="6793992"/>
+            <a:ext cx="2040636" cy="64008"/>
+          </a:xfrm>
+          <a:prstGeom prst="rect">
+            <a:avLst/>
+          </a:prstGeom>
+          <a:solidFill>
+            <a:srgbClr val="11B5AE"/>
+          </a:solidFill>
+          <a:ln/>
+        </p:spPr>
+      </p:sp>
+      <p:sp>
+        <p:nvSpPr>
+          <p:cNvPr id="26" name="Shape 23"/>
+          <p:cNvSpPr/>
+          <p:nvPr/>
+        </p:nvSpPr>
+        <p:spPr>
+          <a:xfrm>
+            <a:off x="6094476" y="6793992"/>
+            <a:ext cx="2040636" cy="64008"/>
+          </a:xfrm>
+          <a:prstGeom prst="rect">
+            <a:avLst/>
+          </a:prstGeom>
+          <a:solidFill>
+            <a:srgbClr val="6CCAD4"/>
+          </a:solidFill>
+          <a:ln/>
+        </p:spPr>
+      </p:sp>
+      <p:sp>
+        <p:nvSpPr>
+          <p:cNvPr id="27" name="Shape 24"/>
+          <p:cNvSpPr/>
+          <p:nvPr/>
+        </p:nvSpPr>
+        <p:spPr>
+          <a:xfrm>
+            <a:off x="8125968" y="6793992"/>
+            <a:ext cx="2040636" cy="64008"/>
+          </a:xfrm>
+          <a:prstGeom prst="rect">
+            <a:avLst/>
+          </a:prstGeom>
+          <a:solidFill>
+            <a:srgbClr val="7FC04C"/>
+          </a:solidFill>
+          <a:ln/>
+        </p:spPr>
+      </p:sp>
+      <p:sp>
+        <p:nvSpPr>
+          <p:cNvPr id="28" name="Shape 25"/>
+          <p:cNvSpPr/>
+          <p:nvPr/>
+        </p:nvSpPr>
+        <p:spPr>
+          <a:xfrm>
+            <a:off x="10157460" y="6793992"/>
+            <a:ext cx="2040636" cy="64008"/>
+          </a:xfrm>
+          <a:prstGeom prst="rect">
+            <a:avLst/>
+          </a:prstGeom>
+          <a:solidFill>
+            <a:srgbClr val="E1DD57"/>
+          </a:solidFill>
+          <a:ln/>
+        </p:spPr>
+      </p:sp>
+    </p:spTree>
+  </p:cSld>
+  <p:clrMapOvr>
+    <a:masterClrMapping/>
+  </p:clrMapOvr>
+</p:sld>
+</file>
+
+<file path=ppt/slides/slide9.xml><?xml version="1.0" encoding="utf-8"?>
 <p:sld xmlns:a="http://schemas.openxmlformats.org/drawingml/2006/main" xmlns:r="http://schemas.openxmlformats.org/officeDocument/2006/relationships" xmlns:p="http://schemas.openxmlformats.org/presentationml/2006/main">
   <p:cSld name="Slide 8">
     <p:bg>
@@ -12651,668 +13349,6 @@
       <p:sp>
         <p:nvSpPr>
           <p:cNvPr id="38" name="Shape 30"/>
-          <p:cNvSpPr/>
-          <p:nvPr/>
-        </p:nvSpPr>
-        <p:spPr>
-          <a:xfrm>
-            <a:off x="10157460" y="6793992"/>
-            <a:ext cx="2040636" cy="64008"/>
-          </a:xfrm>
-          <a:prstGeom prst="rect">
-            <a:avLst/>
-          </a:prstGeom>
-          <a:solidFill>
-            <a:srgbClr val="E1DD57"/>
-          </a:solidFill>
-          <a:ln/>
-        </p:spPr>
-      </p:sp>
-    </p:spTree>
-  </p:cSld>
-  <p:clrMapOvr>
-    <a:masterClrMapping/>
-  </p:clrMapOvr>
-</p:sld>
-</file>
-
-<file path=ppt/slides/slide9.xml><?xml version="1.0" encoding="utf-8"?>
-<p:sld xmlns:a="http://schemas.openxmlformats.org/drawingml/2006/main" xmlns:r="http://schemas.openxmlformats.org/officeDocument/2006/relationships" xmlns:p="http://schemas.openxmlformats.org/presentationml/2006/main">
-  <p:cSld name="Slide 9">
-    <p:bg>
-      <p:bgPr>
-        <a:solidFill>
-          <a:srgbClr val="FFFFFF"/>
-        </a:solidFill>
-      </p:bgPr>
-    </p:bg>
-    <p:spTree>
-      <p:nvGrpSpPr>
-        <p:cNvPr id="1" name=""/>
-        <p:cNvGrpSpPr/>
-        <p:nvPr/>
-      </p:nvGrpSpPr>
-      <p:grpSpPr>
-        <a:xfrm>
-          <a:off x="0" y="0"/>
-          <a:ext cx="0" cy="0"/>
-          <a:chOff x="0" y="0"/>
-          <a:chExt cx="0" cy="0"/>
-        </a:xfrm>
-      </p:grpSpPr>
-      <p:sp>
-        <p:nvSpPr>
-          <p:cNvPr id="2" name="Text 0"/>
-          <p:cNvSpPr txBox="1"/>
-          <p:nvPr/>
-        </p:nvSpPr>
-        <p:spPr>
-          <a:xfrm>
-            <a:off x="548640" y="320040"/>
-            <a:ext cx="11064240" cy="685800"/>
-          </a:xfrm>
-          <a:prstGeom prst="rect">
-            <a:avLst/>
-          </a:prstGeom>
-          <a:noFill/>
-          <a:ln/>
-        </p:spPr>
-        <p:txBody>
-          <a:bodyPr wrap="square" lIns="0" tIns="0" rIns="0" bIns="0" rtlCol="0" anchor="ctr"/>
-          <a:lstStyle/>
-          <a:p>
-            <a:pPr algn="l" indent="0" marL="0">
-              <a:buNone/>
-            </a:pPr>
-            <a:r>
-              <a:rPr lang="en-US" sz="3000" b="1" dirty="0">
-                <a:solidFill>
-                  <a:srgbClr val="01485C"/>
-                </a:solidFill>
-                <a:latin typeface="Calibri" pitchFamily="34" charset="0"/>
-                <a:ea typeface="Calibri" pitchFamily="34" charset="-122"/>
-                <a:cs typeface="Calibri" pitchFamily="34" charset="-120"/>
-              </a:rPr>
-              <a:t>Audit &amp; accountability</a:t>
-            </a:r>
-            <a:endParaRPr lang="en-US" sz="3000" dirty="0"/>
-          </a:p>
-        </p:txBody>
-      </p:sp>
-      <p:sp>
-        <p:nvSpPr>
-          <p:cNvPr id="3" name="Shape 1"/>
-          <p:cNvSpPr/>
-          <p:nvPr/>
-        </p:nvSpPr>
-        <p:spPr>
-          <a:xfrm>
-            <a:off x="548640" y="1463040"/>
-            <a:ext cx="3611880" cy="3108960"/>
-          </a:xfrm>
-          <a:prstGeom prst="roundRect">
-            <a:avLst>
-              <a:gd name="adj" fmla="val 3529"/>
-            </a:avLst>
-          </a:prstGeom>
-          <a:solidFill>
-            <a:srgbClr val="E5F2F0"/>
-          </a:solidFill>
-          <a:ln/>
-        </p:spPr>
-      </p:sp>
-      <p:sp>
-        <p:nvSpPr>
-          <p:cNvPr id="4" name="Shape 2"/>
-          <p:cNvSpPr/>
-          <p:nvPr/>
-        </p:nvSpPr>
-        <p:spPr>
-          <a:xfrm>
-            <a:off x="822960" y="1755648"/>
-            <a:ext cx="658368" cy="658368"/>
-          </a:xfrm>
-          <a:prstGeom prst="ellipse">
-            <a:avLst/>
-          </a:prstGeom>
-          <a:solidFill>
-            <a:srgbClr val="01485C"/>
-          </a:solidFill>
-          <a:ln/>
-        </p:spPr>
-      </p:sp>
-      <p:pic>
-        <p:nvPicPr>
-          <p:cNvPr id="5" name="Image 0" descr="icon_clipboard_w.png">    </p:cNvPr>
-          <p:cNvPicPr>
-            <a:picLocks noChangeAspect="1"/>
-          </p:cNvPicPr>
-          <p:nvPr/>
-        </p:nvPicPr>
-        <p:blipFill>
-          <a:blip r:embed="rId1"/>
-          <a:stretch>
-            <a:fillRect/>
-          </a:stretch>
-        </p:blipFill>
-        <p:spPr>
-          <a:xfrm>
-            <a:off x="994136" y="1926824"/>
-            <a:ext cx="316017" cy="316017"/>
-          </a:xfrm>
-          <a:prstGeom prst="rect">
-            <a:avLst/>
-          </a:prstGeom>
-        </p:spPr>
-      </p:pic>
-      <p:sp>
-        <p:nvSpPr>
-          <p:cNvPr id="6" name="Text 3"/>
-          <p:cNvSpPr txBox="1"/>
-          <p:nvPr/>
-        </p:nvSpPr>
-        <p:spPr>
-          <a:xfrm>
-            <a:off x="822960" y="2606040"/>
-            <a:ext cx="3063240" cy="457200"/>
-          </a:xfrm>
-          <a:prstGeom prst="rect">
-            <a:avLst/>
-          </a:prstGeom>
-          <a:noFill/>
-          <a:ln/>
-        </p:spPr>
-        <p:txBody>
-          <a:bodyPr wrap="square" lIns="0" tIns="0" rIns="0" bIns="0" rtlCol="0" anchor="ctr"/>
-          <a:lstStyle/>
-          <a:p>
-            <a:pPr indent="0" marL="0">
-              <a:buNone/>
-            </a:pPr>
-            <a:r>
-              <a:rPr lang="en-US" sz="1600" b="1" dirty="0">
-                <a:solidFill>
-                  <a:srgbClr val="01485C"/>
-                </a:solidFill>
-                <a:latin typeface="Calibri" pitchFamily="34" charset="0"/>
-                <a:ea typeface="Calibri" pitchFamily="34" charset="-122"/>
-                <a:cs typeface="Calibri" pitchFamily="34" charset="-120"/>
-              </a:rPr>
-              <a:t>audit.log</a:t>
-            </a:r>
-            <a:endParaRPr lang="en-US" sz="1600" dirty="0"/>
-          </a:p>
-        </p:txBody>
-      </p:sp>
-      <p:sp>
-        <p:nvSpPr>
-          <p:cNvPr id="7" name="Text 4"/>
-          <p:cNvSpPr txBox="1"/>
-          <p:nvPr/>
-        </p:nvSpPr>
-        <p:spPr>
-          <a:xfrm>
-            <a:off x="822960" y="3108960"/>
-            <a:ext cx="3063240" cy="1371600"/>
-          </a:xfrm>
-          <a:prstGeom prst="rect">
-            <a:avLst/>
-          </a:prstGeom>
-          <a:noFill/>
-          <a:ln/>
-        </p:spPr>
-        <p:txBody>
-          <a:bodyPr wrap="square" lIns="0" tIns="0" rIns="0" bIns="0" rtlCol="0" anchor="ctr"/>
-          <a:lstStyle/>
-          <a:p>
-            <a:pPr indent="0" marL="0">
-              <a:buNone/>
-            </a:pPr>
-            <a:r>
-              <a:rPr lang="en-US" sz="1250" dirty="0">
-                <a:solidFill>
-                  <a:srgbClr val="17272E"/>
-                </a:solidFill>
-                <a:latin typeface="Calibri" pitchFamily="34" charset="0"/>
-                <a:ea typeface="Calibri" pitchFamily="34" charset="-122"/>
-                <a:cs typeface="Calibri" pitchFamily="34" charset="-120"/>
-              </a:rPr>
-              <a:t>Every report generation: timestamp, Windows username, period, scope — plus every history unlock attempt, including failures</a:t>
-            </a:r>
-            <a:endParaRPr lang="en-US" sz="1250" dirty="0"/>
-          </a:p>
-        </p:txBody>
-      </p:sp>
-      <p:sp>
-        <p:nvSpPr>
-          <p:cNvPr id="8" name="Shape 5"/>
-          <p:cNvSpPr/>
-          <p:nvPr/>
-        </p:nvSpPr>
-        <p:spPr>
-          <a:xfrm>
-            <a:off x="4370832" y="1463040"/>
-            <a:ext cx="3611880" cy="3108960"/>
-          </a:xfrm>
-          <a:prstGeom prst="roundRect">
-            <a:avLst>
-              <a:gd name="adj" fmla="val 3529"/>
-            </a:avLst>
-          </a:prstGeom>
-          <a:solidFill>
-            <a:srgbClr val="E5F2F0"/>
-          </a:solidFill>
-          <a:ln/>
-        </p:spPr>
-      </p:sp>
-      <p:sp>
-        <p:nvSpPr>
-          <p:cNvPr id="9" name="Shape 6"/>
-          <p:cNvSpPr/>
-          <p:nvPr/>
-        </p:nvSpPr>
-        <p:spPr>
-          <a:xfrm>
-            <a:off x="4645152" y="1755648"/>
-            <a:ext cx="658368" cy="658368"/>
-          </a:xfrm>
-          <a:prstGeom prst="ellipse">
-            <a:avLst/>
-          </a:prstGeom>
-          <a:solidFill>
-            <a:srgbClr val="01485C"/>
-          </a:solidFill>
-          <a:ln/>
-        </p:spPr>
-      </p:sp>
-      <p:pic>
-        <p:nvPicPr>
-          <p:cNvPr id="10" name="Image 1" descr="icon_clipboard_w.png">    </p:cNvPr>
-          <p:cNvPicPr>
-            <a:picLocks noChangeAspect="1"/>
-          </p:cNvPicPr>
-          <p:nvPr/>
-        </p:nvPicPr>
-        <p:blipFill>
-          <a:blip r:embed="rId2"/>
-          <a:stretch>
-            <a:fillRect/>
-          </a:stretch>
-        </p:blipFill>
-        <p:spPr>
-          <a:xfrm>
-            <a:off x="4816328" y="1926824"/>
-            <a:ext cx="316017" cy="316017"/>
-          </a:xfrm>
-          <a:prstGeom prst="rect">
-            <a:avLst/>
-          </a:prstGeom>
-        </p:spPr>
-      </p:pic>
-      <p:sp>
-        <p:nvSpPr>
-          <p:cNvPr id="11" name="Text 7"/>
-          <p:cNvSpPr txBox="1"/>
-          <p:nvPr/>
-        </p:nvSpPr>
-        <p:spPr>
-          <a:xfrm>
-            <a:off x="4645152" y="2606040"/>
-            <a:ext cx="3063240" cy="457200"/>
-          </a:xfrm>
-          <a:prstGeom prst="rect">
-            <a:avLst/>
-          </a:prstGeom>
-          <a:noFill/>
-          <a:ln/>
-        </p:spPr>
-        <p:txBody>
-          <a:bodyPr wrap="square" lIns="0" tIns="0" rIns="0" bIns="0" rtlCol="0" anchor="ctr"/>
-          <a:lstStyle/>
-          <a:p>
-            <a:pPr indent="0" marL="0">
-              <a:buNone/>
-            </a:pPr>
-            <a:r>
-              <a:rPr lang="en-US" sz="1600" b="1" dirty="0">
-                <a:solidFill>
-                  <a:srgbClr val="01485C"/>
-                </a:solidFill>
-                <a:latin typeface="Calibri" pitchFamily="34" charset="0"/>
-                <a:ea typeface="Calibri" pitchFamily="34" charset="-122"/>
-                <a:cs typeface="Calibri" pitchFamily="34" charset="-120"/>
-              </a:rPr>
-              <a:t>Network audit logs</a:t>
-            </a:r>
-            <a:endParaRPr lang="en-US" sz="1600" dirty="0"/>
-          </a:p>
-        </p:txBody>
-      </p:sp>
-      <p:sp>
-        <p:nvSpPr>
-          <p:cNvPr id="12" name="Text 8"/>
-          <p:cNvSpPr txBox="1"/>
-          <p:nvPr/>
-        </p:nvSpPr>
-        <p:spPr>
-          <a:xfrm>
-            <a:off x="4645152" y="3108960"/>
-            <a:ext cx="3063240" cy="1371600"/>
-          </a:xfrm>
-          <a:prstGeom prst="rect">
-            <a:avLst/>
-          </a:prstGeom>
-          <a:noFill/>
-          <a:ln/>
-        </p:spPr>
-        <p:txBody>
-          <a:bodyPr wrap="square" lIns="0" tIns="0" rIns="0" bIns="0" rtlCol="0" anchor="ctr"/>
-          <a:lstStyle/>
-          <a:p>
-            <a:pPr indent="0" marL="0">
-              <a:buNone/>
-            </a:pPr>
-            <a:r>
-              <a:rPr lang="en-US" sz="1250" dirty="0">
-                <a:solidFill>
-                  <a:srgbClr val="17272E"/>
-                </a:solidFill>
-                <a:latin typeface="Calibri" pitchFamily="34" charset="0"/>
-                <a:ea typeface="Calibri" pitchFamily="34" charset="-122"/>
-                <a:cs typeface="Calibri" pitchFamily="34" charset="-120"/>
-              </a:rPr>
-              <a:t>The guard’s record: activation lines under normal use; any outbound attempt would appear as BLOCKED with the destination</a:t>
-            </a:r>
-            <a:endParaRPr lang="en-US" sz="1250" dirty="0"/>
-          </a:p>
-        </p:txBody>
-      </p:sp>
-      <p:sp>
-        <p:nvSpPr>
-          <p:cNvPr id="13" name="Shape 9"/>
-          <p:cNvSpPr/>
-          <p:nvPr/>
-        </p:nvSpPr>
-        <p:spPr>
-          <a:xfrm>
-            <a:off x="8193024" y="1463040"/>
-            <a:ext cx="3611880" cy="3108960"/>
-          </a:xfrm>
-          <a:prstGeom prst="roundRect">
-            <a:avLst>
-              <a:gd name="adj" fmla="val 3529"/>
-            </a:avLst>
-          </a:prstGeom>
-          <a:solidFill>
-            <a:srgbClr val="E5F2F0"/>
-          </a:solidFill>
-          <a:ln/>
-        </p:spPr>
-      </p:sp>
-      <p:sp>
-        <p:nvSpPr>
-          <p:cNvPr id="14" name="Shape 10"/>
-          <p:cNvSpPr/>
-          <p:nvPr/>
-        </p:nvSpPr>
-        <p:spPr>
-          <a:xfrm>
-            <a:off x="8467344" y="1755648"/>
-            <a:ext cx="658368" cy="658368"/>
-          </a:xfrm>
-          <a:prstGeom prst="ellipse">
-            <a:avLst/>
-          </a:prstGeom>
-          <a:solidFill>
-            <a:srgbClr val="01485C"/>
-          </a:solidFill>
-          <a:ln/>
-        </p:spPr>
-      </p:sp>
-      <p:pic>
-        <p:nvPicPr>
-          <p:cNvPr id="15" name="Image 2" descr="icon_clipboard_w.png">    </p:cNvPr>
-          <p:cNvPicPr>
-            <a:picLocks noChangeAspect="1"/>
-          </p:cNvPicPr>
-          <p:nvPr/>
-        </p:nvPicPr>
-        <p:blipFill>
-          <a:blip r:embed="rId3"/>
-          <a:stretch>
-            <a:fillRect/>
-          </a:stretch>
-        </p:blipFill>
-        <p:spPr>
-          <a:xfrm>
-            <a:off x="8638520" y="1926824"/>
-            <a:ext cx="316017" cy="316017"/>
-          </a:xfrm>
-          <a:prstGeom prst="rect">
-            <a:avLst/>
-          </a:prstGeom>
-        </p:spPr>
-      </p:pic>
-      <p:sp>
-        <p:nvSpPr>
-          <p:cNvPr id="16" name="Text 11"/>
-          <p:cNvSpPr txBox="1"/>
-          <p:nvPr/>
-        </p:nvSpPr>
-        <p:spPr>
-          <a:xfrm>
-            <a:off x="8467344" y="2606040"/>
-            <a:ext cx="3063240" cy="457200"/>
-          </a:xfrm>
-          <a:prstGeom prst="rect">
-            <a:avLst/>
-          </a:prstGeom>
-          <a:noFill/>
-          <a:ln/>
-        </p:spPr>
-        <p:txBody>
-          <a:bodyPr wrap="square" lIns="0" tIns="0" rIns="0" bIns="0" rtlCol="0" anchor="ctr"/>
-          <a:lstStyle/>
-          <a:p>
-            <a:pPr indent="0" marL="0">
-              <a:buNone/>
-            </a:pPr>
-            <a:r>
-              <a:rPr lang="en-US" sz="1600" b="1" dirty="0">
-                <a:solidFill>
-                  <a:srgbClr val="01485C"/>
-                </a:solidFill>
-                <a:latin typeface="Calibri" pitchFamily="34" charset="0"/>
-                <a:ea typeface="Calibri" pitchFamily="34" charset="-122"/>
-                <a:cs typeface="Calibri" pitchFamily="34" charset="-120"/>
-              </a:rPr>
-              <a:t>Human-readable, on-device</a:t>
-            </a:r>
-            <a:endParaRPr lang="en-US" sz="1600" dirty="0"/>
-          </a:p>
-        </p:txBody>
-      </p:sp>
-      <p:sp>
-        <p:nvSpPr>
-          <p:cNvPr id="17" name="Text 12"/>
-          <p:cNvSpPr txBox="1"/>
-          <p:nvPr/>
-        </p:nvSpPr>
-        <p:spPr>
-          <a:xfrm>
-            <a:off x="8467344" y="3108960"/>
-            <a:ext cx="3063240" cy="1371600"/>
-          </a:xfrm>
-          <a:prstGeom prst="rect">
-            <a:avLst/>
-          </a:prstGeom>
-          <a:noFill/>
-          <a:ln/>
-        </p:spPr>
-        <p:txBody>
-          <a:bodyPr wrap="square" lIns="0" tIns="0" rIns="0" bIns="0" rtlCol="0" anchor="ctr"/>
-          <a:lstStyle/>
-          <a:p>
-            <a:pPr indent="0" marL="0">
-              <a:buNone/>
-            </a:pPr>
-            <a:r>
-              <a:rPr lang="en-US" sz="1250" dirty="0">
-                <a:solidFill>
-                  <a:srgbClr val="17272E"/>
-                </a:solidFill>
-                <a:latin typeface="Calibri" pitchFamily="34" charset="0"/>
-                <a:ea typeface="Calibri" pitchFamily="34" charset="-122"/>
-                <a:cs typeface="Calibri" pitchFamily="34" charset="-120"/>
-              </a:rPr>
-              <a:t>Plain text on the drive — reviewable by any auditor without tooling, tied to OS usernames</a:t>
-            </a:r>
-            <a:endParaRPr lang="en-US" sz="1250" dirty="0"/>
-          </a:p>
-        </p:txBody>
-      </p:sp>
-      <p:sp>
-        <p:nvSpPr>
-          <p:cNvPr id="18" name="Text 13"/>
-          <p:cNvSpPr txBox="1"/>
-          <p:nvPr/>
-        </p:nvSpPr>
-        <p:spPr>
-          <a:xfrm>
-            <a:off x="548640" y="5029200"/>
-            <a:ext cx="11064240" cy="457200"/>
-          </a:xfrm>
-          <a:prstGeom prst="rect">
-            <a:avLst/>
-          </a:prstGeom>
-          <a:noFill/>
-          <a:ln/>
-        </p:spPr>
-        <p:txBody>
-          <a:bodyPr wrap="square" lIns="0" tIns="0" rIns="0" bIns="0" rtlCol="0" anchor="ctr"/>
-          <a:lstStyle/>
-          <a:p>
-            <a:pPr indent="0" marL="0">
-              <a:buNone/>
-            </a:pPr>
-            <a:r>
-              <a:rPr lang="en-US" sz="1400" i="1" dirty="0">
-                <a:solidFill>
-                  <a:srgbClr val="5F7178"/>
-                </a:solidFill>
-                <a:latin typeface="Calibri" pitchFamily="34" charset="0"/>
-                <a:ea typeface="Calibri" pitchFamily="34" charset="-122"/>
-                <a:cs typeface="Calibri" pitchFamily="34" charset="-120"/>
-              </a:rPr>
-              <a:t>Failed password attempts are recorded — repeated failures on a found drive leave evidence.</a:t>
-            </a:r>
-            <a:endParaRPr lang="en-US" sz="1400" dirty="0"/>
-          </a:p>
-        </p:txBody>
-      </p:sp>
-      <p:sp>
-        <p:nvSpPr>
-          <p:cNvPr id="19" name="Shape 14"/>
-          <p:cNvSpPr/>
-          <p:nvPr/>
-        </p:nvSpPr>
-        <p:spPr>
-          <a:xfrm>
-            <a:off x="0" y="6793992"/>
-            <a:ext cx="2040636" cy="64008"/>
-          </a:xfrm>
-          <a:prstGeom prst="rect">
-            <a:avLst/>
-          </a:prstGeom>
-          <a:solidFill>
-            <a:srgbClr val="01485C"/>
-          </a:solidFill>
-          <a:ln/>
-        </p:spPr>
-      </p:sp>
-      <p:sp>
-        <p:nvSpPr>
-          <p:cNvPr id="20" name="Shape 15"/>
-          <p:cNvSpPr/>
-          <p:nvPr/>
-        </p:nvSpPr>
-        <p:spPr>
-          <a:xfrm>
-            <a:off x="2031492" y="6793992"/>
-            <a:ext cx="2040636" cy="64008"/>
-          </a:xfrm>
-          <a:prstGeom prst="rect">
-            <a:avLst/>
-          </a:prstGeom>
-          <a:solidFill>
-            <a:srgbClr val="146175"/>
-          </a:solidFill>
-          <a:ln/>
-        </p:spPr>
-      </p:sp>
-      <p:sp>
-        <p:nvSpPr>
-          <p:cNvPr id="21" name="Shape 16"/>
-          <p:cNvSpPr/>
-          <p:nvPr/>
-        </p:nvSpPr>
-        <p:spPr>
-          <a:xfrm>
-            <a:off x="4062984" y="6793992"/>
-            <a:ext cx="2040636" cy="64008"/>
-          </a:xfrm>
-          <a:prstGeom prst="rect">
-            <a:avLst/>
-          </a:prstGeom>
-          <a:solidFill>
-            <a:srgbClr val="11B5AE"/>
-          </a:solidFill>
-          <a:ln/>
-        </p:spPr>
-      </p:sp>
-      <p:sp>
-        <p:nvSpPr>
-          <p:cNvPr id="22" name="Shape 17"/>
-          <p:cNvSpPr/>
-          <p:nvPr/>
-        </p:nvSpPr>
-        <p:spPr>
-          <a:xfrm>
-            <a:off x="6094476" y="6793992"/>
-            <a:ext cx="2040636" cy="64008"/>
-          </a:xfrm>
-          <a:prstGeom prst="rect">
-            <a:avLst/>
-          </a:prstGeom>
-          <a:solidFill>
-            <a:srgbClr val="6CCAD4"/>
-          </a:solidFill>
-          <a:ln/>
-        </p:spPr>
-      </p:sp>
-      <p:sp>
-        <p:nvSpPr>
-          <p:cNvPr id="23" name="Shape 18"/>
-          <p:cNvSpPr/>
-          <p:nvPr/>
-        </p:nvSpPr>
-        <p:spPr>
-          <a:xfrm>
-            <a:off x="8125968" y="6793992"/>
-            <a:ext cx="2040636" cy="64008"/>
-          </a:xfrm>
-          <a:prstGeom prst="rect">
-            <a:avLst/>
-          </a:prstGeom>
-          <a:solidFill>
-            <a:srgbClr val="7FC04C"/>
-          </a:solidFill>
-          <a:ln/>
-        </p:spPr>
-      </p:sp>
-      <p:sp>
-        <p:nvSpPr>
-          <p:cNvPr id="24" name="Shape 19"/>
           <p:cNvSpPr/>
           <p:nvPr/>
         </p:nvSpPr>

</xml_diff>

<commit_message>
ABL: encrypted histories, 12-slot charts capped at the report month, hospital summaries
- operator and analyser histories AES-encrypted with a password set at first
  launch (same design as i-STAT: PBKDF2 600k, Fernet, keymeta salt+verifier,
  plaintext sweep, lock screen, /lock_status, /unlock, generate refuses when
  locked, unlock attempts audited)
- trend charts: 12 fixed slots, full printable width, every error segment
  labelled, never showing months after the report month
- ABL_<Hospital>_Hospital_Summary_<Month>.docx per hospital: departments,
  analysers, error rates and bands, flagged/low-volume operator counts, and
  analysers with recent history that did not appear this month
- READMEs and both decks updated

Co-Authored-By: Claude Fable 5.1 <noreply@anthropic.com>
</commit_message>
<xml_diff>
--- a/PQ_Report_Generator_Security_Briefing.pptx
+++ b/PQ_Report_Generator_Security_Briefing.pptx
@@ -4638,7 +4638,7 @@
                 <a:ea typeface="Calibri" pitchFamily="34" charset="-122"/>
                 <a:cs typeface="Calibri" pitchFamily="34" charset="-120"/>
               </a:rPr>
-              <a:t>History and BitLocker passwords are shared team secrets; the licence key is the PoC lead’s alone</a:t>
+              <a:t>History and BitLocker passwords are shared team secrets (one history password per engine); the licence key is the PoC lead’s alone</a:t>
             </a:r>
             <a:endParaRPr lang="en-US" sz="1250" dirty="0"/>
           </a:p>
@@ -6867,7 +6867,7 @@
                           <a:ea typeface="Calibri" pitchFamily="34" charset="-122"/>
                           <a:cs typeface="Calibri" pitchFamily="34" charset="-120"/>
                         </a:rPr>
-                        <a:t>ABL history files</a:t>
+                        <a:t>ABL operator &amp; analyser history</a:t>
                       </a:r>
                       <a:endParaRPr lang="en-US" sz="1300" dirty="0">
                         <a:latin typeface="Calibri" charset="0"/>
@@ -6932,7 +6932,7 @@
                           <a:ea typeface="Calibri" pitchFamily="34" charset="-122"/>
                           <a:cs typeface="Calibri" pitchFamily="34" charset="-120"/>
                         </a:rPr>
-                        <a:t>ABL_App\*.json</a:t>
+                        <a:t>ABL_App\abl_*history.json</a:t>
                       </a:r>
                       <a:endParaRPr lang="en-US" sz="1300" dirty="0">
                         <a:latin typeface="Calibri" charset="0"/>
@@ -6997,7 +6997,7 @@
                           <a:ea typeface="Calibri" pitchFamily="34" charset="-122"/>
                           <a:cs typeface="Calibri" pitchFamily="34" charset="-120"/>
                         </a:rPr>
-                        <a:t>ENCRYPTED (BitLocker To Go)</a:t>
+                        <a:t>ENCRYPTED twice (app AES + BitLocker)</a:t>
                       </a:r>
                       <a:endParaRPr lang="en-US" sz="1300" dirty="0">
                         <a:latin typeface="Calibri" charset="0"/>

</xml_diff>